<commit_message>
Review-III pack: fresh app screenshots, an app slide, and the platform roadmap in future work
Screenshots retaken from the current app (chat layout, agreement wording) in light theme at 2x:
answer with chart, abstention, schema map. Future work now lists the research items and the
platform plan (any database incl. Spark/Snowflake/NoSQL via a SQL gateway, per-database adaptation,
access control, serving at scale) in the report, deck and poster.

Co-Authored-By: Claude Opus 5.5 <noreply@anthropic.com>
</commit_message>
<xml_diff>
--- a/docs/Review-III/QueryGenie_Poster.pptx
+++ b/docs/Review-III/QueryGenie_Poster.pptx
@@ -4959,6 +4959,21 @@
             <a:r>
               <a:rPr sz="3000"/>
               <a:t>Spider-Realistic EX TBD; BIRD Mini-Dev EX TBD.</a:t>
+            </a:r>
+          </a:p>
+          <a:p>
+            <a:pPr>
+              <a:spcAft>
+                <a:spcPts val="1050"/>
+              </a:spcAft>
+            </a:pPr>
+            <a:r>
+              <a:rPr b="1" sz="3000"/>
+              <a:t>Next: </a:t>
+            </a:r>
+            <a:r>
+              <a:rPr sz="3000"/>
+              <a:t>a platform companies plug into any database (Spark, Snowflake, NoSQL via a SQL gateway), with access control and per-database adaptation.</a:t>
             </a:r>
           </a:p>
         </p:txBody>

</xml_diff>

<commit_message>
Poster rebuilt on the department's new template, in the style of the reference posters
Title with both logos, icon strip under STUDENTS / INNOVATION / RESEARCH / IMPACT, numbered
objectives, key innovations, app screenshot, architecture diagram, datasets table, four charts of
measured results (validated colour pair, zero-based axes), key results, conclusion, team. Template
updated to the new version; PDF export for printing. Icons: Lucide (ISC).

Co-Authored-By: Claude Opus 5.5 <noreply@anthropic.com>
</commit_message>
<xml_diff>
--- a/docs/Review-III/QueryGenie_Poster.pptx
+++ b/docs/Review-III/QueryGenie_Poster.pptx
@@ -107,6 +107,11 @@
       </a:defRPr>
     </a:lvl9pPr>
   </p:defaultTextStyle>
+  <p:extLst>
+    <p:ext uri="{EFAFB233-063F-42B5-8137-9DF3F51BA10A}">
+      <p15:sldGuideLst xmlns:p15="http://schemas.microsoft.com/office/powerpoint/2012/main"/>
+    </p:ext>
+  </p:extLst>
 </p:presentation>
 </file>
 
@@ -192,7 +197,7 @@
           <a:p>
             <a:fld id="{2F9781CB-E638-AC4E-B8EC-984A76828676}" type="datetimeFigureOut">
               <a:rPr lang="en-US" smtClean="0"/>
-              <a:t>10/1/26</a:t>
+              <a:t>10/8/26</a:t>
             </a:fld>
             <a:endParaRPr lang="en-US"/>
           </a:p>
@@ -1557,7 +1562,7 @@
           <a:p>
             <a:fld id="{7E70713F-4B5C-AD41-A9C1-0EDA460603EE}" type="datetimeFigureOut">
               <a:rPr lang="en-US" smtClean="0"/>
-              <a:t>10/1/26</a:t>
+              <a:t>10/8/26</a:t>
             </a:fld>
             <a:endParaRPr lang="en-US"/>
           </a:p>
@@ -1727,7 +1732,7 @@
           <a:p>
             <a:fld id="{7E70713F-4B5C-AD41-A9C1-0EDA460603EE}" type="datetimeFigureOut">
               <a:rPr lang="en-US" smtClean="0"/>
-              <a:t>10/1/26</a:t>
+              <a:t>10/8/26</a:t>
             </a:fld>
             <a:endParaRPr lang="en-US"/>
           </a:p>
@@ -1907,7 +1912,7 @@
           <a:p>
             <a:fld id="{7E70713F-4B5C-AD41-A9C1-0EDA460603EE}" type="datetimeFigureOut">
               <a:rPr lang="en-US" smtClean="0"/>
-              <a:t>10/1/26</a:t>
+              <a:t>10/8/26</a:t>
             </a:fld>
             <a:endParaRPr lang="en-US"/>
           </a:p>
@@ -2099,7 +2104,7 @@
           <a:p>
             <a:fld id="{7E70713F-4B5C-AD41-A9C1-0EDA460603EE}" type="datetimeFigureOut">
               <a:rPr lang="en-US" smtClean="0"/>
-              <a:t>10/1/26</a:t>
+              <a:t>10/8/26</a:t>
             </a:fld>
             <a:endParaRPr lang="en-US"/>
           </a:p>
@@ -2453,7 +2458,7 @@
           <a:p>
             <a:fld id="{7E70713F-4B5C-AD41-A9C1-0EDA460603EE}" type="datetimeFigureOut">
               <a:rPr lang="en-US" smtClean="0"/>
-              <a:t>10/1/26</a:t>
+              <a:t>10/8/26</a:t>
             </a:fld>
             <a:endParaRPr lang="en-US"/>
           </a:p>
@@ -2685,7 +2690,7 @@
           <a:p>
             <a:fld id="{7E70713F-4B5C-AD41-A9C1-0EDA460603EE}" type="datetimeFigureOut">
               <a:rPr lang="en-US" smtClean="0"/>
-              <a:t>10/1/26</a:t>
+              <a:t>10/8/26</a:t>
             </a:fld>
             <a:endParaRPr lang="en-US"/>
           </a:p>
@@ -3052,7 +3057,7 @@
           <a:p>
             <a:fld id="{7E70713F-4B5C-AD41-A9C1-0EDA460603EE}" type="datetimeFigureOut">
               <a:rPr lang="en-US" smtClean="0"/>
-              <a:t>10/1/26</a:t>
+              <a:t>10/8/26</a:t>
             </a:fld>
             <a:endParaRPr lang="en-US"/>
           </a:p>
@@ -3170,7 +3175,7 @@
           <a:p>
             <a:fld id="{7E70713F-4B5C-AD41-A9C1-0EDA460603EE}" type="datetimeFigureOut">
               <a:rPr lang="en-US" smtClean="0"/>
-              <a:t>10/1/26</a:t>
+              <a:t>10/8/26</a:t>
             </a:fld>
             <a:endParaRPr lang="en-US"/>
           </a:p>
@@ -3265,7 +3270,7 @@
           <a:p>
             <a:fld id="{7E70713F-4B5C-AD41-A9C1-0EDA460603EE}" type="datetimeFigureOut">
               <a:rPr lang="en-US" smtClean="0"/>
-              <a:t>10/1/26</a:t>
+              <a:t>10/8/26</a:t>
             </a:fld>
             <a:endParaRPr lang="en-US"/>
           </a:p>
@@ -3542,7 +3547,7 @@
           <a:p>
             <a:fld id="{7E70713F-4B5C-AD41-A9C1-0EDA460603EE}" type="datetimeFigureOut">
               <a:rPr lang="en-US" smtClean="0"/>
-              <a:t>10/1/26</a:t>
+              <a:t>10/8/26</a:t>
             </a:fld>
             <a:endParaRPr lang="en-US"/>
           </a:p>
@@ -3755,7 +3760,7 @@
           <a:p>
             <a:fld id="{7E70713F-4B5C-AD41-A9C1-0EDA460603EE}" type="datetimeFigureOut">
               <a:rPr lang="en-US" smtClean="0"/>
-              <a:t>10/1/26</a:t>
+              <a:t>10/8/26</a:t>
             </a:fld>
             <a:endParaRPr lang="en-US"/>
           </a:p>
@@ -4187,57 +4192,50 @@
         </p:nvSpPr>
         <p:spPr>
           <a:xfrm>
-            <a:off x="623691" y="7680960"/>
-            <a:ext cx="14299153" cy="10607040"/>
-          </a:xfrm>
-        </p:spPr>
-        <p:txBody>
-          <a:bodyPr wrap="square"/>
-          <a:lstStyle/>
-          <a:p>
-            <a:pPr>
+            <a:off x="640080" y="7726679"/>
+            <a:ext cx="14264640" cy="4846320"/>
+          </a:xfrm>
+        </p:spPr>
+        <p:txBody>
+          <a:bodyPr wrap="square" anchor="t" lIns="73152" rIns="73152" tIns="27432" bIns="27432"/>
+          <a:lstStyle/>
+          <a:p>
+            <a:pPr algn="l">
+              <a:spcBef>
+                <a:spcPts val="0"/>
+              </a:spcBef>
               <a:spcAft>
-                <a:spcPts val="1189"/>
+                <a:spcPts val="725"/>
               </a:spcAft>
             </a:pPr>
             <a:r>
-              <a:rPr sz="3400"/>
-              <a:t>Text-to-SQL models let people who don't know SQL ask a database questions in plain English — but they answer every question with the same confidence, so a wrong answer looks exactly like a right one.</a:t>
+              <a:rPr sz="2900" b="0" i="0">
+                <a:solidFill>
+                  <a:srgbClr val="1F2937"/>
+                </a:solidFill>
+                <a:latin typeface="Times New Roman"/>
+              </a:rPr>
+              <a:t>Text-to-SQL models let people who do not know SQL ask a database questions in plain English, but they answer every question with the same confidence, so a wrong answer looks exactly like a right one. </a:t>
+            </a:r>
+            <a:r>
+              <a:rPr sz="2900" b="1" i="0">
+                <a:solidFill>
+                  <a:srgbClr val="1F2937"/>
+                </a:solidFill>
+                <a:latin typeface="Times New Roman"/>
+              </a:rPr>
+              <a:t>QueryGenie</a:t>
+            </a:r>
+            <a:r>
+              <a:rPr sz="2900" b="0" i="0">
+                <a:solidFill>
+                  <a:srgbClr val="1F2937"/>
+                </a:solidFill>
+                <a:latin typeface="Times New Roman"/>
+              </a:rPr>
+              <a:t> reproduces CodeS (SIGMOD 2024, arXiv:2402.16347), an open-source text-to-SQL model, and makes it say when it is unsure. We reproduce CodeS-1B to 77.8% execution accuracy on Spider (paper: 77.9%) and 69.5% on Spider-Realistic (paper: 70.9%). Our enhancement, confidence-aware abstention, runs the candidate queries the model already generates and checks whether they agree: when they don't, it asks the user instead of guessing. It answers 90.4% of questions and is right on 83.3% of them, with a third fewer wrong answers — a statistically significant gain. Everything runs locally in a desktop app, on open weights.</a:t>
             </a:r>
             <a:endParaRPr lang="en-US"/>
-          </a:p>
-          <a:p>
-            <a:pPr>
-              <a:spcAft>
-                <a:spcPts val="1189"/>
-              </a:spcAft>
-            </a:pPr>
-            <a:r>
-              <a:rPr sz="3400"/>
-              <a:t>We reproduced CodeS (SIGMOD 2024), an open-source text-to-SQL model: 77.8% Execution Accuracy on the Spider development set against 77.9% in the paper.</a:t>
-            </a:r>
-          </a:p>
-          <a:p>
-            <a:pPr>
-              <a:spcAft>
-                <a:spcPts val="1189"/>
-              </a:spcAft>
-            </a:pPr>
-            <a:r>
-              <a:rPr sz="3400"/>
-              <a:t>Our enhancement, confidence-aware abstention, runs the four candidate queries CodeS already generates and counts how many agree. When they disagree, QueryGenie asks the user instead of guessing: it is then correct on 83.3% of the questions it answers (90.4% of all), wrong answers fall by 32%, and the gain is statistically significant.</a:t>
-            </a:r>
-          </a:p>
-          <a:p>
-            <a:pPr>
-              <a:spcAft>
-                <a:spcPts val="1189"/>
-              </a:spcAft>
-            </a:pPr>
-            <a:r>
-              <a:rPr sz="3400"/>
-              <a:t>Everything runs locally on open weights in a desktop app.</a:t>
-            </a:r>
           </a:p>
         </p:txBody>
       </p:sp>
@@ -4258,6 +4256,10 @@
           </p:nvPr>
         </p:nvSpPr>
         <p:spPr>
+          <a:xfrm>
+            <a:off x="640080" y="6858000"/>
+            <a:ext cx="14264640" cy="731520"/>
+          </a:xfrm>
           <a:solidFill>
             <a:srgbClr val="C00000"/>
           </a:solidFill>
@@ -4294,6 +4296,10 @@
           </p:nvPr>
         </p:nvSpPr>
         <p:spPr>
+          <a:xfrm>
+            <a:off x="640080" y="12755880"/>
+            <a:ext cx="14264640" cy="731520"/>
+          </a:xfrm>
           <a:solidFill>
             <a:srgbClr val="C00000"/>
           </a:solidFill>
@@ -4330,6 +4336,10 @@
           </p:nvPr>
         </p:nvSpPr>
         <p:spPr>
+          <a:xfrm>
+            <a:off x="15361920" y="6858000"/>
+            <a:ext cx="14264640" cy="731520"/>
+          </a:xfrm>
           <a:solidFill>
             <a:srgbClr val="C00000"/>
           </a:solidFill>
@@ -4339,12 +4349,12 @@
           <a:lstStyle/>
           <a:p>
             <a:r>
-              <a:rPr lang="en-US" dirty="0">
-                <a:solidFill>
-                  <a:schemeClr val="bg1"/>
+              <a:rPr sz="3900" b="1" u="sng">
+                <a:solidFill>
+                  <a:srgbClr val="FFFFFF"/>
                 </a:solidFill>
               </a:rPr>
-              <a:t>Proposed Methodology</a:t>
+              <a:t>Proposed Methodology / System Architecture</a:t>
             </a:r>
           </a:p>
         </p:txBody>
@@ -4367,73 +4377,15 @@
         </p:nvSpPr>
         <p:spPr>
           <a:xfrm>
-            <a:off x="15353328" y="15713963"/>
-            <a:ext cx="14287682" cy="8778240"/>
-          </a:xfrm>
-        </p:spPr>
-        <p:txBody>
-          <a:bodyPr wrap="square"/>
-          <a:lstStyle/>
-          <a:p>
-            <a:pPr>
-              <a:spcAft>
-                <a:spcPts val="1050"/>
-              </a:spcAft>
-            </a:pPr>
-            <a:r>
-              <a:rPr b="1" sz="3000"/>
-              <a:t>Data </a:t>
-            </a:r>
-            <a:r>
-              <a:rPr sz="3000"/>
-              <a:t>(Hugging Face, approved source): Spider dev — 1,034 questions, 20 unseen databases; Spider-Realistic — 508 questions without column names; BIRD Mini-Dev — 500 questions on 11 real-world databases.</a:t>
-            </a:r>
+            <a:off x="15361920" y="7726679"/>
+            <a:ext cx="91440" cy="91440"/>
+          </a:xfrm>
+        </p:spPr>
+        <p:txBody>
+          <a:bodyPr/>
+          <a:lstStyle/>
+          <a:p>
             <a:endParaRPr lang="en-US"/>
-          </a:p>
-          <a:p>
-            <a:pPr>
-              <a:spcAft>
-                <a:spcPts val="1050"/>
-              </a:spcAft>
-            </a:pPr>
-            <a:r>
-              <a:rPr b="1" sz="3000"/>
-              <a:t>CodeS pipeline (reproduced): </a:t>
-            </a:r>
-            <a:r>
-              <a:rPr sz="3000"/>
-              <a:t>database prompt (schema, keys, sample values, matched values) → 4 candidate queries by beam search → first query that runs.</a:t>
-            </a:r>
-          </a:p>
-          <a:p>
-            <a:pPr>
-              <a:spcAft>
-                <a:spcPts val="1050"/>
-              </a:spcAft>
-            </a:pPr>
-            <a:r>
-              <a:rPr b="1" sz="3000"/>
-              <a:t>Enhancement: </a:t>
-            </a:r>
-            <a:r>
-              <a:rPr sz="3000"/>
-              <a:t>execute all 4 candidates and count how many return the same result. Agreement below the threshold (τ = 0.2526, calibrated on held-out halves) → abstain and show the readings to choose from.</a:t>
-            </a:r>
-          </a:p>
-          <a:p>
-            <a:pPr>
-              <a:spcAft>
-                <a:spcPts val="1050"/>
-              </a:spcAft>
-            </a:pPr>
-            <a:r>
-              <a:rPr b="1" sz="3000"/>
-              <a:t>Evaluation: </a:t>
-            </a:r>
-            <a:r>
-              <a:rPr sz="3000"/>
-              <a:t>official Spider evaluator; 10 calibration/test splits, paired t-test and Wilcoxon, bootstrap over questions.</a:t>
-            </a:r>
           </a:p>
         </p:txBody>
       </p:sp>
@@ -4454,6 +4406,10 @@
           </p:nvPr>
         </p:nvSpPr>
         <p:spPr>
+          <a:xfrm>
+            <a:off x="640080" y="34518600"/>
+            <a:ext cx="14264640" cy="731520"/>
+          </a:xfrm>
           <a:solidFill>
             <a:srgbClr val="C00000"/>
           </a:solidFill>
@@ -4491,122 +4447,236 @@
         </p:nvSpPr>
         <p:spPr>
           <a:xfrm>
-            <a:off x="623691" y="32644080"/>
-            <a:ext cx="14289232" cy="8961120"/>
-          </a:xfrm>
-        </p:spPr>
-        <p:txBody>
-          <a:bodyPr wrap="square"/>
-          <a:lstStyle/>
-          <a:p>
-            <a:pPr>
+            <a:off x="640080" y="35387280"/>
+            <a:ext cx="14264640" cy="6400800"/>
+          </a:xfrm>
+        </p:spPr>
+        <p:txBody>
+          <a:bodyPr wrap="square" anchor="t" lIns="73152" rIns="73152" tIns="27432" bIns="27432"/>
+          <a:lstStyle/>
+          <a:p>
+            <a:pPr algn="l">
+              <a:spcBef>
+                <a:spcPts val="0"/>
+              </a:spcBef>
               <a:spcAft>
-                <a:spcPts val="769"/>
+                <a:spcPts val="660"/>
               </a:spcAft>
             </a:pPr>
             <a:r>
-              <a:rPr sz="2200"/>
+              <a:rPr sz="2200" b="1" i="0">
+                <a:solidFill>
+                  <a:srgbClr val="1F2937"/>
+                </a:solidFill>
+                <a:latin typeface="Times New Roman"/>
+              </a:rPr>
+              <a:t>[1] </a:t>
+            </a:r>
+            <a:r>
+              <a:rPr sz="2200" b="0" i="0">
+                <a:solidFill>
+                  <a:srgbClr val="1F2937"/>
+                </a:solidFill>
+                <a:latin typeface="Times New Roman"/>
+              </a:rPr>
               <a:t>Li, H., et al. (2024). CodeS: Towards building open-source language models for text-to-SQL. arXiv:2402.16347.</a:t>
             </a:r>
             <a:endParaRPr lang="en-US"/>
           </a:p>
           <a:p>
-            <a:pPr>
+            <a:pPr algn="l">
+              <a:spcBef>
+                <a:spcPts val="0"/>
+              </a:spcBef>
               <a:spcAft>
-                <a:spcPts val="769"/>
+                <a:spcPts val="660"/>
               </a:spcAft>
             </a:pPr>
             <a:r>
-              <a:rPr sz="2200"/>
+              <a:rPr sz="2200" b="1" i="0">
+                <a:solidFill>
+                  <a:srgbClr val="1F2937"/>
+                </a:solidFill>
+                <a:latin typeface="Times New Roman"/>
+              </a:rPr>
+              <a:t>[2] </a:t>
+            </a:r>
+            <a:r>
+              <a:rPr sz="2200" b="0" i="0">
+                <a:solidFill>
+                  <a:srgbClr val="1F2937"/>
+                </a:solidFill>
+                <a:latin typeface="Times New Roman"/>
+              </a:rPr>
               <a:t>Yu, T., et al. (2018). Spider: A large-scale human-labeled dataset for complex and cross-domain semantic parsing and text-to-SQL task. arXiv:1809.08887.</a:t>
             </a:r>
           </a:p>
           <a:p>
-            <a:pPr>
+            <a:pPr algn="l">
+              <a:spcBef>
+                <a:spcPts val="0"/>
+              </a:spcBef>
               <a:spcAft>
-                <a:spcPts val="769"/>
+                <a:spcPts val="660"/>
               </a:spcAft>
             </a:pPr>
             <a:r>
-              <a:rPr sz="2200"/>
-              <a:t>Li, J., et al. (2023). Can LLM already serve as a database interface? A big bench for large-scale database grounded text-to-SQLs. arXiv:2305.03111.</a:t>
-            </a:r>
-          </a:p>
-          <a:p>
-            <a:pPr>
+              <a:rPr sz="2200" b="1" i="0">
+                <a:solidFill>
+                  <a:srgbClr val="1F2937"/>
+                </a:solidFill>
+                <a:latin typeface="Times New Roman"/>
+              </a:rPr>
+              <a:t>[3] </a:t>
+            </a:r>
+            <a:r>
+              <a:rPr sz="2200" b="0" i="0">
+                <a:solidFill>
+                  <a:srgbClr val="1F2937"/>
+                </a:solidFill>
+                <a:latin typeface="Times New Roman"/>
+              </a:rPr>
+              <a:t>Deng, X., Awadallah, A. H., Meek, C., Polozov, O., Sun, H., &amp; Richardson, M. (2020). Structure-grounded pretraining for text-to-SQL. arXiv:2010.12773.</a:t>
+            </a:r>
+          </a:p>
+          <a:p>
+            <a:pPr algn="l">
+              <a:spcBef>
+                <a:spcPts val="0"/>
+              </a:spcBef>
               <a:spcAft>
-                <a:spcPts val="769"/>
+                <a:spcPts val="660"/>
               </a:spcAft>
             </a:pPr>
             <a:r>
-              <a:rPr sz="2200"/>
-              <a:t>Deng, X., Awadallah, A. H., Meek, C., Polozov, O., Sun, H., &amp; Richardson, M. (2020). Structure-grounded pretraining for text-to-SQL. arXiv:2010.12773.</a:t>
-            </a:r>
-          </a:p>
-          <a:p>
-            <a:pPr>
+              <a:rPr sz="2200" b="1" i="0">
+                <a:solidFill>
+                  <a:srgbClr val="1F2937"/>
+                </a:solidFill>
+                <a:latin typeface="Times New Roman"/>
+              </a:rPr>
+              <a:t>[4] </a:t>
+            </a:r>
+            <a:r>
+              <a:rPr sz="2200" b="0" i="0">
+                <a:solidFill>
+                  <a:srgbClr val="1F2937"/>
+                </a:solidFill>
+                <a:latin typeface="Times New Roman"/>
+              </a:rPr>
+              <a:t>Li, J., et al. (2023). Can LLM already serve as a database interface? A big bench for large-scale database grounded text-to-SQLs. arXiv:2305.03111.</a:t>
+            </a:r>
+          </a:p>
+          <a:p>
+            <a:pPr algn="l">
+              <a:spcBef>
+                <a:spcPts val="0"/>
+              </a:spcBef>
               <a:spcAft>
-                <a:spcPts val="769"/>
+                <a:spcPts val="660"/>
               </a:spcAft>
             </a:pPr>
             <a:r>
-              <a:rPr sz="2200"/>
+              <a:rPr sz="2200" b="1" i="0">
+                <a:solidFill>
+                  <a:srgbClr val="1F2937"/>
+                </a:solidFill>
+                <a:latin typeface="Times New Roman"/>
+              </a:rPr>
+              <a:t>[5] </a:t>
+            </a:r>
+            <a:r>
+              <a:rPr sz="2200" b="0" i="0">
+                <a:solidFill>
+                  <a:srgbClr val="1F2937"/>
+                </a:solidFill>
+                <a:latin typeface="Times New Roman"/>
+              </a:rPr>
               <a:t>Pourreza, M., &amp; Rafiei, D. (2023). DIN-SQL: Decomposed in-context learning of text-to-SQL with self-correction. arXiv:2304.11015.</a:t>
             </a:r>
           </a:p>
           <a:p>
-            <a:pPr>
+            <a:pPr algn="l">
+              <a:spcBef>
+                <a:spcPts val="0"/>
+              </a:spcBef>
               <a:spcAft>
-                <a:spcPts val="769"/>
+                <a:spcPts val="660"/>
               </a:spcAft>
             </a:pPr>
             <a:r>
-              <a:rPr sz="2200"/>
+              <a:rPr sz="2200" b="1" i="0">
+                <a:solidFill>
+                  <a:srgbClr val="1F2937"/>
+                </a:solidFill>
+                <a:latin typeface="Times New Roman"/>
+              </a:rPr>
+              <a:t>[6] </a:t>
+            </a:r>
+            <a:r>
+              <a:rPr sz="2200" b="0" i="0">
+                <a:solidFill>
+                  <a:srgbClr val="1F2937"/>
+                </a:solidFill>
+                <a:latin typeface="Times New Roman"/>
+              </a:rPr>
               <a:t>Wang, X., et al. (2022). Self-consistency improves chain of thought reasoning in language models. arXiv:2203.11171.</a:t>
             </a:r>
           </a:p>
           <a:p>
-            <a:pPr>
+            <a:pPr algn="l">
+              <a:spcBef>
+                <a:spcPts val="0"/>
+              </a:spcBef>
               <a:spcAft>
-                <a:spcPts val="769"/>
+                <a:spcPts val="660"/>
               </a:spcAft>
             </a:pPr>
             <a:r>
-              <a:rPr sz="2200"/>
+              <a:rPr sz="2200" b="1" i="0">
+                <a:solidFill>
+                  <a:srgbClr val="1F2937"/>
+                </a:solidFill>
+                <a:latin typeface="Times New Roman"/>
+              </a:rPr>
+              <a:t>[7] </a:t>
+            </a:r>
+            <a:r>
+              <a:rPr sz="2200" b="0" i="0">
+                <a:solidFill>
+                  <a:srgbClr val="1F2937"/>
+                </a:solidFill>
+                <a:latin typeface="Times New Roman"/>
+              </a:rPr>
               <a:t>Geifman, Y., &amp; El-Yaniv, R. (2017). Selective classification for deep neural networks. arXiv:1705.08500.</a:t>
             </a:r>
           </a:p>
           <a:p>
-            <a:pPr>
+            <a:pPr algn="l">
+              <a:spcBef>
+                <a:spcPts val="0"/>
+              </a:spcBef>
               <a:spcAft>
-                <a:spcPts val="769"/>
+                <a:spcPts val="660"/>
               </a:spcAft>
             </a:pPr>
             <a:r>
-              <a:rPr sz="2200"/>
+              <a:rPr sz="2200" b="1" i="0">
+                <a:solidFill>
+                  <a:srgbClr val="1F2937"/>
+                </a:solidFill>
+                <a:latin typeface="Times New Roman"/>
+              </a:rPr>
+              <a:t>[8] </a:t>
+            </a:r>
+            <a:r>
+              <a:rPr sz="2200" b="0" i="0">
+                <a:solidFill>
+                  <a:srgbClr val="1F2937"/>
+                </a:solidFill>
+                <a:latin typeface="Times New Roman"/>
+              </a:rPr>
               <a:t>Zhong, R., Yu, T., &amp; Klein, D. (2020). Semantic evaluation for text-to-SQL with distilled test suites. arXiv:2010.02840.</a:t>
-            </a:r>
-          </a:p>
-          <a:p>
-            <a:pPr>
-              <a:spcAft>
-                <a:spcPts val="769"/>
-              </a:spcAft>
-            </a:pPr>
-            <a:r>
-              <a:rPr sz="2200"/>
-              <a:t>Li, H., et al. (2023). RESDSQL: Decoupling schema linking and skeleton parsing for text-to-SQL. arXiv:2302.05965.</a:t>
-            </a:r>
-          </a:p>
-          <a:p>
-            <a:pPr>
-              <a:spcAft>
-                <a:spcPts val="769"/>
-              </a:spcAft>
-            </a:pPr>
-            <a:r>
-              <a:rPr sz="2200"/>
-              <a:t>Lin, X. V., Socher, R., &amp; Xiong, C. (2020). Bridging textual and tabular data for cross-domain text-to-SQL semantic parsing. arXiv:2012.12627.</a:t>
             </a:r>
           </a:p>
         </p:txBody>
@@ -4628,6 +4698,10 @@
           </p:nvPr>
         </p:nvSpPr>
         <p:spPr>
+          <a:xfrm>
+            <a:off x="15361920" y="37536120"/>
+            <a:ext cx="14264640" cy="731520"/>
+          </a:xfrm>
           <a:solidFill>
             <a:srgbClr val="C00000"/>
           </a:solidFill>
@@ -4665,54 +4739,114 @@
         </p:nvSpPr>
         <p:spPr>
           <a:xfrm>
-            <a:off x="15353329" y="37358864"/>
-            <a:ext cx="14283756" cy="3272899"/>
-          </a:xfrm>
-        </p:spPr>
-        <p:txBody>
-          <a:bodyPr wrap="square"/>
-          <a:lstStyle/>
-          <a:p>
-            <a:pPr>
+            <a:off x="15361920" y="38359080"/>
+            <a:ext cx="14264640" cy="3383280"/>
+          </a:xfrm>
+        </p:spPr>
+        <p:txBody>
+          <a:bodyPr wrap="square" anchor="t" lIns="73152" rIns="73152" tIns="27432" bIns="27432"/>
+          <a:lstStyle/>
+          <a:p>
+            <a:pPr algn="l">
+              <a:spcBef>
+                <a:spcPts val="0"/>
+              </a:spcBef>
               <a:spcAft>
-                <a:spcPts val="979"/>
+                <a:spcPts val="675"/>
               </a:spcAft>
             </a:pPr>
             <a:r>
-              <a:rPr sz="2800"/>
-              <a:t>Team 18 · Supervisor: M Parameswar, Associate Professor</a:t>
-            </a:r>
-          </a:p>
-          <a:p>
-            <a:pPr>
+              <a:rPr sz="2700" b="1" i="0">
+                <a:solidFill>
+                  <a:srgbClr val="1F2937"/>
+                </a:solidFill>
+                <a:latin typeface="Times New Roman"/>
+              </a:rPr>
+              <a:t>Supervisor: </a:t>
+            </a:r>
+            <a:r>
+              <a:rPr sz="2700" b="0" i="0">
+                <a:solidFill>
+                  <a:srgbClr val="1F2937"/>
+                </a:solidFill>
+                <a:latin typeface="Times New Roman"/>
+              </a:rPr>
+              <a:t>M Parameswar, Associate Professor</a:t>
+            </a:r>
+          </a:p>
+          <a:p>
+            <a:pPr algn="l">
+              <a:spcBef>
+                <a:spcPts val="0"/>
+              </a:spcBef>
               <a:spcAft>
-                <a:spcPts val="979"/>
+                <a:spcPts val="675"/>
               </a:spcAft>
             </a:pPr>
             <a:r>
-              <a:rPr sz="2800"/>
-              <a:t>2320090050 – N V V S S Jayakanth Kamisetti</a:t>
-            </a:r>
-          </a:p>
-          <a:p>
-            <a:pPr>
+              <a:rPr sz="2700" b="1" i="0">
+                <a:solidFill>
+                  <a:srgbClr val="002060"/>
+                </a:solidFill>
+                <a:latin typeface="Times New Roman"/>
+              </a:rPr>
+              <a:t>Team 18</a:t>
+            </a:r>
+          </a:p>
+          <a:p>
+            <a:pPr algn="l">
+              <a:spcBef>
+                <a:spcPts val="0"/>
+              </a:spcBef>
               <a:spcAft>
-                <a:spcPts val="979"/>
+                <a:spcPts val="675"/>
               </a:spcAft>
             </a:pPr>
             <a:r>
-              <a:rPr sz="2800"/>
-              <a:t>2320090009 – Boddupally Narendar</a:t>
-            </a:r>
-          </a:p>
-          <a:p>
-            <a:pPr>
+              <a:rPr sz="2700" b="0" i="0">
+                <a:solidFill>
+                  <a:srgbClr val="1F2937"/>
+                </a:solidFill>
+                <a:latin typeface="Times New Roman"/>
+              </a:rPr>
+              <a:t>2320090050 – N V V S S Jayakanth Kamisetti</a:t>
+            </a:r>
+          </a:p>
+          <a:p>
+            <a:pPr algn="l">
+              <a:spcBef>
+                <a:spcPts val="0"/>
+              </a:spcBef>
               <a:spcAft>
-                <a:spcPts val="979"/>
+                <a:spcPts val="675"/>
               </a:spcAft>
             </a:pPr>
             <a:r>
-              <a:rPr sz="2800"/>
+              <a:rPr sz="2700" b="0" i="0">
+                <a:solidFill>
+                  <a:srgbClr val="1F2937"/>
+                </a:solidFill>
+                <a:latin typeface="Times New Roman"/>
+              </a:rPr>
+              <a:t>2320090009 – Boddupally Narendar</a:t>
+            </a:r>
+          </a:p>
+          <a:p>
+            <a:pPr algn="l">
+              <a:spcBef>
+                <a:spcPts val="0"/>
+              </a:spcBef>
+              <a:spcAft>
+                <a:spcPts val="675"/>
+              </a:spcAft>
+            </a:pPr>
+            <a:r>
+              <a:rPr sz="2700" b="0" i="0">
+                <a:solidFill>
+                  <a:srgbClr val="1F2937"/>
+                </a:solidFill>
+                <a:latin typeface="Times New Roman"/>
+              </a:rPr>
               <a:t>2320090018 – M Praneeth Reddy</a:t>
             </a:r>
           </a:p>
@@ -4736,88 +4870,15 @@
         </p:nvSpPr>
         <p:spPr>
           <a:xfrm>
-            <a:off x="623691" y="19385280"/>
-            <a:ext cx="14300387" cy="4754880"/>
-          </a:xfrm>
-        </p:spPr>
-        <p:txBody>
-          <a:bodyPr wrap="square"/>
-          <a:lstStyle/>
-          <a:p>
-            <a:pPr>
-              <a:spcAft>
-                <a:spcPts val="1050"/>
-              </a:spcAft>
-            </a:pPr>
-            <a:r>
-              <a:rPr b="1" sz="3000"/>
-              <a:t>1. Reproduce </a:t>
-            </a:r>
-            <a:r>
-              <a:rPr sz="3000"/>
-              <a:t>CodeS-1B on Spider within ±5–10% of the published result.</a:t>
-            </a:r>
+            <a:off x="640080" y="13716000"/>
+            <a:ext cx="91440" cy="91440"/>
+          </a:xfrm>
+        </p:spPr>
+        <p:txBody>
+          <a:bodyPr/>
+          <a:lstStyle/>
+          <a:p>
             <a:endParaRPr lang="en-US"/>
-          </a:p>
-          <a:p>
-            <a:pPr>
-              <a:spcAft>
-                <a:spcPts val="1050"/>
-              </a:spcAft>
-            </a:pPr>
-            <a:r>
-              <a:rPr b="1" sz="3000"/>
-              <a:t>2. Ablate </a:t>
-            </a:r>
-            <a:r>
-              <a:rPr sz="3000"/>
-              <a:t>the CodeS pipeline to find which parts matter.</a:t>
-            </a:r>
-          </a:p>
-          <a:p>
-            <a:pPr>
-              <a:spcAft>
-                <a:spcPts val="1050"/>
-              </a:spcAft>
-            </a:pPr>
-            <a:r>
-              <a:rPr b="1" sz="3000"/>
-              <a:t>3. Enhance </a:t>
-            </a:r>
-            <a:r>
-              <a:rPr sz="3000"/>
-              <a:t>it with confidence-aware abstention and test it statistically.</a:t>
-            </a:r>
-          </a:p>
-          <a:p>
-            <a:pPr>
-              <a:spcAft>
-                <a:spcPts val="1050"/>
-              </a:spcAft>
-            </a:pPr>
-            <a:r>
-              <a:rPr b="1" sz="3000"/>
-              <a:t>4. Measure </a:t>
-            </a:r>
-            <a:r>
-              <a:rPr sz="3000"/>
-              <a:t>the benchmark-to-reality gap on realistic questions and real databases.</a:t>
-            </a:r>
-          </a:p>
-          <a:p>
-            <a:pPr>
-              <a:spcAft>
-                <a:spcPts val="1050"/>
-              </a:spcAft>
-            </a:pPr>
-            <a:r>
-              <a:rPr b="1" sz="3000"/>
-              <a:t>5. Deliver </a:t>
-            </a:r>
-            <a:r>
-              <a:rPr sz="3000"/>
-              <a:t>a working desktop application, not a notebook.</a:t>
-            </a:r>
           </a:p>
         </p:txBody>
       </p:sp>
@@ -4839,17 +4900,68 @@
         </p:nvSpPr>
         <p:spPr>
           <a:xfrm>
-            <a:off x="6248401" y="1190980"/>
-            <a:ext cx="20319999" cy="2712068"/>
-          </a:xfrm>
-        </p:spPr>
-        <p:txBody>
-          <a:bodyPr/>
-          <a:lstStyle/>
-          <a:p>
-            <a:r>
-              <a:rPr sz="6600" b="1"/>
-              <a:t>QueryGenie: A Self-Correcting Natural Language to SQL Interface</a:t>
+            <a:off x="6035040" y="1005840"/>
+            <a:ext cx="19568160" cy="3108960"/>
+          </a:xfrm>
+        </p:spPr>
+        <p:txBody>
+          <a:bodyPr wrap="square" anchor="t" lIns="73152" rIns="73152" tIns="27432" bIns="27432"/>
+          <a:lstStyle/>
+          <a:p>
+            <a:pPr algn="ctr">
+              <a:spcBef>
+                <a:spcPts val="0"/>
+              </a:spcBef>
+              <a:spcAft>
+                <a:spcPts val="130"/>
+              </a:spcAft>
+            </a:pPr>
+            <a:r>
+              <a:rPr sz="10000" b="1" i="0">
+                <a:solidFill>
+                  <a:srgbClr val="002060"/>
+                </a:solidFill>
+                <a:latin typeface="Times New Roman"/>
+              </a:rPr>
+              <a:t>QueryGenie</a:t>
+            </a:r>
+          </a:p>
+          <a:p>
+            <a:pPr algn="ctr">
+              <a:spcBef>
+                <a:spcPts val="0"/>
+              </a:spcBef>
+              <a:spcAft>
+                <a:spcPts val="130"/>
+              </a:spcAft>
+            </a:pPr>
+            <a:r>
+              <a:rPr sz="4000" b="0" i="0">
+                <a:solidFill>
+                  <a:srgbClr val="002060"/>
+                </a:solidFill>
+                <a:latin typeface="Times New Roman"/>
+              </a:rPr>
+              <a:t>A Self-Correcting, Confidence-Aware Natural Language to SQL Interface</a:t>
+            </a:r>
+          </a:p>
+          <a:p>
+            <a:pPr algn="ctr">
+              <a:spcBef>
+                <a:spcPts val="0"/>
+              </a:spcBef>
+              <a:spcAft>
+                <a:spcPts val="130"/>
+              </a:spcAft>
+            </a:pPr>
+            <a:r>
+              <a:rPr sz="2800" b="0" i="1">
+                <a:solidFill>
+                  <a:srgbClr val="4B5563"/>
+                </a:solidFill>
+                <a:latin typeface="Times New Roman"/>
+              </a:rPr>
+              <a:t>Ask a database in plain English — and get told when the answer can't be trusted</a:t>
             </a:r>
           </a:p>
         </p:txBody>
@@ -4871,6 +4983,10 @@
           </p:nvPr>
         </p:nvSpPr>
         <p:spPr>
+          <a:xfrm>
+            <a:off x="15361920" y="19476720"/>
+            <a:ext cx="14264640" cy="731520"/>
+          </a:xfrm>
           <a:solidFill>
             <a:srgbClr val="C00000"/>
           </a:solidFill>
@@ -4908,73 +5024,15 @@
         </p:nvSpPr>
         <p:spPr>
           <a:xfrm>
-            <a:off x="15353328" y="29809440"/>
-            <a:ext cx="14300387" cy="6583680"/>
-          </a:xfrm>
-        </p:spPr>
-        <p:txBody>
-          <a:bodyPr wrap="square"/>
-          <a:lstStyle/>
-          <a:p>
-            <a:pPr>
-              <a:spcAft>
-                <a:spcPts val="1050"/>
-              </a:spcAft>
-            </a:pPr>
-            <a:r>
-              <a:rPr b="1" sz="3000"/>
-              <a:t>Reproduction: </a:t>
-            </a:r>
-            <a:r>
-              <a:rPr sz="3000"/>
-              <a:t>77.8% vs 77.9% (−0.1 pts) on a free Colab T4.</a:t>
-            </a:r>
+            <a:off x="15361920" y="19476720"/>
+            <a:ext cx="91440" cy="91440"/>
+          </a:xfrm>
+        </p:spPr>
+        <p:txBody>
+          <a:bodyPr/>
+          <a:lstStyle/>
+          <a:p>
             <a:endParaRPr lang="en-US" dirty="0"/>
-          </a:p>
-          <a:p>
-            <a:pPr>
-              <a:spcAft>
-                <a:spcPts val="1050"/>
-              </a:spcAft>
-            </a:pPr>
-            <a:r>
-              <a:rPr b="1" sz="3000"/>
-              <a:t>Enhancement: </a:t>
-            </a:r>
-            <a:r>
-              <a:rPr sz="3000"/>
-              <a:t>+5.5 pts accuracy on answered questions; t-test p = 7.7×10⁻¹⁰, Wilcoxon p = 9.8×10⁻⁴, 95% CI +4.5 to +6.7.</a:t>
-            </a:r>
-          </a:p>
-          <a:p>
-            <a:pPr>
-              <a:spcAft>
-                <a:spcPts val="1050"/>
-              </a:spcAft>
-            </a:pPr>
-            <a:r>
-              <a:rPr b="1" sz="3000"/>
-              <a:t>Beyond Spider: </a:t>
-            </a:r>
-            <a:r>
-              <a:rPr sz="3000"/>
-              <a:t>Spider-Realistic EX 69.5% (paper 70.9%; the wording costs 3.3 pts, p = 0.016); BIRD Mini-Dev EX TBD.</a:t>
-            </a:r>
-          </a:p>
-          <a:p>
-            <a:pPr>
-              <a:spcAft>
-                <a:spcPts val="1050"/>
-              </a:spcAft>
-            </a:pPr>
-            <a:r>
-              <a:rPr b="1" sz="3000"/>
-              <a:t>Next: </a:t>
-            </a:r>
-            <a:r>
-              <a:rPr sz="3000"/>
-              <a:t>a platform companies plug into any database (Spark, Snowflake, NoSQL via a SQL gateway), with access control and per-database adaptation.</a:t>
-            </a:r>
           </a:p>
         </p:txBody>
       </p:sp>
@@ -5057,7 +5115,7 @@
           <a:p>
             <a:pPr algn="ctr"/>
             <a:r>
-              <a:rPr lang="en-US" sz="3200" dirty="0">
+              <a:rPr lang="en-US" sz="3200" b="1" dirty="0">
                 <a:solidFill>
                   <a:schemeClr val="tx1"/>
                 </a:solidFill>
@@ -5296,9 +5354,169 @@
           </p:txBody>
         </p:sp>
       </p:grpSp>
+      <p:sp>
+        <p:nvSpPr>
+          <p:cNvPr id="13" name="TextBox 12">
+            <a:extLst>
+              <a:ext uri="{FF2B5EF4-FFF2-40B4-BE49-F238E27FC236}">
+                <a16:creationId xmlns:a16="http://schemas.microsoft.com/office/drawing/2014/main" id="{9EC58C13-E2F0-38F2-BE1B-7BB99133B9E5}"/>
+              </a:ext>
+            </a:extLst>
+          </p:cNvPr>
+          <p:cNvSpPr txBox="1"/>
+          <p:nvPr/>
+        </p:nvSpPr>
+        <p:spPr>
+          <a:xfrm>
+            <a:off x="2202874" y="4405744"/>
+            <a:ext cx="2784764" cy="584775"/>
+          </a:xfrm>
+          <a:prstGeom prst="rect">
+            <a:avLst/>
+          </a:prstGeom>
+          <a:noFill/>
+        </p:spPr>
+        <p:txBody>
+          <a:bodyPr wrap="square" rtlCol="0">
+            <a:spAutoFit/>
+          </a:bodyPr>
+          <a:lstStyle/>
+          <a:p>
+            <a:pPr algn="ctr"/>
+            <a:r>
+              <a:rPr lang="en-US" sz="3200" b="1" dirty="0">
+                <a:solidFill>
+                  <a:srgbClr val="002060"/>
+                </a:solidFill>
+              </a:rPr>
+              <a:t>STUDENTS</a:t>
+            </a:r>
+          </a:p>
+        </p:txBody>
+      </p:sp>
+      <p:sp>
+        <p:nvSpPr>
+          <p:cNvPr id="17" name="TextBox 16">
+            <a:extLst>
+              <a:ext uri="{FF2B5EF4-FFF2-40B4-BE49-F238E27FC236}">
+                <a16:creationId xmlns:a16="http://schemas.microsoft.com/office/drawing/2014/main" id="{114D8927-421D-132B-30DD-C0DECF1225BE}"/>
+              </a:ext>
+            </a:extLst>
+          </p:cNvPr>
+          <p:cNvSpPr txBox="1"/>
+          <p:nvPr/>
+        </p:nvSpPr>
+        <p:spPr>
+          <a:xfrm>
+            <a:off x="9712038" y="4396253"/>
+            <a:ext cx="2784764" cy="584775"/>
+          </a:xfrm>
+          <a:prstGeom prst="rect">
+            <a:avLst/>
+          </a:prstGeom>
+          <a:noFill/>
+        </p:spPr>
+        <p:txBody>
+          <a:bodyPr wrap="square" rtlCol="0">
+            <a:spAutoFit/>
+          </a:bodyPr>
+          <a:lstStyle/>
+          <a:p>
+            <a:pPr algn="ctr"/>
+            <a:r>
+              <a:rPr lang="en-US" sz="3200" b="1" dirty="0">
+                <a:solidFill>
+                  <a:srgbClr val="002060"/>
+                </a:solidFill>
+              </a:rPr>
+              <a:t>INNOVATION</a:t>
+            </a:r>
+          </a:p>
+        </p:txBody>
+      </p:sp>
+      <p:sp>
+        <p:nvSpPr>
+          <p:cNvPr id="25" name="TextBox 24">
+            <a:extLst>
+              <a:ext uri="{FF2B5EF4-FFF2-40B4-BE49-F238E27FC236}">
+                <a16:creationId xmlns:a16="http://schemas.microsoft.com/office/drawing/2014/main" id="{4D3A5CA1-6A1D-A450-A745-A29C2F565D5D}"/>
+              </a:ext>
+            </a:extLst>
+          </p:cNvPr>
+          <p:cNvSpPr txBox="1"/>
+          <p:nvPr/>
+        </p:nvSpPr>
+        <p:spPr>
+          <a:xfrm>
+            <a:off x="17576645" y="4428013"/>
+            <a:ext cx="2784764" cy="584775"/>
+          </a:xfrm>
+          <a:prstGeom prst="rect">
+            <a:avLst/>
+          </a:prstGeom>
+          <a:noFill/>
+        </p:spPr>
+        <p:txBody>
+          <a:bodyPr wrap="square" rtlCol="0">
+            <a:spAutoFit/>
+          </a:bodyPr>
+          <a:lstStyle/>
+          <a:p>
+            <a:pPr algn="ctr"/>
+            <a:r>
+              <a:rPr lang="en-US" sz="3200" b="1" dirty="0">
+                <a:solidFill>
+                  <a:srgbClr val="002060"/>
+                </a:solidFill>
+              </a:rPr>
+              <a:t>RESEARCH</a:t>
+            </a:r>
+          </a:p>
+        </p:txBody>
+      </p:sp>
+      <p:sp>
+        <p:nvSpPr>
+          <p:cNvPr id="26" name="TextBox 25">
+            <a:extLst>
+              <a:ext uri="{FF2B5EF4-FFF2-40B4-BE49-F238E27FC236}">
+                <a16:creationId xmlns:a16="http://schemas.microsoft.com/office/drawing/2014/main" id="{6A124A98-D633-909B-F752-74C8912A4A84}"/>
+              </a:ext>
+            </a:extLst>
+          </p:cNvPr>
+          <p:cNvSpPr txBox="1"/>
+          <p:nvPr/>
+        </p:nvSpPr>
+        <p:spPr>
+          <a:xfrm>
+            <a:off x="25176018" y="4414407"/>
+            <a:ext cx="2784764" cy="584775"/>
+          </a:xfrm>
+          <a:prstGeom prst="rect">
+            <a:avLst/>
+          </a:prstGeom>
+          <a:noFill/>
+        </p:spPr>
+        <p:txBody>
+          <a:bodyPr wrap="square" rtlCol="0">
+            <a:spAutoFit/>
+          </a:bodyPr>
+          <a:lstStyle/>
+          <a:p>
+            <a:pPr algn="ctr"/>
+            <a:r>
+              <a:rPr lang="en-US" sz="3200" b="1" dirty="0">
+                <a:solidFill>
+                  <a:srgbClr val="002060"/>
+                </a:solidFill>
+              </a:rPr>
+              <a:t>IMPACT</a:t>
+            </a:r>
+          </a:p>
+        </p:txBody>
+      </p:sp>
       <p:pic>
         <p:nvPicPr>
-          <p:cNvPr id="25" name="Picture 24" descr="app_not_sure.png"/>
+          <p:cNvPr id="27" name="Picture 26" descr="mark.png"/>
           <p:cNvPicPr>
             <a:picLocks noChangeAspect="1"/>
           </p:cNvPicPr>
@@ -5312,8 +5530,8 @@
         </p:blipFill>
         <p:spPr>
           <a:xfrm>
-            <a:off x="2468880" y="24231600"/>
-            <a:ext cx="10607040" cy="6629400"/>
+            <a:off x="26517600" y="1143000"/>
+            <a:ext cx="2945718" cy="2743200"/>
           </a:xfrm>
           <a:prstGeom prst="rect">
             <a:avLst/>
@@ -5322,36 +5540,55 @@
       </p:pic>
       <p:sp>
         <p:nvSpPr>
-          <p:cNvPr id="26" name="TextBox 25"/>
-          <p:cNvSpPr txBox="1"/>
+          <p:cNvPr id="28" name="Rounded Rectangle 27"/>
+          <p:cNvSpPr/>
           <p:nvPr/>
         </p:nvSpPr>
         <p:spPr>
           <a:xfrm>
-            <a:off x="640080" y="30952440"/>
-            <a:ext cx="14264640" cy="548640"/>
-          </a:xfrm>
-          <a:prstGeom prst="rect">
-            <a:avLst/>
-          </a:prstGeom>
-          <a:noFill/>
-        </p:spPr>
-        <p:txBody>
-          <a:bodyPr wrap="none">
-            <a:spAutoFit/>
-          </a:bodyPr>
-          <a:lstStyle/>
-          <a:p>
-            <a:r>
-              <a:rPr sz="2000" i="1"/>
-              <a:t>QueryGenie asking which reading was meant when its four queries disagree.</a:t>
-            </a:r>
+            <a:off x="640080" y="5394960"/>
+            <a:ext cx="3451860" cy="1143000"/>
+          </a:xfrm>
+          <a:prstGeom prst="roundRect">
+            <a:avLst>
+              <a:gd name="adj" fmla="val 18000"/>
+            </a:avLst>
+          </a:prstGeom>
+          <a:solidFill>
+            <a:srgbClr val="FFFFFF"/>
+          </a:solidFill>
+          <a:ln w="19050">
+            <a:solidFill>
+              <a:srgbClr val="D6DCE5"/>
+            </a:solidFill>
+          </a:ln>
+          <a:effectLst/>
+        </p:spPr>
+        <p:style>
+          <a:lnRef idx="1">
+            <a:schemeClr val="accent1"/>
+          </a:lnRef>
+          <a:fillRef idx="3">
+            <a:schemeClr val="accent1"/>
+          </a:fillRef>
+          <a:effectRef idx="2">
+            <a:schemeClr val="accent1"/>
+          </a:effectRef>
+          <a:fontRef idx="minor">
+            <a:schemeClr val="lt1"/>
+          </a:fontRef>
+        </p:style>
+        <p:txBody>
+          <a:bodyPr rtlCol="0" anchor="ctr"/>
+          <a:lstStyle/>
+          <a:p>
+            <a:pPr algn="ctr"/>
           </a:p>
         </p:txBody>
       </p:sp>
       <p:pic>
         <p:nvPicPr>
-          <p:cNvPr id="27" name="Picture 26" descr="final_pipeline.png"/>
+          <p:cNvPr id="29" name="Picture 28" descr="graduation-cap_navy.png"/>
           <p:cNvPicPr>
             <a:picLocks noChangeAspect="1"/>
           </p:cNvPicPr>
@@ -5365,315 +5602,107 @@
         </p:blipFill>
         <p:spPr>
           <a:xfrm>
-            <a:off x="15361920" y="7772400"/>
-            <a:ext cx="14264640" cy="7667244"/>
+            <a:off x="777240" y="5669280"/>
+            <a:ext cx="594360" cy="594360"/>
           </a:xfrm>
           <a:prstGeom prst="rect">
             <a:avLst/>
           </a:prstGeom>
         </p:spPr>
       </p:pic>
-      <p:graphicFrame>
-        <p:nvGraphicFramePr>
-          <p:cNvPr id="28" name="Table 27"/>
-          <p:cNvGraphicFramePr>
-            <a:graphicFrameLocks noGrp="1"/>
-          </p:cNvGraphicFramePr>
+      <p:sp>
+        <p:nvSpPr>
+          <p:cNvPr id="30" name="TextBox 29"/>
+          <p:cNvSpPr txBox="1"/>
           <p:nvPr/>
-        </p:nvGraphicFramePr>
-        <p:xfrm>
-          <a:off x="15361920" y="25786080"/>
-          <a:ext cx="7680960" cy="2743200"/>
-        </p:xfrm>
-        <a:graphic>
-          <a:graphicData uri="http://schemas.openxmlformats.org/drawingml/2006/table">
-            <a:tbl>
-              <a:tblPr firstRow="1" bandRow="1">
-                <a:tableStyleId>{5C22544A-7EE6-4342-B048-85BDC9FD1C3A}</a:tableStyleId>
-              </a:tblPr>
-              <a:tblGrid>
-                <a:gridCol w="3291840"/>
-                <a:gridCol w="1463040"/>
-                <a:gridCol w="1463040"/>
-                <a:gridCol w="1463040"/>
-              </a:tblGrid>
-              <a:tr h="548640">
-                <a:tc>
-                  <a:txBody>
-                    <a:bodyPr/>
-                    <a:lstStyle/>
-                    <a:p>
-                      <a:r>
-                        <a:rPr sz="2000" b="1"/>
-                        <a:t>System (Spider dev)</a:t>
-                      </a:r>
-                    </a:p>
-                  </a:txBody>
-                  <a:tcPr/>
-                </a:tc>
-                <a:tc>
-                  <a:txBody>
-                    <a:bodyPr/>
-                    <a:lstStyle/>
-                    <a:p>
-                      <a:r>
-                        <a:rPr sz="2000" b="1"/>
-                        <a:t>Answered</a:t>
-                      </a:r>
-                    </a:p>
-                  </a:txBody>
-                  <a:tcPr/>
-                </a:tc>
-                <a:tc>
-                  <a:txBody>
-                    <a:bodyPr/>
-                    <a:lstStyle/>
-                    <a:p>
-                      <a:r>
-                        <a:rPr sz="2000" b="1"/>
-                        <a:t>Correct</a:t>
-                      </a:r>
-                    </a:p>
-                  </a:txBody>
-                  <a:tcPr/>
-                </a:tc>
-                <a:tc>
-                  <a:txBody>
-                    <a:bodyPr/>
-                    <a:lstStyle/>
-                    <a:p>
-                      <a:r>
-                        <a:rPr sz="2000" b="1"/>
-                        <a:t>Wrong</a:t>
-                      </a:r>
-                    </a:p>
-                  </a:txBody>
-                  <a:tcPr/>
-                </a:tc>
-              </a:tr>
-              <a:tr h="548640">
-                <a:tc>
-                  <a:txBody>
-                    <a:bodyPr/>
-                    <a:lstStyle/>
-                    <a:p>
-                      <a:r>
-                        <a:rPr sz="2000" b="0"/>
-                        <a:t>CodeS-1B, paper</a:t>
-                      </a:r>
-                    </a:p>
-                  </a:txBody>
-                  <a:tcPr/>
-                </a:tc>
-                <a:tc>
-                  <a:txBody>
-                    <a:bodyPr/>
-                    <a:lstStyle/>
-                    <a:p>
-                      <a:r>
-                        <a:rPr sz="2000" b="0"/>
-                        <a:t>100%</a:t>
-                      </a:r>
-                    </a:p>
-                  </a:txBody>
-                  <a:tcPr/>
-                </a:tc>
-                <a:tc>
-                  <a:txBody>
-                    <a:bodyPr/>
-                    <a:lstStyle/>
-                    <a:p>
-                      <a:r>
-                        <a:rPr sz="2000" b="0"/>
-                        <a:t>77.9%</a:t>
-                      </a:r>
-                    </a:p>
-                  </a:txBody>
-                  <a:tcPr/>
-                </a:tc>
-                <a:tc>
-                  <a:txBody>
-                    <a:bodyPr/>
-                    <a:lstStyle/>
-                    <a:p>
-                      <a:r>
-                        <a:rPr sz="2000" b="0"/>
-                        <a:t>—</a:t>
-                      </a:r>
-                    </a:p>
-                  </a:txBody>
-                  <a:tcPr/>
-                </a:tc>
-              </a:tr>
-              <a:tr h="548640">
-                <a:tc>
-                  <a:txBody>
-                    <a:bodyPr/>
-                    <a:lstStyle/>
-                    <a:p>
-                      <a:r>
-                        <a:rPr sz="2000" b="0"/>
-                        <a:t>Our reproduction</a:t>
-                      </a:r>
-                    </a:p>
-                  </a:txBody>
-                  <a:tcPr/>
-                </a:tc>
-                <a:tc>
-                  <a:txBody>
-                    <a:bodyPr/>
-                    <a:lstStyle/>
-                    <a:p>
-                      <a:r>
-                        <a:rPr sz="2000" b="0"/>
-                        <a:t>100%</a:t>
-                      </a:r>
-                    </a:p>
-                  </a:txBody>
-                  <a:tcPr/>
-                </a:tc>
-                <a:tc>
-                  <a:txBody>
-                    <a:bodyPr/>
-                    <a:lstStyle/>
-                    <a:p>
-                      <a:r>
-                        <a:rPr sz="2000" b="0"/>
-                        <a:t>77.8%</a:t>
-                      </a:r>
-                    </a:p>
-                  </a:txBody>
-                  <a:tcPr/>
-                </a:tc>
-                <a:tc>
-                  <a:txBody>
-                    <a:bodyPr/>
-                    <a:lstStyle/>
-                    <a:p>
-                      <a:r>
-                        <a:rPr sz="2000" b="0"/>
-                        <a:t>230</a:t>
-                      </a:r>
-                    </a:p>
-                  </a:txBody>
-                  <a:tcPr/>
-                </a:tc>
-              </a:tr>
-              <a:tr h="548640">
-                <a:tc>
-                  <a:txBody>
-                    <a:bodyPr/>
-                    <a:lstStyle/>
-                    <a:p>
-                      <a:r>
-                        <a:rPr sz="2000" b="1"/>
-                        <a:t>Enhanced (tested)</a:t>
-                      </a:r>
-                    </a:p>
-                  </a:txBody>
-                  <a:tcPr/>
-                </a:tc>
-                <a:tc>
-                  <a:txBody>
-                    <a:bodyPr/>
-                    <a:lstStyle/>
-                    <a:p>
-                      <a:r>
-                        <a:rPr sz="2000" b="1"/>
-                        <a:t>90.4%</a:t>
-                      </a:r>
-                    </a:p>
-                  </a:txBody>
-                  <a:tcPr/>
-                </a:tc>
-                <a:tc>
-                  <a:txBody>
-                    <a:bodyPr/>
-                    <a:lstStyle/>
-                    <a:p>
-                      <a:r>
-                        <a:rPr sz="2000" b="1"/>
-                        <a:t>83.3%</a:t>
-                      </a:r>
-                    </a:p>
-                  </a:txBody>
-                  <a:tcPr/>
-                </a:tc>
-                <a:tc>
-                  <a:txBody>
-                    <a:bodyPr/>
-                    <a:lstStyle/>
-                    <a:p>
-                      <a:r>
-                        <a:rPr sz="2000" b="1"/>
-                        <a:t>156</a:t>
-                      </a:r>
-                    </a:p>
-                  </a:txBody>
-                  <a:tcPr/>
-                </a:tc>
-              </a:tr>
-              <a:tr h="548640">
-                <a:tc>
-                  <a:txBody>
-                    <a:bodyPr/>
-                    <a:lstStyle/>
-                    <a:p>
-                      <a:r>
-                        <a:rPr sz="2000" b="0"/>
-                        <a:t>All 4 must agree</a:t>
-                      </a:r>
-                    </a:p>
-                  </a:txBody>
-                  <a:tcPr/>
-                </a:tc>
-                <a:tc>
-                  <a:txBody>
-                    <a:bodyPr/>
-                    <a:lstStyle/>
-                    <a:p>
-                      <a:r>
-                        <a:rPr sz="2000" b="0"/>
-                        <a:t>39.8%</a:t>
-                      </a:r>
-                    </a:p>
-                  </a:txBody>
-                  <a:tcPr/>
-                </a:tc>
-                <a:tc>
-                  <a:txBody>
-                    <a:bodyPr/>
-                    <a:lstStyle/>
-                    <a:p>
-                      <a:r>
-                        <a:rPr sz="2000" b="0"/>
-                        <a:t>88.3%</a:t>
-                      </a:r>
-                    </a:p>
-                  </a:txBody>
-                  <a:tcPr/>
-                </a:tc>
-                <a:tc>
-                  <a:txBody>
-                    <a:bodyPr/>
-                    <a:lstStyle/>
-                    <a:p>
-                      <a:r>
-                        <a:rPr sz="2000" b="0"/>
-                        <a:t>48</a:t>
-                      </a:r>
-                    </a:p>
-                  </a:txBody>
-                  <a:tcPr/>
-                </a:tc>
-              </a:tr>
-            </a:tbl>
-          </a:graphicData>
-        </a:graphic>
-      </p:graphicFrame>
+        </p:nvSpPr>
+        <p:spPr>
+          <a:xfrm>
+            <a:off x="1417319" y="5394960"/>
+            <a:ext cx="2583180" cy="1143000"/>
+          </a:xfrm>
+          <a:prstGeom prst="rect">
+            <a:avLst/>
+          </a:prstGeom>
+          <a:noFill/>
+        </p:spPr>
+        <p:txBody>
+          <a:bodyPr wrap="square" anchor="ctr" lIns="73152" rIns="73152" tIns="27432" bIns="27432">
+            <a:spAutoFit/>
+          </a:bodyPr>
+          <a:lstStyle/>
+          <a:p>
+            <a:pPr algn="l">
+              <a:spcBef>
+                <a:spcPts val="0"/>
+              </a:spcBef>
+              <a:spcAft>
+                <a:spcPts val="650"/>
+              </a:spcAft>
+            </a:pPr>
+            <a:r>
+              <a:rPr sz="2100" b="1" i="0">
+                <a:solidFill>
+                  <a:srgbClr val="002060"/>
+                </a:solidFill>
+                <a:latin typeface="Times New Roman"/>
+              </a:rPr>
+              <a:t>B.Tech CSIT</a:t>
+            </a:r>
+          </a:p>
+        </p:txBody>
+      </p:sp>
+      <p:sp>
+        <p:nvSpPr>
+          <p:cNvPr id="31" name="Rounded Rectangle 30"/>
+          <p:cNvSpPr/>
+          <p:nvPr/>
+        </p:nvSpPr>
+        <p:spPr>
+          <a:xfrm>
+            <a:off x="4274820" y="5394960"/>
+            <a:ext cx="3451860" cy="1143000"/>
+          </a:xfrm>
+          <a:prstGeom prst="roundRect">
+            <a:avLst>
+              <a:gd name="adj" fmla="val 18000"/>
+            </a:avLst>
+          </a:prstGeom>
+          <a:solidFill>
+            <a:srgbClr val="FFFFFF"/>
+          </a:solidFill>
+          <a:ln w="19050">
+            <a:solidFill>
+              <a:srgbClr val="D6DCE5"/>
+            </a:solidFill>
+          </a:ln>
+          <a:effectLst/>
+        </p:spPr>
+        <p:style>
+          <a:lnRef idx="1">
+            <a:schemeClr val="accent1"/>
+          </a:lnRef>
+          <a:fillRef idx="3">
+            <a:schemeClr val="accent1"/>
+          </a:fillRef>
+          <a:effectRef idx="2">
+            <a:schemeClr val="accent1"/>
+          </a:effectRef>
+          <a:fontRef idx="minor">
+            <a:schemeClr val="lt1"/>
+          </a:fontRef>
+        </p:style>
+        <p:txBody>
+          <a:bodyPr rtlCol="0" anchor="ctr"/>
+          <a:lstStyle/>
+          <a:p>
+            <a:pPr algn="ctr"/>
+          </a:p>
+        </p:txBody>
+      </p:sp>
       <p:pic>
         <p:nvPicPr>
-          <p:cNvPr id="29" name="Picture 28" descr="accuracy_coverage_T2-006.png"/>
+          <p:cNvPr id="32" name="Picture 31" descr="users_navy.png"/>
           <p:cNvPicPr>
             <a:picLocks noChangeAspect="1"/>
           </p:cNvPicPr>
@@ -5687,14 +5716,2513 @@
         </p:blipFill>
         <p:spPr>
           <a:xfrm>
-            <a:off x="23225760" y="25786080"/>
-            <a:ext cx="6400800" cy="3733800"/>
+            <a:off x="4411980" y="5669280"/>
+            <a:ext cx="594360" cy="594360"/>
           </a:xfrm>
           <a:prstGeom prst="rect">
             <a:avLst/>
           </a:prstGeom>
         </p:spPr>
       </p:pic>
+      <p:sp>
+        <p:nvSpPr>
+          <p:cNvPr id="33" name="TextBox 32"/>
+          <p:cNvSpPr txBox="1"/>
+          <p:nvPr/>
+        </p:nvSpPr>
+        <p:spPr>
+          <a:xfrm>
+            <a:off x="5052059" y="5394960"/>
+            <a:ext cx="2583180" cy="1143000"/>
+          </a:xfrm>
+          <a:prstGeom prst="rect">
+            <a:avLst/>
+          </a:prstGeom>
+          <a:noFill/>
+        </p:spPr>
+        <p:txBody>
+          <a:bodyPr wrap="square" anchor="ctr" lIns="73152" rIns="73152" tIns="27432" bIns="27432">
+            <a:spAutoFit/>
+          </a:bodyPr>
+          <a:lstStyle/>
+          <a:p>
+            <a:pPr algn="l">
+              <a:spcBef>
+                <a:spcPts val="0"/>
+              </a:spcBef>
+              <a:spcAft>
+                <a:spcPts val="650"/>
+              </a:spcAft>
+            </a:pPr>
+            <a:r>
+              <a:rPr sz="2100" b="1" i="0">
+                <a:solidFill>
+                  <a:srgbClr val="002060"/>
+                </a:solidFill>
+                <a:latin typeface="Times New Roman"/>
+              </a:rPr>
+              <a:t>Team 18</a:t>
+            </a:r>
+          </a:p>
+        </p:txBody>
+      </p:sp>
+      <p:sp>
+        <p:nvSpPr>
+          <p:cNvPr id="34" name="Rounded Rectangle 33"/>
+          <p:cNvSpPr/>
+          <p:nvPr/>
+        </p:nvSpPr>
+        <p:spPr>
+          <a:xfrm>
+            <a:off x="7939735" y="5394960"/>
+            <a:ext cx="3451860" cy="1143000"/>
+          </a:xfrm>
+          <a:prstGeom prst="roundRect">
+            <a:avLst>
+              <a:gd name="adj" fmla="val 18000"/>
+            </a:avLst>
+          </a:prstGeom>
+          <a:solidFill>
+            <a:srgbClr val="FFFFFF"/>
+          </a:solidFill>
+          <a:ln w="19050">
+            <a:solidFill>
+              <a:srgbClr val="D6DCE5"/>
+            </a:solidFill>
+          </a:ln>
+          <a:effectLst/>
+        </p:spPr>
+        <p:style>
+          <a:lnRef idx="1">
+            <a:schemeClr val="accent1"/>
+          </a:lnRef>
+          <a:fillRef idx="3">
+            <a:schemeClr val="accent1"/>
+          </a:fillRef>
+          <a:effectRef idx="2">
+            <a:schemeClr val="accent1"/>
+          </a:effectRef>
+          <a:fontRef idx="minor">
+            <a:schemeClr val="lt1"/>
+          </a:fontRef>
+        </p:style>
+        <p:txBody>
+          <a:bodyPr rtlCol="0" anchor="ctr"/>
+          <a:lstStyle/>
+          <a:p>
+            <a:pPr algn="ctr"/>
+          </a:p>
+        </p:txBody>
+      </p:sp>
+      <p:pic>
+        <p:nvPicPr>
+          <p:cNvPr id="35" name="Picture 34" descr="shield-check_navy.png"/>
+          <p:cNvPicPr>
+            <a:picLocks noChangeAspect="1"/>
+          </p:cNvPicPr>
+          <p:nvPr/>
+        </p:nvPicPr>
+        <p:blipFill>
+          <a:blip r:embed="rId6"/>
+          <a:stretch>
+            <a:fillRect/>
+          </a:stretch>
+        </p:blipFill>
+        <p:spPr>
+          <a:xfrm>
+            <a:off x="8076895" y="5669280"/>
+            <a:ext cx="594360" cy="594360"/>
+          </a:xfrm>
+          <a:prstGeom prst="rect">
+            <a:avLst/>
+          </a:prstGeom>
+        </p:spPr>
+      </p:pic>
+      <p:sp>
+        <p:nvSpPr>
+          <p:cNvPr id="36" name="TextBox 35"/>
+          <p:cNvSpPr txBox="1"/>
+          <p:nvPr/>
+        </p:nvSpPr>
+        <p:spPr>
+          <a:xfrm>
+            <a:off x="8716975" y="5394960"/>
+            <a:ext cx="2583180" cy="1143000"/>
+          </a:xfrm>
+          <a:prstGeom prst="rect">
+            <a:avLst/>
+          </a:prstGeom>
+          <a:noFill/>
+        </p:spPr>
+        <p:txBody>
+          <a:bodyPr wrap="square" anchor="ctr" lIns="73152" rIns="73152" tIns="27432" bIns="27432">
+            <a:spAutoFit/>
+          </a:bodyPr>
+          <a:lstStyle/>
+          <a:p>
+            <a:pPr algn="l">
+              <a:spcBef>
+                <a:spcPts val="0"/>
+              </a:spcBef>
+              <a:spcAft>
+                <a:spcPts val="650"/>
+              </a:spcAft>
+            </a:pPr>
+            <a:r>
+              <a:rPr sz="2100" b="1" i="0">
+                <a:solidFill>
+                  <a:srgbClr val="002060"/>
+                </a:solidFill>
+                <a:latin typeface="Times New Roman"/>
+              </a:rPr>
+              <a:t>Confidence-aware abstention</a:t>
+            </a:r>
+          </a:p>
+        </p:txBody>
+      </p:sp>
+      <p:sp>
+        <p:nvSpPr>
+          <p:cNvPr id="37" name="Rounded Rectangle 36"/>
+          <p:cNvSpPr/>
+          <p:nvPr/>
+        </p:nvSpPr>
+        <p:spPr>
+          <a:xfrm>
+            <a:off x="11574475" y="5394960"/>
+            <a:ext cx="3451860" cy="1143000"/>
+          </a:xfrm>
+          <a:prstGeom prst="roundRect">
+            <a:avLst>
+              <a:gd name="adj" fmla="val 18000"/>
+            </a:avLst>
+          </a:prstGeom>
+          <a:solidFill>
+            <a:srgbClr val="FFFFFF"/>
+          </a:solidFill>
+          <a:ln w="19050">
+            <a:solidFill>
+              <a:srgbClr val="D6DCE5"/>
+            </a:solidFill>
+          </a:ln>
+          <a:effectLst/>
+        </p:spPr>
+        <p:style>
+          <a:lnRef idx="1">
+            <a:schemeClr val="accent1"/>
+          </a:lnRef>
+          <a:fillRef idx="3">
+            <a:schemeClr val="accent1"/>
+          </a:fillRef>
+          <a:effectRef idx="2">
+            <a:schemeClr val="accent1"/>
+          </a:effectRef>
+          <a:fontRef idx="minor">
+            <a:schemeClr val="lt1"/>
+          </a:fontRef>
+        </p:style>
+        <p:txBody>
+          <a:bodyPr rtlCol="0" anchor="ctr"/>
+          <a:lstStyle/>
+          <a:p>
+            <a:pPr algn="ctr"/>
+          </a:p>
+        </p:txBody>
+      </p:sp>
+      <p:pic>
+        <p:nvPicPr>
+          <p:cNvPr id="38" name="Picture 37" descr="refresh-cw_navy.png"/>
+          <p:cNvPicPr>
+            <a:picLocks noChangeAspect="1"/>
+          </p:cNvPicPr>
+          <p:nvPr/>
+        </p:nvPicPr>
+        <p:blipFill>
+          <a:blip r:embed="rId7"/>
+          <a:stretch>
+            <a:fillRect/>
+          </a:stretch>
+        </p:blipFill>
+        <p:spPr>
+          <a:xfrm>
+            <a:off x="11711635" y="5669280"/>
+            <a:ext cx="594360" cy="594360"/>
+          </a:xfrm>
+          <a:prstGeom prst="rect">
+            <a:avLst/>
+          </a:prstGeom>
+        </p:spPr>
+      </p:pic>
+      <p:sp>
+        <p:nvSpPr>
+          <p:cNvPr id="39" name="TextBox 38"/>
+          <p:cNvSpPr txBox="1"/>
+          <p:nvPr/>
+        </p:nvSpPr>
+        <p:spPr>
+          <a:xfrm>
+            <a:off x="12351715" y="5394960"/>
+            <a:ext cx="2583180" cy="1143000"/>
+          </a:xfrm>
+          <a:prstGeom prst="rect">
+            <a:avLst/>
+          </a:prstGeom>
+          <a:noFill/>
+        </p:spPr>
+        <p:txBody>
+          <a:bodyPr wrap="square" anchor="ctr" lIns="73152" rIns="73152" tIns="27432" bIns="27432">
+            <a:spAutoFit/>
+          </a:bodyPr>
+          <a:lstStyle/>
+          <a:p>
+            <a:pPr algn="l">
+              <a:spcBef>
+                <a:spcPts val="0"/>
+              </a:spcBef>
+              <a:spcAft>
+                <a:spcPts val="650"/>
+              </a:spcAft>
+            </a:pPr>
+            <a:r>
+              <a:rPr sz="2100" b="1" i="0">
+                <a:solidFill>
+                  <a:srgbClr val="002060"/>
+                </a:solidFill>
+                <a:latin typeface="Times New Roman"/>
+              </a:rPr>
+              <a:t>Self-correction</a:t>
+            </a:r>
+          </a:p>
+        </p:txBody>
+      </p:sp>
+      <p:sp>
+        <p:nvSpPr>
+          <p:cNvPr id="40" name="Rounded Rectangle 39"/>
+          <p:cNvSpPr/>
+          <p:nvPr/>
+        </p:nvSpPr>
+        <p:spPr>
+          <a:xfrm>
+            <a:off x="15239390" y="5394960"/>
+            <a:ext cx="3451860" cy="1143000"/>
+          </a:xfrm>
+          <a:prstGeom prst="roundRect">
+            <a:avLst>
+              <a:gd name="adj" fmla="val 18000"/>
+            </a:avLst>
+          </a:prstGeom>
+          <a:solidFill>
+            <a:srgbClr val="FFFFFF"/>
+          </a:solidFill>
+          <a:ln w="19050">
+            <a:solidFill>
+              <a:srgbClr val="D6DCE5"/>
+            </a:solidFill>
+          </a:ln>
+          <a:effectLst/>
+        </p:spPr>
+        <p:style>
+          <a:lnRef idx="1">
+            <a:schemeClr val="accent1"/>
+          </a:lnRef>
+          <a:fillRef idx="3">
+            <a:schemeClr val="accent1"/>
+          </a:fillRef>
+          <a:effectRef idx="2">
+            <a:schemeClr val="accent1"/>
+          </a:effectRef>
+          <a:fontRef idx="minor">
+            <a:schemeClr val="lt1"/>
+          </a:fontRef>
+        </p:style>
+        <p:txBody>
+          <a:bodyPr rtlCol="0" anchor="ctr"/>
+          <a:lstStyle/>
+          <a:p>
+            <a:pPr algn="ctr"/>
+          </a:p>
+        </p:txBody>
+      </p:sp>
+      <p:pic>
+        <p:nvPicPr>
+          <p:cNvPr id="41" name="Picture 40" descr="book-open_navy.png"/>
+          <p:cNvPicPr>
+            <a:picLocks noChangeAspect="1"/>
+          </p:cNvPicPr>
+          <p:nvPr/>
+        </p:nvPicPr>
+        <p:blipFill>
+          <a:blip r:embed="rId8"/>
+          <a:stretch>
+            <a:fillRect/>
+          </a:stretch>
+        </p:blipFill>
+        <p:spPr>
+          <a:xfrm>
+            <a:off x="15376550" y="5669280"/>
+            <a:ext cx="594360" cy="594360"/>
+          </a:xfrm>
+          <a:prstGeom prst="rect">
+            <a:avLst/>
+          </a:prstGeom>
+        </p:spPr>
+      </p:pic>
+      <p:sp>
+        <p:nvSpPr>
+          <p:cNvPr id="42" name="TextBox 41"/>
+          <p:cNvSpPr txBox="1"/>
+          <p:nvPr/>
+        </p:nvSpPr>
+        <p:spPr>
+          <a:xfrm>
+            <a:off x="16016630" y="5394960"/>
+            <a:ext cx="2583180" cy="1143000"/>
+          </a:xfrm>
+          <a:prstGeom prst="rect">
+            <a:avLst/>
+          </a:prstGeom>
+          <a:noFill/>
+        </p:spPr>
+        <p:txBody>
+          <a:bodyPr wrap="square" anchor="ctr" lIns="73152" rIns="73152" tIns="27432" bIns="27432">
+            <a:spAutoFit/>
+          </a:bodyPr>
+          <a:lstStyle/>
+          <a:p>
+            <a:pPr algn="l">
+              <a:spcBef>
+                <a:spcPts val="0"/>
+              </a:spcBef>
+              <a:spcAft>
+                <a:spcPts val="650"/>
+              </a:spcAft>
+            </a:pPr>
+            <a:r>
+              <a:rPr sz="2100" b="1" i="0">
+                <a:solidFill>
+                  <a:srgbClr val="002060"/>
+                </a:solidFill>
+                <a:latin typeface="Times New Roman"/>
+              </a:rPr>
+              <a:t>CodeS · SIGMOD 2024</a:t>
+            </a:r>
+          </a:p>
+        </p:txBody>
+      </p:sp>
+      <p:sp>
+        <p:nvSpPr>
+          <p:cNvPr id="43" name="Rounded Rectangle 42"/>
+          <p:cNvSpPr/>
+          <p:nvPr/>
+        </p:nvSpPr>
+        <p:spPr>
+          <a:xfrm>
+            <a:off x="18874130" y="5394960"/>
+            <a:ext cx="3451860" cy="1143000"/>
+          </a:xfrm>
+          <a:prstGeom prst="roundRect">
+            <a:avLst>
+              <a:gd name="adj" fmla="val 18000"/>
+            </a:avLst>
+          </a:prstGeom>
+          <a:solidFill>
+            <a:srgbClr val="FFFFFF"/>
+          </a:solidFill>
+          <a:ln w="19050">
+            <a:solidFill>
+              <a:srgbClr val="D6DCE5"/>
+            </a:solidFill>
+          </a:ln>
+          <a:effectLst/>
+        </p:spPr>
+        <p:style>
+          <a:lnRef idx="1">
+            <a:schemeClr val="accent1"/>
+          </a:lnRef>
+          <a:fillRef idx="3">
+            <a:schemeClr val="accent1"/>
+          </a:fillRef>
+          <a:effectRef idx="2">
+            <a:schemeClr val="accent1"/>
+          </a:effectRef>
+          <a:fontRef idx="minor">
+            <a:schemeClr val="lt1"/>
+          </a:fontRef>
+        </p:style>
+        <p:txBody>
+          <a:bodyPr rtlCol="0" anchor="ctr"/>
+          <a:lstStyle/>
+          <a:p>
+            <a:pPr algn="ctr"/>
+          </a:p>
+        </p:txBody>
+      </p:sp>
+      <p:pic>
+        <p:nvPicPr>
+          <p:cNvPr id="44" name="Picture 43" descr="database_navy.png"/>
+          <p:cNvPicPr>
+            <a:picLocks noChangeAspect="1"/>
+          </p:cNvPicPr>
+          <p:nvPr/>
+        </p:nvPicPr>
+        <p:blipFill>
+          <a:blip r:embed="rId9"/>
+          <a:stretch>
+            <a:fillRect/>
+          </a:stretch>
+        </p:blipFill>
+        <p:spPr>
+          <a:xfrm>
+            <a:off x="19011290" y="5669280"/>
+            <a:ext cx="594360" cy="594360"/>
+          </a:xfrm>
+          <a:prstGeom prst="rect">
+            <a:avLst/>
+          </a:prstGeom>
+        </p:spPr>
+      </p:pic>
+      <p:sp>
+        <p:nvSpPr>
+          <p:cNvPr id="45" name="TextBox 44"/>
+          <p:cNvSpPr txBox="1"/>
+          <p:nvPr/>
+        </p:nvSpPr>
+        <p:spPr>
+          <a:xfrm>
+            <a:off x="19651370" y="5394960"/>
+            <a:ext cx="2583180" cy="1143000"/>
+          </a:xfrm>
+          <a:prstGeom prst="rect">
+            <a:avLst/>
+          </a:prstGeom>
+          <a:noFill/>
+        </p:spPr>
+        <p:txBody>
+          <a:bodyPr wrap="square" anchor="ctr" lIns="73152" rIns="73152" tIns="27432" bIns="27432">
+            <a:spAutoFit/>
+          </a:bodyPr>
+          <a:lstStyle/>
+          <a:p>
+            <a:pPr algn="l">
+              <a:spcBef>
+                <a:spcPts val="0"/>
+              </a:spcBef>
+              <a:spcAft>
+                <a:spcPts val="650"/>
+              </a:spcAft>
+            </a:pPr>
+            <a:r>
+              <a:rPr sz="2100" b="1" i="0">
+                <a:solidFill>
+                  <a:srgbClr val="002060"/>
+                </a:solidFill>
+                <a:latin typeface="Times New Roman"/>
+              </a:rPr>
+              <a:t>Spider benchmark</a:t>
+            </a:r>
+          </a:p>
+        </p:txBody>
+      </p:sp>
+      <p:sp>
+        <p:nvSpPr>
+          <p:cNvPr id="46" name="Rounded Rectangle 45"/>
+          <p:cNvSpPr/>
+          <p:nvPr/>
+        </p:nvSpPr>
+        <p:spPr>
+          <a:xfrm>
+            <a:off x="22539045" y="5394960"/>
+            <a:ext cx="3451860" cy="1143000"/>
+          </a:xfrm>
+          <a:prstGeom prst="roundRect">
+            <a:avLst>
+              <a:gd name="adj" fmla="val 18000"/>
+            </a:avLst>
+          </a:prstGeom>
+          <a:solidFill>
+            <a:srgbClr val="FFFFFF"/>
+          </a:solidFill>
+          <a:ln w="19050">
+            <a:solidFill>
+              <a:srgbClr val="D6DCE5"/>
+            </a:solidFill>
+          </a:ln>
+          <a:effectLst/>
+        </p:spPr>
+        <p:style>
+          <a:lnRef idx="1">
+            <a:schemeClr val="accent1"/>
+          </a:lnRef>
+          <a:fillRef idx="3">
+            <a:schemeClr val="accent1"/>
+          </a:fillRef>
+          <a:effectRef idx="2">
+            <a:schemeClr val="accent1"/>
+          </a:effectRef>
+          <a:fontRef idx="minor">
+            <a:schemeClr val="lt1"/>
+          </a:fontRef>
+        </p:style>
+        <p:txBody>
+          <a:bodyPr rtlCol="0" anchor="ctr"/>
+          <a:lstStyle/>
+          <a:p>
+            <a:pPr algn="ctr"/>
+          </a:p>
+        </p:txBody>
+      </p:sp>
+      <p:pic>
+        <p:nvPicPr>
+          <p:cNvPr id="47" name="Picture 46" descr="monitor-smartphone_navy.png"/>
+          <p:cNvPicPr>
+            <a:picLocks noChangeAspect="1"/>
+          </p:cNvPicPr>
+          <p:nvPr/>
+        </p:nvPicPr>
+        <p:blipFill>
+          <a:blip r:embed="rId10"/>
+          <a:stretch>
+            <a:fillRect/>
+          </a:stretch>
+        </p:blipFill>
+        <p:spPr>
+          <a:xfrm>
+            <a:off x="22676205" y="5669280"/>
+            <a:ext cx="594360" cy="594360"/>
+          </a:xfrm>
+          <a:prstGeom prst="rect">
+            <a:avLst/>
+          </a:prstGeom>
+        </p:spPr>
+      </p:pic>
+      <p:sp>
+        <p:nvSpPr>
+          <p:cNvPr id="48" name="TextBox 47"/>
+          <p:cNvSpPr txBox="1"/>
+          <p:nvPr/>
+        </p:nvSpPr>
+        <p:spPr>
+          <a:xfrm>
+            <a:off x="23316285" y="5394960"/>
+            <a:ext cx="2583180" cy="1143000"/>
+          </a:xfrm>
+          <a:prstGeom prst="rect">
+            <a:avLst/>
+          </a:prstGeom>
+          <a:noFill/>
+        </p:spPr>
+        <p:txBody>
+          <a:bodyPr wrap="square" anchor="ctr" lIns="73152" rIns="73152" tIns="27432" bIns="27432">
+            <a:spAutoFit/>
+          </a:bodyPr>
+          <a:lstStyle/>
+          <a:p>
+            <a:pPr algn="l">
+              <a:spcBef>
+                <a:spcPts val="0"/>
+              </a:spcBef>
+              <a:spcAft>
+                <a:spcPts val="650"/>
+              </a:spcAft>
+            </a:pPr>
+            <a:r>
+              <a:rPr sz="2100" b="1" i="0">
+                <a:solidFill>
+                  <a:srgbClr val="002060"/>
+                </a:solidFill>
+                <a:latin typeface="Times New Roman"/>
+              </a:rPr>
+              <a:t>Desktop app</a:t>
+            </a:r>
+          </a:p>
+        </p:txBody>
+      </p:sp>
+      <p:sp>
+        <p:nvSpPr>
+          <p:cNvPr id="49" name="Rounded Rectangle 48"/>
+          <p:cNvSpPr/>
+          <p:nvPr/>
+        </p:nvSpPr>
+        <p:spPr>
+          <a:xfrm>
+            <a:off x="26173785" y="5394960"/>
+            <a:ext cx="3451860" cy="1143000"/>
+          </a:xfrm>
+          <a:prstGeom prst="roundRect">
+            <a:avLst>
+              <a:gd name="adj" fmla="val 18000"/>
+            </a:avLst>
+          </a:prstGeom>
+          <a:solidFill>
+            <a:srgbClr val="FFFFFF"/>
+          </a:solidFill>
+          <a:ln w="19050">
+            <a:solidFill>
+              <a:srgbClr val="D6DCE5"/>
+            </a:solidFill>
+          </a:ln>
+          <a:effectLst/>
+        </p:spPr>
+        <p:style>
+          <a:lnRef idx="1">
+            <a:schemeClr val="accent1"/>
+          </a:lnRef>
+          <a:fillRef idx="3">
+            <a:schemeClr val="accent1"/>
+          </a:fillRef>
+          <a:effectRef idx="2">
+            <a:schemeClr val="accent1"/>
+          </a:effectRef>
+          <a:fontRef idx="minor">
+            <a:schemeClr val="lt1"/>
+          </a:fontRef>
+        </p:style>
+        <p:txBody>
+          <a:bodyPr rtlCol="0" anchor="ctr"/>
+          <a:lstStyle/>
+          <a:p>
+            <a:pPr algn="ctr"/>
+          </a:p>
+        </p:txBody>
+      </p:sp>
+      <p:pic>
+        <p:nvPicPr>
+          <p:cNvPr id="50" name="Picture 49" descr="lock-keyhole_navy.png"/>
+          <p:cNvPicPr>
+            <a:picLocks noChangeAspect="1"/>
+          </p:cNvPicPr>
+          <p:nvPr/>
+        </p:nvPicPr>
+        <p:blipFill>
+          <a:blip r:embed="rId11"/>
+          <a:stretch>
+            <a:fillRect/>
+          </a:stretch>
+        </p:blipFill>
+        <p:spPr>
+          <a:xfrm>
+            <a:off x="26310945" y="5669280"/>
+            <a:ext cx="594360" cy="594360"/>
+          </a:xfrm>
+          <a:prstGeom prst="rect">
+            <a:avLst/>
+          </a:prstGeom>
+        </p:spPr>
+      </p:pic>
+      <p:sp>
+        <p:nvSpPr>
+          <p:cNvPr id="51" name="TextBox 50"/>
+          <p:cNvSpPr txBox="1"/>
+          <p:nvPr/>
+        </p:nvSpPr>
+        <p:spPr>
+          <a:xfrm>
+            <a:off x="26951025" y="5394960"/>
+            <a:ext cx="2583180" cy="1143000"/>
+          </a:xfrm>
+          <a:prstGeom prst="rect">
+            <a:avLst/>
+          </a:prstGeom>
+          <a:noFill/>
+        </p:spPr>
+        <p:txBody>
+          <a:bodyPr wrap="square" anchor="ctr" lIns="73152" rIns="73152" tIns="27432" bIns="27432">
+            <a:spAutoFit/>
+          </a:bodyPr>
+          <a:lstStyle/>
+          <a:p>
+            <a:pPr algn="l">
+              <a:spcBef>
+                <a:spcPts val="0"/>
+              </a:spcBef>
+              <a:spcAft>
+                <a:spcPts val="650"/>
+              </a:spcAft>
+            </a:pPr>
+            <a:r>
+              <a:rPr sz="2100" b="1" i="0">
+                <a:solidFill>
+                  <a:srgbClr val="002060"/>
+                </a:solidFill>
+                <a:latin typeface="Times New Roman"/>
+              </a:rPr>
+              <a:t>Runs locally</a:t>
+            </a:r>
+          </a:p>
+        </p:txBody>
+      </p:sp>
+      <p:sp>
+        <p:nvSpPr>
+          <p:cNvPr id="52" name="Oval 51"/>
+          <p:cNvSpPr/>
+          <p:nvPr/>
+        </p:nvSpPr>
+        <p:spPr>
+          <a:xfrm>
+            <a:off x="777240" y="13716000"/>
+            <a:ext cx="713232" cy="713232"/>
+          </a:xfrm>
+          <a:prstGeom prst="ellipse">
+            <a:avLst/>
+          </a:prstGeom>
+          <a:solidFill>
+            <a:srgbClr val="0070C0"/>
+          </a:solidFill>
+          <a:ln>
+            <a:noFill/>
+          </a:ln>
+          <a:effectLst/>
+        </p:spPr>
+        <p:style>
+          <a:lnRef idx="1">
+            <a:schemeClr val="accent1"/>
+          </a:lnRef>
+          <a:fillRef idx="3">
+            <a:schemeClr val="accent1"/>
+          </a:fillRef>
+          <a:effectRef idx="2">
+            <a:schemeClr val="accent1"/>
+          </a:effectRef>
+          <a:fontRef idx="minor">
+            <a:schemeClr val="lt1"/>
+          </a:fontRef>
+        </p:style>
+        <p:txBody>
+          <a:bodyPr rtlCol="0" anchor="ctr" lIns="0" rIns="0" tIns="0" bIns="0"/>
+          <a:lstStyle/>
+          <a:p>
+            <a:pPr algn="ctr"/>
+            <a:r>
+              <a:rPr sz="2800" b="1" i="0">
+                <a:solidFill>
+                  <a:srgbClr val="FFFFFF"/>
+                </a:solidFill>
+                <a:latin typeface="Times New Roman"/>
+              </a:rPr>
+              <a:t>1</a:t>
+            </a:r>
+          </a:p>
+        </p:txBody>
+      </p:sp>
+      <p:sp>
+        <p:nvSpPr>
+          <p:cNvPr id="53" name="TextBox 52"/>
+          <p:cNvSpPr txBox="1"/>
+          <p:nvPr/>
+        </p:nvSpPr>
+        <p:spPr>
+          <a:xfrm>
+            <a:off x="1691639" y="13642848"/>
+            <a:ext cx="13121640" cy="868680"/>
+          </a:xfrm>
+          <a:prstGeom prst="rect">
+            <a:avLst/>
+          </a:prstGeom>
+          <a:noFill/>
+        </p:spPr>
+        <p:txBody>
+          <a:bodyPr wrap="square" anchor="ctr" lIns="73152" rIns="73152" tIns="27432" bIns="27432">
+            <a:spAutoFit/>
+          </a:bodyPr>
+          <a:lstStyle/>
+          <a:p>
+            <a:pPr algn="l">
+              <a:spcBef>
+                <a:spcPts val="0"/>
+              </a:spcBef>
+              <a:spcAft>
+                <a:spcPts val="675"/>
+              </a:spcAft>
+            </a:pPr>
+            <a:r>
+              <a:rPr sz="2700" b="0" i="0">
+                <a:solidFill>
+                  <a:srgbClr val="1F2937"/>
+                </a:solidFill>
+                <a:latin typeface="Times New Roman"/>
+              </a:rPr>
+              <a:t>Reproduce CodeS-1B on Spider within the ±5–10% tolerance, logging every run.</a:t>
+            </a:r>
+          </a:p>
+        </p:txBody>
+      </p:sp>
+      <p:sp>
+        <p:nvSpPr>
+          <p:cNvPr id="54" name="Oval 53"/>
+          <p:cNvSpPr/>
+          <p:nvPr/>
+        </p:nvSpPr>
+        <p:spPr>
+          <a:xfrm>
+            <a:off x="777240" y="14648688"/>
+            <a:ext cx="713232" cy="713232"/>
+          </a:xfrm>
+          <a:prstGeom prst="ellipse">
+            <a:avLst/>
+          </a:prstGeom>
+          <a:solidFill>
+            <a:srgbClr val="2E7D32"/>
+          </a:solidFill>
+          <a:ln>
+            <a:noFill/>
+          </a:ln>
+          <a:effectLst/>
+        </p:spPr>
+        <p:style>
+          <a:lnRef idx="1">
+            <a:schemeClr val="accent1"/>
+          </a:lnRef>
+          <a:fillRef idx="3">
+            <a:schemeClr val="accent1"/>
+          </a:fillRef>
+          <a:effectRef idx="2">
+            <a:schemeClr val="accent1"/>
+          </a:effectRef>
+          <a:fontRef idx="minor">
+            <a:schemeClr val="lt1"/>
+          </a:fontRef>
+        </p:style>
+        <p:txBody>
+          <a:bodyPr rtlCol="0" anchor="ctr" lIns="0" rIns="0" tIns="0" bIns="0"/>
+          <a:lstStyle/>
+          <a:p>
+            <a:pPr algn="ctr"/>
+            <a:r>
+              <a:rPr sz="2800" b="1" i="0">
+                <a:solidFill>
+                  <a:srgbClr val="FFFFFF"/>
+                </a:solidFill>
+                <a:latin typeface="Times New Roman"/>
+              </a:rPr>
+              <a:t>2</a:t>
+            </a:r>
+          </a:p>
+        </p:txBody>
+      </p:sp>
+      <p:sp>
+        <p:nvSpPr>
+          <p:cNvPr id="55" name="TextBox 54"/>
+          <p:cNvSpPr txBox="1"/>
+          <p:nvPr/>
+        </p:nvSpPr>
+        <p:spPr>
+          <a:xfrm>
+            <a:off x="1691639" y="14575536"/>
+            <a:ext cx="13121640" cy="868680"/>
+          </a:xfrm>
+          <a:prstGeom prst="rect">
+            <a:avLst/>
+          </a:prstGeom>
+          <a:noFill/>
+        </p:spPr>
+        <p:txBody>
+          <a:bodyPr wrap="square" anchor="ctr" lIns="73152" rIns="73152" tIns="27432" bIns="27432">
+            <a:spAutoFit/>
+          </a:bodyPr>
+          <a:lstStyle/>
+          <a:p>
+            <a:pPr algn="l">
+              <a:spcBef>
+                <a:spcPts val="0"/>
+              </a:spcBef>
+              <a:spcAft>
+                <a:spcPts val="675"/>
+              </a:spcAft>
+            </a:pPr>
+            <a:r>
+              <a:rPr sz="2700" b="0" i="0">
+                <a:solidFill>
+                  <a:srgbClr val="1F2937"/>
+                </a:solidFill>
+                <a:latin typeface="Times New Roman"/>
+              </a:rPr>
+              <a:t>Ablate the CodeS pipeline to find which components matter.</a:t>
+            </a:r>
+          </a:p>
+        </p:txBody>
+      </p:sp>
+      <p:sp>
+        <p:nvSpPr>
+          <p:cNvPr id="56" name="Oval 55"/>
+          <p:cNvSpPr/>
+          <p:nvPr/>
+        </p:nvSpPr>
+        <p:spPr>
+          <a:xfrm>
+            <a:off x="777240" y="15581376"/>
+            <a:ext cx="713232" cy="713232"/>
+          </a:xfrm>
+          <a:prstGeom prst="ellipse">
+            <a:avLst/>
+          </a:prstGeom>
+          <a:solidFill>
+            <a:srgbClr val="FFC000"/>
+          </a:solidFill>
+          <a:ln>
+            <a:noFill/>
+          </a:ln>
+          <a:effectLst/>
+        </p:spPr>
+        <p:style>
+          <a:lnRef idx="1">
+            <a:schemeClr val="accent1"/>
+          </a:lnRef>
+          <a:fillRef idx="3">
+            <a:schemeClr val="accent1"/>
+          </a:fillRef>
+          <a:effectRef idx="2">
+            <a:schemeClr val="accent1"/>
+          </a:effectRef>
+          <a:fontRef idx="minor">
+            <a:schemeClr val="lt1"/>
+          </a:fontRef>
+        </p:style>
+        <p:txBody>
+          <a:bodyPr rtlCol="0" anchor="ctr" lIns="0" rIns="0" tIns="0" bIns="0"/>
+          <a:lstStyle/>
+          <a:p>
+            <a:pPr algn="ctr"/>
+            <a:r>
+              <a:rPr sz="2800" b="1" i="0">
+                <a:solidFill>
+                  <a:srgbClr val="FFFFFF"/>
+                </a:solidFill>
+                <a:latin typeface="Times New Roman"/>
+              </a:rPr>
+              <a:t>3</a:t>
+            </a:r>
+          </a:p>
+        </p:txBody>
+      </p:sp>
+      <p:sp>
+        <p:nvSpPr>
+          <p:cNvPr id="57" name="TextBox 56"/>
+          <p:cNvSpPr txBox="1"/>
+          <p:nvPr/>
+        </p:nvSpPr>
+        <p:spPr>
+          <a:xfrm>
+            <a:off x="1691639" y="15508224"/>
+            <a:ext cx="13121640" cy="868680"/>
+          </a:xfrm>
+          <a:prstGeom prst="rect">
+            <a:avLst/>
+          </a:prstGeom>
+          <a:noFill/>
+        </p:spPr>
+        <p:txBody>
+          <a:bodyPr wrap="square" anchor="ctr" lIns="73152" rIns="73152" tIns="27432" bIns="27432">
+            <a:spAutoFit/>
+          </a:bodyPr>
+          <a:lstStyle/>
+          <a:p>
+            <a:pPr algn="l">
+              <a:spcBef>
+                <a:spcPts val="0"/>
+              </a:spcBef>
+              <a:spcAft>
+                <a:spcPts val="675"/>
+              </a:spcAft>
+            </a:pPr>
+            <a:r>
+              <a:rPr sz="2700" b="0" i="0">
+                <a:solidFill>
+                  <a:srgbClr val="1F2937"/>
+                </a:solidFill>
+                <a:latin typeface="Times New Roman"/>
+              </a:rPr>
+              <a:t>Make the system say when it is unsure: confidence-aware abstention, tested statistically.</a:t>
+            </a:r>
+          </a:p>
+        </p:txBody>
+      </p:sp>
+      <p:sp>
+        <p:nvSpPr>
+          <p:cNvPr id="58" name="Oval 57"/>
+          <p:cNvSpPr/>
+          <p:nvPr/>
+        </p:nvSpPr>
+        <p:spPr>
+          <a:xfrm>
+            <a:off x="777240" y="16514063"/>
+            <a:ext cx="713232" cy="713232"/>
+          </a:xfrm>
+          <a:prstGeom prst="ellipse">
+            <a:avLst/>
+          </a:prstGeom>
+          <a:solidFill>
+            <a:srgbClr val="C00000"/>
+          </a:solidFill>
+          <a:ln>
+            <a:noFill/>
+          </a:ln>
+          <a:effectLst/>
+        </p:spPr>
+        <p:style>
+          <a:lnRef idx="1">
+            <a:schemeClr val="accent1"/>
+          </a:lnRef>
+          <a:fillRef idx="3">
+            <a:schemeClr val="accent1"/>
+          </a:fillRef>
+          <a:effectRef idx="2">
+            <a:schemeClr val="accent1"/>
+          </a:effectRef>
+          <a:fontRef idx="minor">
+            <a:schemeClr val="lt1"/>
+          </a:fontRef>
+        </p:style>
+        <p:txBody>
+          <a:bodyPr rtlCol="0" anchor="ctr" lIns="0" rIns="0" tIns="0" bIns="0"/>
+          <a:lstStyle/>
+          <a:p>
+            <a:pPr algn="ctr"/>
+            <a:r>
+              <a:rPr sz="2800" b="1" i="0">
+                <a:solidFill>
+                  <a:srgbClr val="FFFFFF"/>
+                </a:solidFill>
+                <a:latin typeface="Times New Roman"/>
+              </a:rPr>
+              <a:t>4</a:t>
+            </a:r>
+          </a:p>
+        </p:txBody>
+      </p:sp>
+      <p:sp>
+        <p:nvSpPr>
+          <p:cNvPr id="59" name="TextBox 58"/>
+          <p:cNvSpPr txBox="1"/>
+          <p:nvPr/>
+        </p:nvSpPr>
+        <p:spPr>
+          <a:xfrm>
+            <a:off x="1691639" y="16440912"/>
+            <a:ext cx="13121640" cy="868680"/>
+          </a:xfrm>
+          <a:prstGeom prst="rect">
+            <a:avLst/>
+          </a:prstGeom>
+          <a:noFill/>
+        </p:spPr>
+        <p:txBody>
+          <a:bodyPr wrap="square" anchor="ctr" lIns="73152" rIns="73152" tIns="27432" bIns="27432">
+            <a:spAutoFit/>
+          </a:bodyPr>
+          <a:lstStyle/>
+          <a:p>
+            <a:pPr algn="l">
+              <a:spcBef>
+                <a:spcPts val="0"/>
+              </a:spcBef>
+              <a:spcAft>
+                <a:spcPts val="675"/>
+              </a:spcAft>
+            </a:pPr>
+            <a:r>
+              <a:rPr sz="2700" b="0" i="0">
+                <a:solidFill>
+                  <a:srgbClr val="1F2937"/>
+                </a:solidFill>
+                <a:latin typeface="Times New Roman"/>
+              </a:rPr>
+              <a:t>Measure the benchmark-to-reality gap on realistically worded questions.</a:t>
+            </a:r>
+          </a:p>
+        </p:txBody>
+      </p:sp>
+      <p:sp>
+        <p:nvSpPr>
+          <p:cNvPr id="60" name="Oval 59"/>
+          <p:cNvSpPr/>
+          <p:nvPr/>
+        </p:nvSpPr>
+        <p:spPr>
+          <a:xfrm>
+            <a:off x="777240" y="17446752"/>
+            <a:ext cx="713232" cy="713232"/>
+          </a:xfrm>
+          <a:prstGeom prst="ellipse">
+            <a:avLst/>
+          </a:prstGeom>
+          <a:solidFill>
+            <a:srgbClr val="7030A0"/>
+          </a:solidFill>
+          <a:ln>
+            <a:noFill/>
+          </a:ln>
+          <a:effectLst/>
+        </p:spPr>
+        <p:style>
+          <a:lnRef idx="1">
+            <a:schemeClr val="accent1"/>
+          </a:lnRef>
+          <a:fillRef idx="3">
+            <a:schemeClr val="accent1"/>
+          </a:fillRef>
+          <a:effectRef idx="2">
+            <a:schemeClr val="accent1"/>
+          </a:effectRef>
+          <a:fontRef idx="minor">
+            <a:schemeClr val="lt1"/>
+          </a:fontRef>
+        </p:style>
+        <p:txBody>
+          <a:bodyPr rtlCol="0" anchor="ctr" lIns="0" rIns="0" tIns="0" bIns="0"/>
+          <a:lstStyle/>
+          <a:p>
+            <a:pPr algn="ctr"/>
+            <a:r>
+              <a:rPr sz="2800" b="1" i="0">
+                <a:solidFill>
+                  <a:srgbClr val="FFFFFF"/>
+                </a:solidFill>
+                <a:latin typeface="Times New Roman"/>
+              </a:rPr>
+              <a:t>5</a:t>
+            </a:r>
+          </a:p>
+        </p:txBody>
+      </p:sp>
+      <p:sp>
+        <p:nvSpPr>
+          <p:cNvPr id="61" name="TextBox 60"/>
+          <p:cNvSpPr txBox="1"/>
+          <p:nvPr/>
+        </p:nvSpPr>
+        <p:spPr>
+          <a:xfrm>
+            <a:off x="1691639" y="17373600"/>
+            <a:ext cx="13121640" cy="868680"/>
+          </a:xfrm>
+          <a:prstGeom prst="rect">
+            <a:avLst/>
+          </a:prstGeom>
+          <a:noFill/>
+        </p:spPr>
+        <p:txBody>
+          <a:bodyPr wrap="square" anchor="ctr" lIns="73152" rIns="73152" tIns="27432" bIns="27432">
+            <a:spAutoFit/>
+          </a:bodyPr>
+          <a:lstStyle/>
+          <a:p>
+            <a:pPr algn="l">
+              <a:spcBef>
+                <a:spcPts val="0"/>
+              </a:spcBef>
+              <a:spcAft>
+                <a:spcPts val="675"/>
+              </a:spcAft>
+            </a:pPr>
+            <a:r>
+              <a:rPr sz="2700" b="0" i="0">
+                <a:solidFill>
+                  <a:srgbClr val="1F2937"/>
+                </a:solidFill>
+                <a:latin typeface="Times New Roman"/>
+              </a:rPr>
+              <a:t>Deliver a working desktop application that runs fully locally.</a:t>
+            </a:r>
+          </a:p>
+        </p:txBody>
+      </p:sp>
+      <p:sp>
+        <p:nvSpPr>
+          <p:cNvPr id="62" name="Rectangle 61"/>
+          <p:cNvSpPr/>
+          <p:nvPr/>
+        </p:nvSpPr>
+        <p:spPr>
+          <a:xfrm>
+            <a:off x="640080" y="18562320"/>
+            <a:ext cx="14264640" cy="731520"/>
+          </a:xfrm>
+          <a:prstGeom prst="rect">
+            <a:avLst/>
+          </a:prstGeom>
+          <a:solidFill>
+            <a:srgbClr val="C00000"/>
+          </a:solidFill>
+          <a:ln>
+            <a:noFill/>
+          </a:ln>
+          <a:effectLst/>
+        </p:spPr>
+        <p:style>
+          <a:lnRef idx="1">
+            <a:schemeClr val="accent1"/>
+          </a:lnRef>
+          <a:fillRef idx="3">
+            <a:schemeClr val="accent1"/>
+          </a:fillRef>
+          <a:effectRef idx="2">
+            <a:schemeClr val="accent1"/>
+          </a:effectRef>
+          <a:fontRef idx="minor">
+            <a:schemeClr val="lt1"/>
+          </a:fontRef>
+        </p:style>
+        <p:txBody>
+          <a:bodyPr rtlCol="0" anchor="ctr"/>
+          <a:lstStyle/>
+          <a:p>
+            <a:pPr algn="ctr"/>
+            <a:r>
+              <a:rPr sz="3900" b="1" i="0" u="sng">
+                <a:solidFill>
+                  <a:srgbClr val="FFFFFF"/>
+                </a:solidFill>
+                <a:latin typeface="Times New Roman"/>
+              </a:rPr>
+              <a:t>Key Innovations &amp; Contributions</a:t>
+            </a:r>
+          </a:p>
+        </p:txBody>
+      </p:sp>
+      <p:pic>
+        <p:nvPicPr>
+          <p:cNvPr id="63" name="Picture 62" descr="shield-check_blue.png"/>
+          <p:cNvPicPr>
+            <a:picLocks noChangeAspect="1"/>
+          </p:cNvPicPr>
+          <p:nvPr/>
+        </p:nvPicPr>
+        <p:blipFill>
+          <a:blip r:embed="rId12"/>
+          <a:stretch>
+            <a:fillRect/>
+          </a:stretch>
+        </p:blipFill>
+        <p:spPr>
+          <a:xfrm>
+            <a:off x="822959" y="19659600"/>
+            <a:ext cx="868680" cy="868680"/>
+          </a:xfrm>
+          <a:prstGeom prst="rect">
+            <a:avLst/>
+          </a:prstGeom>
+        </p:spPr>
+      </p:pic>
+      <p:sp>
+        <p:nvSpPr>
+          <p:cNvPr id="64" name="TextBox 63"/>
+          <p:cNvSpPr txBox="1"/>
+          <p:nvPr/>
+        </p:nvSpPr>
+        <p:spPr>
+          <a:xfrm>
+            <a:off x="1920239" y="19522440"/>
+            <a:ext cx="12893040" cy="1554480"/>
+          </a:xfrm>
+          <a:prstGeom prst="rect">
+            <a:avLst/>
+          </a:prstGeom>
+          <a:noFill/>
+        </p:spPr>
+        <p:txBody>
+          <a:bodyPr wrap="square" anchor="t" lIns="73152" rIns="73152" tIns="27432" bIns="27432">
+            <a:spAutoFit/>
+          </a:bodyPr>
+          <a:lstStyle/>
+          <a:p>
+            <a:pPr algn="l">
+              <a:spcBef>
+                <a:spcPts val="0"/>
+              </a:spcBef>
+              <a:spcAft>
+                <a:spcPts val="130"/>
+              </a:spcAft>
+            </a:pPr>
+            <a:r>
+              <a:rPr sz="2800" b="1" i="0">
+                <a:solidFill>
+                  <a:srgbClr val="002060"/>
+                </a:solidFill>
+                <a:latin typeface="Times New Roman"/>
+              </a:rPr>
+              <a:t>Confidence-aware abstention</a:t>
+            </a:r>
+          </a:p>
+          <a:p>
+            <a:pPr algn="l">
+              <a:spcBef>
+                <a:spcPts val="0"/>
+              </a:spcBef>
+              <a:spcAft>
+                <a:spcPts val="130"/>
+              </a:spcAft>
+            </a:pPr>
+            <a:r>
+              <a:rPr sz="2500" b="0" i="0">
+                <a:solidFill>
+                  <a:srgbClr val="1F2937"/>
+                </a:solidFill>
+                <a:latin typeface="Times New Roman"/>
+              </a:rPr>
+              <a:t>Runs every candidate query, counts how many agree, and asks “Did you mean…?” when they don't.</a:t>
+            </a:r>
+          </a:p>
+        </p:txBody>
+      </p:sp>
+      <p:pic>
+        <p:nvPicPr>
+          <p:cNvPr id="65" name="Picture 64" descr="badge-check_blue.png"/>
+          <p:cNvPicPr>
+            <a:picLocks noChangeAspect="1"/>
+          </p:cNvPicPr>
+          <p:nvPr/>
+        </p:nvPicPr>
+        <p:blipFill>
+          <a:blip r:embed="rId13"/>
+          <a:stretch>
+            <a:fillRect/>
+          </a:stretch>
+        </p:blipFill>
+        <p:spPr>
+          <a:xfrm>
+            <a:off x="822959" y="21259800"/>
+            <a:ext cx="868680" cy="868680"/>
+          </a:xfrm>
+          <a:prstGeom prst="rect">
+            <a:avLst/>
+          </a:prstGeom>
+        </p:spPr>
+      </p:pic>
+      <p:sp>
+        <p:nvSpPr>
+          <p:cNvPr id="66" name="TextBox 65"/>
+          <p:cNvSpPr txBox="1"/>
+          <p:nvPr/>
+        </p:nvSpPr>
+        <p:spPr>
+          <a:xfrm>
+            <a:off x="1920239" y="21122640"/>
+            <a:ext cx="12893040" cy="1554480"/>
+          </a:xfrm>
+          <a:prstGeom prst="rect">
+            <a:avLst/>
+          </a:prstGeom>
+          <a:noFill/>
+        </p:spPr>
+        <p:txBody>
+          <a:bodyPr wrap="square" anchor="t" lIns="73152" rIns="73152" tIns="27432" bIns="27432">
+            <a:spAutoFit/>
+          </a:bodyPr>
+          <a:lstStyle/>
+          <a:p>
+            <a:pPr algn="l">
+              <a:spcBef>
+                <a:spcPts val="0"/>
+              </a:spcBef>
+              <a:spcAft>
+                <a:spcPts val="130"/>
+              </a:spcAft>
+            </a:pPr>
+            <a:r>
+              <a:rPr sz="2800" b="1" i="0">
+                <a:solidFill>
+                  <a:srgbClr val="002060"/>
+                </a:solidFill>
+                <a:latin typeface="Times New Roman"/>
+              </a:rPr>
+              <a:t>Faithful, audited reproduction</a:t>
+            </a:r>
+          </a:p>
+          <a:p>
+            <a:pPr algn="l">
+              <a:spcBef>
+                <a:spcPts val="0"/>
+              </a:spcBef>
+              <a:spcAft>
+                <a:spcPts val="130"/>
+              </a:spcAft>
+            </a:pPr>
+            <a:r>
+              <a:rPr sz="2500" b="0" i="0">
+                <a:solidFill>
+                  <a:srgbClr val="1F2937"/>
+                </a:solidFill>
+                <a:latin typeface="Times New Roman"/>
+              </a:rPr>
+              <a:t>77.8% vs 77.9% with the official evaluator, after an audit that fixed our own scoring and a value-retriever bug.</a:t>
+            </a:r>
+          </a:p>
+        </p:txBody>
+      </p:sp>
+      <p:pic>
+        <p:nvPicPr>
+          <p:cNvPr id="67" name="Picture 66" descr="refresh-cw_blue.png"/>
+          <p:cNvPicPr>
+            <a:picLocks noChangeAspect="1"/>
+          </p:cNvPicPr>
+          <p:nvPr/>
+        </p:nvPicPr>
+        <p:blipFill>
+          <a:blip r:embed="rId14"/>
+          <a:stretch>
+            <a:fillRect/>
+          </a:stretch>
+        </p:blipFill>
+        <p:spPr>
+          <a:xfrm>
+            <a:off x="822959" y="22860000"/>
+            <a:ext cx="868680" cy="868680"/>
+          </a:xfrm>
+          <a:prstGeom prst="rect">
+            <a:avLst/>
+          </a:prstGeom>
+        </p:spPr>
+      </p:pic>
+      <p:sp>
+        <p:nvSpPr>
+          <p:cNvPr id="68" name="TextBox 67"/>
+          <p:cNvSpPr txBox="1"/>
+          <p:nvPr/>
+        </p:nvSpPr>
+        <p:spPr>
+          <a:xfrm>
+            <a:off x="1920239" y="22722840"/>
+            <a:ext cx="12893040" cy="1554480"/>
+          </a:xfrm>
+          <a:prstGeom prst="rect">
+            <a:avLst/>
+          </a:prstGeom>
+          <a:noFill/>
+        </p:spPr>
+        <p:txBody>
+          <a:bodyPr wrap="square" anchor="t" lIns="73152" rIns="73152" tIns="27432" bIns="27432">
+            <a:spAutoFit/>
+          </a:bodyPr>
+          <a:lstStyle/>
+          <a:p>
+            <a:pPr algn="l">
+              <a:spcBef>
+                <a:spcPts val="0"/>
+              </a:spcBef>
+              <a:spcAft>
+                <a:spcPts val="130"/>
+              </a:spcAft>
+            </a:pPr>
+            <a:r>
+              <a:rPr sz="2800" b="1" i="0">
+                <a:solidFill>
+                  <a:srgbClr val="002060"/>
+                </a:solidFill>
+                <a:latin typeface="Times New Roman"/>
+              </a:rPr>
+              <a:t>Execution-guided self-correction</a:t>
+            </a:r>
+          </a:p>
+          <a:p>
+            <a:pPr algn="l">
+              <a:spcBef>
+                <a:spcPts val="0"/>
+              </a:spcBef>
+              <a:spcAft>
+                <a:spcPts val="130"/>
+              </a:spcAft>
+            </a:pPr>
+            <a:r>
+              <a:rPr sz="2500" b="0" i="0">
+                <a:solidFill>
+                  <a:srgbClr val="1F2937"/>
+                </a:solidFill>
+                <a:latin typeface="Times New Roman"/>
+              </a:rPr>
+              <a:t>Failed queries go back to the model with the database error; measured honestly (77.76 → 77.85%).</a:t>
+            </a:r>
+          </a:p>
+        </p:txBody>
+      </p:sp>
+      <p:pic>
+        <p:nvPicPr>
+          <p:cNvPr id="69" name="Picture 68" descr="monitor-smartphone_blue.png"/>
+          <p:cNvPicPr>
+            <a:picLocks noChangeAspect="1"/>
+          </p:cNvPicPr>
+          <p:nvPr/>
+        </p:nvPicPr>
+        <p:blipFill>
+          <a:blip r:embed="rId15"/>
+          <a:stretch>
+            <a:fillRect/>
+          </a:stretch>
+        </p:blipFill>
+        <p:spPr>
+          <a:xfrm>
+            <a:off x="822959" y="24460200"/>
+            <a:ext cx="868680" cy="868680"/>
+          </a:xfrm>
+          <a:prstGeom prst="rect">
+            <a:avLst/>
+          </a:prstGeom>
+        </p:spPr>
+      </p:pic>
+      <p:sp>
+        <p:nvSpPr>
+          <p:cNvPr id="70" name="TextBox 69"/>
+          <p:cNvSpPr txBox="1"/>
+          <p:nvPr/>
+        </p:nvSpPr>
+        <p:spPr>
+          <a:xfrm>
+            <a:off x="1920239" y="24323040"/>
+            <a:ext cx="12893040" cy="1554480"/>
+          </a:xfrm>
+          <a:prstGeom prst="rect">
+            <a:avLst/>
+          </a:prstGeom>
+          <a:noFill/>
+        </p:spPr>
+        <p:txBody>
+          <a:bodyPr wrap="square" anchor="t" lIns="73152" rIns="73152" tIns="27432" bIns="27432">
+            <a:spAutoFit/>
+          </a:bodyPr>
+          <a:lstStyle/>
+          <a:p>
+            <a:pPr algn="l">
+              <a:spcBef>
+                <a:spcPts val="0"/>
+              </a:spcBef>
+              <a:spcAft>
+                <a:spcPts val="130"/>
+              </a:spcAft>
+            </a:pPr>
+            <a:r>
+              <a:rPr sz="2800" b="1" i="0">
+                <a:solidFill>
+                  <a:srgbClr val="002060"/>
+                </a:solidFill>
+                <a:latin typeface="Times New Roman"/>
+              </a:rPr>
+              <a:t>Local desktop application</a:t>
+            </a:r>
+          </a:p>
+          <a:p>
+            <a:pPr algn="l">
+              <a:spcBef>
+                <a:spcPts val="0"/>
+              </a:spcBef>
+              <a:spcAft>
+                <a:spcPts val="130"/>
+              </a:spcAft>
+            </a:pPr>
+            <a:r>
+              <a:rPr sz="2500" b="0" i="0">
+                <a:solidFill>
+                  <a:srgbClr val="1F2937"/>
+                </a:solidFill>
+                <a:latin typeface="Times New Roman"/>
+              </a:rPr>
+              <a:t>Chats, schema map, charts, SQLite / PostgreSQL / MySQL — schema and data never leave the computer.</a:t>
+            </a:r>
+          </a:p>
+        </p:txBody>
+      </p:sp>
+      <p:sp>
+        <p:nvSpPr>
+          <p:cNvPr id="71" name="Rectangle 70"/>
+          <p:cNvSpPr/>
+          <p:nvPr/>
+        </p:nvSpPr>
+        <p:spPr>
+          <a:xfrm>
+            <a:off x="640080" y="26060400"/>
+            <a:ext cx="14264640" cy="731520"/>
+          </a:xfrm>
+          <a:prstGeom prst="rect">
+            <a:avLst/>
+          </a:prstGeom>
+          <a:solidFill>
+            <a:srgbClr val="C00000"/>
+          </a:solidFill>
+          <a:ln>
+            <a:noFill/>
+          </a:ln>
+          <a:effectLst/>
+        </p:spPr>
+        <p:style>
+          <a:lnRef idx="1">
+            <a:schemeClr val="accent1"/>
+          </a:lnRef>
+          <a:fillRef idx="3">
+            <a:schemeClr val="accent1"/>
+          </a:fillRef>
+          <a:effectRef idx="2">
+            <a:schemeClr val="accent1"/>
+          </a:effectRef>
+          <a:fontRef idx="minor">
+            <a:schemeClr val="lt1"/>
+          </a:fontRef>
+        </p:style>
+        <p:txBody>
+          <a:bodyPr rtlCol="0" anchor="ctr"/>
+          <a:lstStyle/>
+          <a:p>
+            <a:pPr algn="ctr"/>
+            <a:r>
+              <a:rPr sz="3900" b="1" i="0" u="sng">
+                <a:solidFill>
+                  <a:srgbClr val="FFFFFF"/>
+                </a:solidFill>
+                <a:latin typeface="Times New Roman"/>
+              </a:rPr>
+              <a:t>The Application</a:t>
+            </a:r>
+          </a:p>
+        </p:txBody>
+      </p:sp>
+      <p:pic>
+        <p:nvPicPr>
+          <p:cNvPr id="72" name="Picture 71" descr="app_not_sure.png"/>
+          <p:cNvPicPr>
+            <a:picLocks noChangeAspect="1"/>
+          </p:cNvPicPr>
+          <p:nvPr/>
+        </p:nvPicPr>
+        <p:blipFill>
+          <a:blip r:embed="rId16"/>
+          <a:stretch>
+            <a:fillRect/>
+          </a:stretch>
+        </p:blipFill>
+        <p:spPr>
+          <a:xfrm>
+            <a:off x="2468880" y="26974800"/>
+            <a:ext cx="10607040" cy="6629400"/>
+          </a:xfrm>
+          <a:prstGeom prst="rect">
+            <a:avLst/>
+          </a:prstGeom>
+        </p:spPr>
+      </p:pic>
+      <p:sp>
+        <p:nvSpPr>
+          <p:cNvPr id="73" name="TextBox 72"/>
+          <p:cNvSpPr txBox="1"/>
+          <p:nvPr/>
+        </p:nvSpPr>
+        <p:spPr>
+          <a:xfrm>
+            <a:off x="640080" y="33695640"/>
+            <a:ext cx="14264640" cy="548640"/>
+          </a:xfrm>
+          <a:prstGeom prst="rect">
+            <a:avLst/>
+          </a:prstGeom>
+          <a:noFill/>
+        </p:spPr>
+        <p:txBody>
+          <a:bodyPr wrap="square" anchor="t" lIns="73152" rIns="73152" tIns="27432" bIns="27432">
+            <a:spAutoFit/>
+          </a:bodyPr>
+          <a:lstStyle/>
+          <a:p>
+            <a:pPr algn="ctr">
+              <a:spcBef>
+                <a:spcPts val="0"/>
+              </a:spcBef>
+              <a:spcAft>
+                <a:spcPts val="650"/>
+              </a:spcAft>
+            </a:pPr>
+            <a:r>
+              <a:rPr sz="2100" b="0" i="1">
+                <a:solidFill>
+                  <a:srgbClr val="4B5563"/>
+                </a:solidFill>
+                <a:latin typeface="Times New Roman"/>
+              </a:rPr>
+              <a:t>The four candidate queries disagree, so QueryGenie asks which reading was meant instead of guessing.</a:t>
+            </a:r>
+          </a:p>
+        </p:txBody>
+      </p:sp>
+      <p:pic>
+        <p:nvPicPr>
+          <p:cNvPr id="74" name="Picture 73" descr="final_pipeline.png"/>
+          <p:cNvPicPr>
+            <a:picLocks noChangeAspect="1"/>
+          </p:cNvPicPr>
+          <p:nvPr/>
+        </p:nvPicPr>
+        <p:blipFill>
+          <a:blip r:embed="rId17"/>
+          <a:stretch>
+            <a:fillRect/>
+          </a:stretch>
+        </p:blipFill>
+        <p:spPr>
+          <a:xfrm>
+            <a:off x="15361920" y="7726679"/>
+            <a:ext cx="14264640" cy="7667244"/>
+          </a:xfrm>
+          <a:prstGeom prst="rect">
+            <a:avLst/>
+          </a:prstGeom>
+        </p:spPr>
+      </p:pic>
+      <p:sp>
+        <p:nvSpPr>
+          <p:cNvPr id="75" name="TextBox 74"/>
+          <p:cNvSpPr txBox="1"/>
+          <p:nvPr/>
+        </p:nvSpPr>
+        <p:spPr>
+          <a:xfrm>
+            <a:off x="15361920" y="15622524"/>
+            <a:ext cx="14264640" cy="548640"/>
+          </a:xfrm>
+          <a:prstGeom prst="rect">
+            <a:avLst/>
+          </a:prstGeom>
+          <a:noFill/>
+        </p:spPr>
+        <p:txBody>
+          <a:bodyPr wrap="square" anchor="t" lIns="73152" rIns="73152" tIns="27432" bIns="27432">
+            <a:spAutoFit/>
+          </a:bodyPr>
+          <a:lstStyle/>
+          <a:p>
+            <a:pPr algn="l">
+              <a:spcBef>
+                <a:spcPts val="0"/>
+              </a:spcBef>
+              <a:spcAft>
+                <a:spcPts val="650"/>
+              </a:spcAft>
+            </a:pPr>
+            <a:r>
+              <a:rPr sz="2500" b="1" i="0">
+                <a:solidFill>
+                  <a:srgbClr val="002060"/>
+                </a:solidFill>
+                <a:latin typeface="Times New Roman"/>
+              </a:rPr>
+              <a:t>Datasets — all from Hugging Face (approved source; no Kaggle)</a:t>
+            </a:r>
+          </a:p>
+        </p:txBody>
+      </p:sp>
+      <p:graphicFrame>
+        <p:nvGraphicFramePr>
+          <p:cNvPr id="76" name="Table 75"/>
+          <p:cNvGraphicFramePr>
+            <a:graphicFrameLocks noGrp="1"/>
+          </p:cNvGraphicFramePr>
+          <p:nvPr/>
+        </p:nvGraphicFramePr>
+        <p:xfrm>
+          <a:off x="15361920" y="16216884"/>
+          <a:ext cx="14264640" cy="2194560"/>
+        </p:xfrm>
+        <a:graphic>
+          <a:graphicData uri="http://schemas.openxmlformats.org/drawingml/2006/table">
+            <a:tbl>
+              <a:tblPr firstRow="1" bandRow="1">
+                <a:tableStyleId>{5C22544A-7EE6-4342-B048-85BDC9FD1C3A}</a:tableStyleId>
+              </a:tblPr>
+              <a:tblGrid>
+                <a:gridCol w="4937760"/>
+                <a:gridCol w="3108960"/>
+                <a:gridCol w="6217920"/>
+              </a:tblGrid>
+              <a:tr h="548640">
+                <a:tc>
+                  <a:txBody>
+                    <a:bodyPr/>
+                    <a:lstStyle/>
+                    <a:p>
+                      <a:r>
+                        <a:rPr sz="2100" b="1">
+                          <a:solidFill>
+                            <a:srgbClr val="FFFFFF"/>
+                          </a:solidFill>
+                          <a:latin typeface="Times New Roman"/>
+                        </a:rPr>
+                        <a:t>Set</a:t>
+                      </a:r>
+                    </a:p>
+                  </a:txBody>
+                  <a:tcPr>
+                    <a:solidFill>
+                      <a:srgbClr val="002060"/>
+                    </a:solidFill>
+                  </a:tcPr>
+                </a:tc>
+                <a:tc>
+                  <a:txBody>
+                    <a:bodyPr/>
+                    <a:lstStyle/>
+                    <a:p>
+                      <a:r>
+                        <a:rPr sz="2100" b="1">
+                          <a:solidFill>
+                            <a:srgbClr val="FFFFFF"/>
+                          </a:solidFill>
+                          <a:latin typeface="Times New Roman"/>
+                        </a:rPr>
+                        <a:t>Questions</a:t>
+                      </a:r>
+                    </a:p>
+                  </a:txBody>
+                  <a:tcPr>
+                    <a:solidFill>
+                      <a:srgbClr val="002060"/>
+                    </a:solidFill>
+                  </a:tcPr>
+                </a:tc>
+                <a:tc>
+                  <a:txBody>
+                    <a:bodyPr/>
+                    <a:lstStyle/>
+                    <a:p>
+                      <a:r>
+                        <a:rPr sz="2100" b="1">
+                          <a:solidFill>
+                            <a:srgbClr val="FFFFFF"/>
+                          </a:solidFill>
+                          <a:latin typeface="Times New Roman"/>
+                        </a:rPr>
+                        <a:t>Used for</a:t>
+                      </a:r>
+                    </a:p>
+                  </a:txBody>
+                  <a:tcPr>
+                    <a:solidFill>
+                      <a:srgbClr val="002060"/>
+                    </a:solidFill>
+                  </a:tcPr>
+                </a:tc>
+              </a:tr>
+              <a:tr h="548640">
+                <a:tc>
+                  <a:txBody>
+                    <a:bodyPr/>
+                    <a:lstStyle/>
+                    <a:p>
+                      <a:r>
+                        <a:rPr sz="2100" b="0">
+                          <a:solidFill>
+                            <a:srgbClr val="1F2937"/>
+                          </a:solidFill>
+                          <a:latin typeface="Times New Roman"/>
+                        </a:rPr>
+                        <a:t>Spider dev</a:t>
+                      </a:r>
+                    </a:p>
+                  </a:txBody>
+                  <a:tcPr>
+                    <a:solidFill>
+                      <a:srgbClr val="EEF3F9"/>
+                    </a:solidFill>
+                  </a:tcPr>
+                </a:tc>
+                <a:tc>
+                  <a:txBody>
+                    <a:bodyPr/>
+                    <a:lstStyle/>
+                    <a:p>
+                      <a:r>
+                        <a:rPr sz="2100" b="0">
+                          <a:solidFill>
+                            <a:srgbClr val="1F2937"/>
+                          </a:solidFill>
+                          <a:latin typeface="Times New Roman"/>
+                        </a:rPr>
+                        <a:t>1,034 · 20 databases</a:t>
+                      </a:r>
+                    </a:p>
+                  </a:txBody>
+                  <a:tcPr>
+                    <a:solidFill>
+                      <a:srgbClr val="EEF3F9"/>
+                    </a:solidFill>
+                  </a:tcPr>
+                </a:tc>
+                <a:tc>
+                  <a:txBody>
+                    <a:bodyPr/>
+                    <a:lstStyle/>
+                    <a:p>
+                      <a:r>
+                        <a:rPr sz="2100" b="0">
+                          <a:solidFill>
+                            <a:srgbClr val="1F2937"/>
+                          </a:solidFill>
+                          <a:latin typeface="Times New Roman"/>
+                        </a:rPr>
+                        <a:t>Reproduction, ablation, enhancement</a:t>
+                      </a:r>
+                    </a:p>
+                  </a:txBody>
+                  <a:tcPr>
+                    <a:solidFill>
+                      <a:srgbClr val="EEF3F9"/>
+                    </a:solidFill>
+                  </a:tcPr>
+                </a:tc>
+              </a:tr>
+              <a:tr h="548640">
+                <a:tc>
+                  <a:txBody>
+                    <a:bodyPr/>
+                    <a:lstStyle/>
+                    <a:p>
+                      <a:r>
+                        <a:rPr sz="2100" b="0">
+                          <a:solidFill>
+                            <a:srgbClr val="1F2937"/>
+                          </a:solidFill>
+                          <a:latin typeface="Times New Roman"/>
+                        </a:rPr>
+                        <a:t>Spider-Realistic</a:t>
+                      </a:r>
+                    </a:p>
+                  </a:txBody>
+                  <a:tcPr>
+                    <a:solidFill>
+                      <a:srgbClr val="FFFFFF"/>
+                    </a:solidFill>
+                  </a:tcPr>
+                </a:tc>
+                <a:tc>
+                  <a:txBody>
+                    <a:bodyPr/>
+                    <a:lstStyle/>
+                    <a:p>
+                      <a:r>
+                        <a:rPr sz="2100" b="0">
+                          <a:solidFill>
+                            <a:srgbClr val="1F2937"/>
+                          </a:solidFill>
+                          <a:latin typeface="Times New Roman"/>
+                        </a:rPr>
+                        <a:t>508</a:t>
+                      </a:r>
+                    </a:p>
+                  </a:txBody>
+                  <a:tcPr>
+                    <a:solidFill>
+                      <a:srgbClr val="FFFFFF"/>
+                    </a:solidFill>
+                  </a:tcPr>
+                </a:tc>
+                <a:tc>
+                  <a:txBody>
+                    <a:bodyPr/>
+                    <a:lstStyle/>
+                    <a:p>
+                      <a:r>
+                        <a:rPr sz="2100" b="0">
+                          <a:solidFill>
+                            <a:srgbClr val="1F2937"/>
+                          </a:solidFill>
+                          <a:latin typeface="Times New Roman"/>
+                        </a:rPr>
+                        <a:t>Realistic wording (no column names)</a:t>
+                      </a:r>
+                    </a:p>
+                  </a:txBody>
+                  <a:tcPr>
+                    <a:solidFill>
+                      <a:srgbClr val="FFFFFF"/>
+                    </a:solidFill>
+                  </a:tcPr>
+                </a:tc>
+              </a:tr>
+              <a:tr h="548640">
+                <a:tc>
+                  <a:txBody>
+                    <a:bodyPr/>
+                    <a:lstStyle/>
+                    <a:p>
+                      <a:r>
+                        <a:rPr sz="2100" b="0">
+                          <a:solidFill>
+                            <a:srgbClr val="1F2937"/>
+                          </a:solidFill>
+                          <a:latin typeface="Times New Roman"/>
+                        </a:rPr>
+                        <a:t>BIRD Mini-Dev</a:t>
+                      </a:r>
+                    </a:p>
+                  </a:txBody>
+                  <a:tcPr>
+                    <a:solidFill>
+                      <a:srgbClr val="EEF3F9"/>
+                    </a:solidFill>
+                  </a:tcPr>
+                </a:tc>
+                <a:tc>
+                  <a:txBody>
+                    <a:bodyPr/>
+                    <a:lstStyle/>
+                    <a:p>
+                      <a:r>
+                        <a:rPr sz="2100" b="0">
+                          <a:solidFill>
+                            <a:srgbClr val="1F2937"/>
+                          </a:solidFill>
+                          <a:latin typeface="Times New Roman"/>
+                        </a:rPr>
+                        <a:t>500 · 11 databases</a:t>
+                      </a:r>
+                    </a:p>
+                  </a:txBody>
+                  <a:tcPr>
+                    <a:solidFill>
+                      <a:srgbClr val="EEF3F9"/>
+                    </a:solidFill>
+                  </a:tcPr>
+                </a:tc>
+                <a:tc>
+                  <a:txBody>
+                    <a:bodyPr/>
+                    <a:lstStyle/>
+                    <a:p>
+                      <a:r>
+                        <a:rPr sz="2100" b="0">
+                          <a:solidFill>
+                            <a:srgbClr val="1F2937"/>
+                          </a:solidFill>
+                          <a:latin typeface="Times New Roman"/>
+                        </a:rPr>
+                        <a:t>Real-world databases (set up; future work)</a:t>
+                      </a:r>
+                    </a:p>
+                  </a:txBody>
+                  <a:tcPr>
+                    <a:solidFill>
+                      <a:srgbClr val="EEF3F9"/>
+                    </a:solidFill>
+                  </a:tcPr>
+                </a:tc>
+              </a:tr>
+            </a:tbl>
+          </a:graphicData>
+        </a:graphic>
+      </p:graphicFrame>
+      <p:pic>
+        <p:nvPicPr>
+          <p:cNvPr id="77" name="Picture 76" descr="chart_reproduction.png"/>
+          <p:cNvPicPr>
+            <a:picLocks noChangeAspect="1"/>
+          </p:cNvPicPr>
+          <p:nvPr/>
+        </p:nvPicPr>
+        <p:blipFill>
+          <a:blip r:embed="rId18"/>
+          <a:stretch>
+            <a:fillRect/>
+          </a:stretch>
+        </p:blipFill>
+        <p:spPr>
+          <a:xfrm>
+            <a:off x="15361920" y="20345400"/>
+            <a:ext cx="7040880" cy="4446872"/>
+          </a:xfrm>
+          <a:prstGeom prst="rect">
+            <a:avLst/>
+          </a:prstGeom>
+        </p:spPr>
+      </p:pic>
+      <p:pic>
+        <p:nvPicPr>
+          <p:cNvPr id="78" name="Picture 77" descr="chart_enhancement.png"/>
+          <p:cNvPicPr>
+            <a:picLocks noChangeAspect="1"/>
+          </p:cNvPicPr>
+          <p:nvPr/>
+        </p:nvPicPr>
+        <p:blipFill>
+          <a:blip r:embed="rId19"/>
+          <a:stretch>
+            <a:fillRect/>
+          </a:stretch>
+        </p:blipFill>
+        <p:spPr>
+          <a:xfrm>
+            <a:off x="22585680" y="20345400"/>
+            <a:ext cx="7040880" cy="4446872"/>
+          </a:xfrm>
+          <a:prstGeom prst="rect">
+            <a:avLst/>
+          </a:prstGeom>
+        </p:spPr>
+      </p:pic>
+      <p:pic>
+        <p:nvPicPr>
+          <p:cNvPr id="79" name="Picture 78" descr="chart_wrong.png"/>
+          <p:cNvPicPr>
+            <a:picLocks noChangeAspect="1"/>
+          </p:cNvPicPr>
+          <p:nvPr/>
+        </p:nvPicPr>
+        <p:blipFill>
+          <a:blip r:embed="rId20"/>
+          <a:stretch>
+            <a:fillRect/>
+          </a:stretch>
+        </p:blipFill>
+        <p:spPr>
+          <a:xfrm>
+            <a:off x="15361920" y="24929431"/>
+            <a:ext cx="7040880" cy="4446872"/>
+          </a:xfrm>
+          <a:prstGeom prst="rect">
+            <a:avLst/>
+          </a:prstGeom>
+        </p:spPr>
+      </p:pic>
+      <p:pic>
+        <p:nvPicPr>
+          <p:cNvPr id="80" name="Picture 79" descr="chart_calibration.png"/>
+          <p:cNvPicPr>
+            <a:picLocks noChangeAspect="1"/>
+          </p:cNvPicPr>
+          <p:nvPr/>
+        </p:nvPicPr>
+        <p:blipFill>
+          <a:blip r:embed="rId21"/>
+          <a:stretch>
+            <a:fillRect/>
+          </a:stretch>
+        </p:blipFill>
+        <p:spPr>
+          <a:xfrm>
+            <a:off x="22585680" y="24929431"/>
+            <a:ext cx="7040880" cy="4446872"/>
+          </a:xfrm>
+          <a:prstGeom prst="rect">
+            <a:avLst/>
+          </a:prstGeom>
+        </p:spPr>
+      </p:pic>
+      <p:sp>
+        <p:nvSpPr>
+          <p:cNvPr id="81" name="Rounded Rectangle 80"/>
+          <p:cNvSpPr/>
+          <p:nvPr/>
+        </p:nvSpPr>
+        <p:spPr>
+          <a:xfrm>
+            <a:off x="15361920" y="29604903"/>
+            <a:ext cx="14264640" cy="3840480"/>
+          </a:xfrm>
+          <a:prstGeom prst="roundRect">
+            <a:avLst>
+              <a:gd name="adj" fmla="val 6000"/>
+            </a:avLst>
+          </a:prstGeom>
+          <a:solidFill>
+            <a:srgbClr val="FFF7E6"/>
+          </a:solidFill>
+          <a:ln w="19050">
+            <a:solidFill>
+              <a:srgbClr val="FFC000"/>
+            </a:solidFill>
+          </a:ln>
+          <a:effectLst/>
+        </p:spPr>
+        <p:style>
+          <a:lnRef idx="1">
+            <a:schemeClr val="accent1"/>
+          </a:lnRef>
+          <a:fillRef idx="3">
+            <a:schemeClr val="accent1"/>
+          </a:fillRef>
+          <a:effectRef idx="2">
+            <a:schemeClr val="accent1"/>
+          </a:effectRef>
+          <a:fontRef idx="minor">
+            <a:schemeClr val="lt1"/>
+          </a:fontRef>
+        </p:style>
+        <p:txBody>
+          <a:bodyPr rtlCol="0" anchor="ctr"/>
+          <a:lstStyle/>
+          <a:p>
+            <a:pPr algn="ctr"/>
+          </a:p>
+        </p:txBody>
+      </p:sp>
+      <p:sp>
+        <p:nvSpPr>
+          <p:cNvPr id="82" name="TextBox 81"/>
+          <p:cNvSpPr txBox="1"/>
+          <p:nvPr/>
+        </p:nvSpPr>
+        <p:spPr>
+          <a:xfrm>
+            <a:off x="15590520" y="29696343"/>
+            <a:ext cx="13807440" cy="3749039"/>
+          </a:xfrm>
+          <a:prstGeom prst="rect">
+            <a:avLst/>
+          </a:prstGeom>
+          <a:noFill/>
+        </p:spPr>
+        <p:txBody>
+          <a:bodyPr wrap="square" anchor="t" lIns="73152" rIns="73152" tIns="27432" bIns="27432">
+            <a:spAutoFit/>
+          </a:bodyPr>
+          <a:lstStyle/>
+          <a:p>
+            <a:pPr algn="l">
+              <a:spcBef>
+                <a:spcPts val="0"/>
+              </a:spcBef>
+              <a:spcAft>
+                <a:spcPts val="324"/>
+              </a:spcAft>
+            </a:pPr>
+            <a:r>
+              <a:rPr sz="2800" b="1" i="0">
+                <a:solidFill>
+                  <a:srgbClr val="002060"/>
+                </a:solidFill>
+                <a:latin typeface="Times New Roman"/>
+              </a:rPr>
+              <a:t>Key results</a:t>
+            </a:r>
+          </a:p>
+          <a:p>
+            <a:pPr algn="l">
+              <a:spcBef>
+                <a:spcPts val="0"/>
+              </a:spcBef>
+              <a:spcAft>
+                <a:spcPts val="324"/>
+              </a:spcAft>
+            </a:pPr>
+            <a:r>
+              <a:rPr sz="2700" b="1" i="0">
+                <a:solidFill>
+                  <a:srgbClr val="1F2937"/>
+                </a:solidFill>
+                <a:latin typeface="Times New Roman"/>
+              </a:rPr>
+              <a:t>Reproduced: </a:t>
+            </a:r>
+            <a:r>
+              <a:rPr sz="2700" b="0" i="0">
+                <a:solidFill>
+                  <a:srgbClr val="1F2937"/>
+                </a:solidFill>
+                <a:latin typeface="Times New Roman"/>
+              </a:rPr>
+              <a:t>77.8% EX on Spider (paper 77.9%), 69.5% on Spider-Realistic (paper 70.9%) — within tolerance.</a:t>
+            </a:r>
+          </a:p>
+          <a:p>
+            <a:pPr algn="l">
+              <a:spcBef>
+                <a:spcPts val="0"/>
+              </a:spcBef>
+              <a:spcAft>
+                <a:spcPts val="324"/>
+              </a:spcAft>
+            </a:pPr>
+            <a:r>
+              <a:rPr sz="2700" b="1" i="0">
+                <a:solidFill>
+                  <a:srgbClr val="1F2937"/>
+                </a:solidFill>
+                <a:latin typeface="Times New Roman"/>
+              </a:rPr>
+              <a:t>Enhanced: </a:t>
+            </a:r>
+            <a:r>
+              <a:rPr sz="2700" b="0" i="0">
+                <a:solidFill>
+                  <a:srgbClr val="1F2937"/>
+                </a:solidFill>
+                <a:latin typeface="Times New Roman"/>
+              </a:rPr>
+              <a:t>answers 90.4% of questions, correct on 83.3% (vs 77.8%); wrong answers 230 → 156.</a:t>
+            </a:r>
+          </a:p>
+          <a:p>
+            <a:pPr algn="l">
+              <a:spcBef>
+                <a:spcPts val="0"/>
+              </a:spcBef>
+              <a:spcAft>
+                <a:spcPts val="324"/>
+              </a:spcAft>
+            </a:pPr>
+            <a:r>
+              <a:rPr sz="2700" b="1" i="0">
+                <a:solidFill>
+                  <a:srgbClr val="1F2937"/>
+                </a:solidFill>
+                <a:latin typeface="Times New Roman"/>
+              </a:rPr>
+              <a:t>Significant: </a:t>
+            </a:r>
+            <a:r>
+              <a:rPr sz="2700" b="0" i="0">
+                <a:solidFill>
+                  <a:srgbClr val="1F2937"/>
+                </a:solidFill>
+                <a:latin typeface="Times New Roman"/>
+              </a:rPr>
+              <a:t>paired t-test p = 7.7×10⁻¹⁰, Wilcoxon p = 9.8×10⁻⁴, bootstrap 95% CI +4.5 to +6.7 pts.</a:t>
+            </a:r>
+          </a:p>
+          <a:p>
+            <a:pPr algn="l">
+              <a:spcBef>
+                <a:spcPts val="0"/>
+              </a:spcBef>
+              <a:spcAft>
+                <a:spcPts val="324"/>
+              </a:spcAft>
+            </a:pPr>
+            <a:r>
+              <a:rPr sz="2700" b="1" i="0">
+                <a:solidFill>
+                  <a:srgbClr val="1F2937"/>
+                </a:solidFill>
+                <a:latin typeface="Times New Roman"/>
+              </a:rPr>
+              <a:t>Robust: </a:t>
+            </a:r>
+            <a:r>
+              <a:rPr sz="2700" b="0" i="0">
+                <a:solidFill>
+                  <a:srgbClr val="1F2937"/>
+                </a:solidFill>
+                <a:latin typeface="Times New Roman"/>
+              </a:rPr>
+              <a:t>counting each different query once, it still reaches 83.5% at 90% coverage.</a:t>
+            </a:r>
+          </a:p>
+        </p:txBody>
+      </p:sp>
+      <p:sp>
+        <p:nvSpPr>
+          <p:cNvPr id="83" name="Rectangle 82"/>
+          <p:cNvSpPr/>
+          <p:nvPr/>
+        </p:nvSpPr>
+        <p:spPr>
+          <a:xfrm>
+            <a:off x="15361920" y="33673983"/>
+            <a:ext cx="14264640" cy="731520"/>
+          </a:xfrm>
+          <a:prstGeom prst="rect">
+            <a:avLst/>
+          </a:prstGeom>
+          <a:solidFill>
+            <a:srgbClr val="C00000"/>
+          </a:solidFill>
+          <a:ln>
+            <a:noFill/>
+          </a:ln>
+          <a:effectLst/>
+        </p:spPr>
+        <p:style>
+          <a:lnRef idx="1">
+            <a:schemeClr val="accent1"/>
+          </a:lnRef>
+          <a:fillRef idx="3">
+            <a:schemeClr val="accent1"/>
+          </a:fillRef>
+          <a:effectRef idx="2">
+            <a:schemeClr val="accent1"/>
+          </a:effectRef>
+          <a:fontRef idx="minor">
+            <a:schemeClr val="lt1"/>
+          </a:fontRef>
+        </p:style>
+        <p:txBody>
+          <a:bodyPr rtlCol="0" anchor="ctr"/>
+          <a:lstStyle/>
+          <a:p>
+            <a:pPr algn="ctr"/>
+            <a:r>
+              <a:rPr sz="3900" b="1" i="0" u="sng">
+                <a:solidFill>
+                  <a:srgbClr val="FFFFFF"/>
+                </a:solidFill>
+                <a:latin typeface="Times New Roman"/>
+              </a:rPr>
+              <a:t>Conclusion &amp; Future Work</a:t>
+            </a:r>
+          </a:p>
+        </p:txBody>
+      </p:sp>
+      <p:sp>
+        <p:nvSpPr>
+          <p:cNvPr id="84" name="TextBox 83"/>
+          <p:cNvSpPr txBox="1"/>
+          <p:nvPr/>
+        </p:nvSpPr>
+        <p:spPr>
+          <a:xfrm>
+            <a:off x="15361920" y="34542663"/>
+            <a:ext cx="14264640" cy="3108960"/>
+          </a:xfrm>
+          <a:prstGeom prst="rect">
+            <a:avLst/>
+          </a:prstGeom>
+          <a:noFill/>
+        </p:spPr>
+        <p:txBody>
+          <a:bodyPr wrap="square" anchor="t" lIns="73152" rIns="73152" tIns="27432" bIns="27432">
+            <a:spAutoFit/>
+          </a:bodyPr>
+          <a:lstStyle/>
+          <a:p>
+            <a:pPr algn="l">
+              <a:spcBef>
+                <a:spcPts val="0"/>
+              </a:spcBef>
+              <a:spcAft>
+                <a:spcPts val="405"/>
+              </a:spcAft>
+            </a:pPr>
+            <a:r>
+              <a:rPr sz="2700" b="0" i="0">
+                <a:solidFill>
+                  <a:srgbClr val="1F2937"/>
+                </a:solidFill>
+                <a:latin typeface="Times New Roman"/>
+              </a:rPr>
+              <a:t>CodeS reproduced within 0.1 points; abstention makes its answers more trustworthy, running locally.</a:t>
+            </a:r>
+          </a:p>
+          <a:p>
+            <a:pPr algn="l">
+              <a:spcBef>
+                <a:spcPts val="0"/>
+              </a:spcBef>
+              <a:spcAft>
+                <a:spcPts val="405"/>
+              </a:spcAft>
+            </a:pPr>
+            <a:r>
+              <a:rPr sz="2700" b="1" i="0">
+                <a:solidFill>
+                  <a:srgbClr val="1F2937"/>
+                </a:solidFill>
+                <a:latin typeface="Times New Roman"/>
+              </a:rPr>
+              <a:t>Next: </a:t>
+            </a:r>
+            <a:r>
+              <a:rPr sz="2700" b="0" i="0">
+                <a:solidFill>
+                  <a:srgbClr val="1F2937"/>
+                </a:solidFill>
+                <a:latin typeface="Times New Roman"/>
+              </a:rPr>
+              <a:t>CodeS-3B and more, more diverse candidate queries; then a platform that plugs into any database (Spark, Snowflake, NoSQL via a SQL gateway) with access control.</a:t>
+            </a:r>
+          </a:p>
+        </p:txBody>
+      </p:sp>
     </p:spTree>
     <p:extLst>
       <p:ext uri="{BB962C8B-B14F-4D97-AF65-F5344CB8AC3E}">

</xml_diff>

<commit_message>
Poster: show a confident answer with a chart instead of the abstention screen
Co-Authored-By: Claude Opus 5.5 <noreply@anthropic.com>
</commit_message>
<xml_diff>
--- a/docs/Review-III/QueryGenie_Poster.pptx
+++ b/docs/Review-III/QueryGenie_Poster.pptx
@@ -7373,7 +7373,7 @@
       </p:sp>
       <p:pic>
         <p:nvPicPr>
-          <p:cNvPr id="72" name="Picture 71" descr="app_not_sure.png"/>
+          <p:cNvPr id="72" name="Picture 71" descr="app_answer.png"/>
           <p:cNvPicPr>
             <a:picLocks noChangeAspect="1"/>
           </p:cNvPicPr>
@@ -7432,7 +7432,7 @@
                 </a:solidFill>
                 <a:latin typeface="Times New Roman"/>
               </a:rPr>
-              <a:t>The four candidate queries disagree, so QueryGenie asks which reading was meant instead of guessing.</a:t>
+              <a:t>A confident answer: all four candidate queries agree, so QueryGenie shows the table and a chart.</a:t>
             </a:r>
           </a:p>
         </p:txBody>

</xml_diff>

<commit_message>
Poster: drop the headline-numbers column; larger charts across the results band
Co-Authored-By: Claude Opus 5.5 <noreply@anthropic.com>
</commit_message>
<xml_diff>
--- a/docs/Review-III/QueryGenie_Poster.pptx
+++ b/docs/Review-III/QueryGenie_Poster.pptx
@@ -9766,8 +9766,8 @@
         </p:blipFill>
         <p:spPr>
           <a:xfrm>
-            <a:off x="640080" y="30678120"/>
-            <a:ext cx="6309360" cy="3984859"/>
+            <a:off x="1394460" y="30678120"/>
+            <a:ext cx="7863840" cy="4966636"/>
           </a:xfrm>
           <a:prstGeom prst="rect">
             <a:avLst/>
@@ -9790,8 +9790,8 @@
         </p:blipFill>
         <p:spPr>
           <a:xfrm>
-            <a:off x="7086600" y="30678120"/>
-            <a:ext cx="6309360" cy="3984859"/>
+            <a:off x="9395460" y="30678120"/>
+            <a:ext cx="7863840" cy="4966636"/>
           </a:xfrm>
           <a:prstGeom prst="rect">
             <a:avLst/>
@@ -9814,8 +9814,8 @@
         </p:blipFill>
         <p:spPr>
           <a:xfrm>
-            <a:off x="640080" y="34754418"/>
-            <a:ext cx="6309360" cy="3984859"/>
+            <a:off x="1394460" y="35736195"/>
+            <a:ext cx="7863840" cy="4966636"/>
           </a:xfrm>
           <a:prstGeom prst="rect">
             <a:avLst/>
@@ -9838,8 +9838,8 @@
         </p:blipFill>
         <p:spPr>
           <a:xfrm>
-            <a:off x="7086600" y="34754418"/>
-            <a:ext cx="6309360" cy="3984859"/>
+            <a:off x="9395460" y="35736195"/>
+            <a:ext cx="7863840" cy="4966636"/>
           </a:xfrm>
           <a:prstGeom prst="rect">
             <a:avLst/>
@@ -9848,367 +9848,14 @@
       </p:pic>
       <p:sp>
         <p:nvSpPr>
-          <p:cNvPr id="128" name="Rounded Rectangle 127"/>
-          <p:cNvSpPr/>
-          <p:nvPr/>
-        </p:nvSpPr>
-        <p:spPr>
-          <a:xfrm>
-            <a:off x="13578840" y="30678120"/>
-            <a:ext cx="4434840" cy="8061157"/>
-          </a:xfrm>
-          <a:prstGeom prst="roundRect">
-            <a:avLst>
-              <a:gd name="adj" fmla="val 4000"/>
-            </a:avLst>
-          </a:prstGeom>
-          <a:solidFill>
-            <a:srgbClr val="FFF7E6"/>
-          </a:solidFill>
-          <a:ln w="25400">
-            <a:solidFill>
-              <a:srgbClr val="FFC000"/>
-            </a:solidFill>
-          </a:ln>
-          <a:effectLst/>
-        </p:spPr>
-        <p:style>
-          <a:lnRef idx="1">
-            <a:schemeClr val="accent1"/>
-          </a:lnRef>
-          <a:fillRef idx="3">
-            <a:schemeClr val="accent1"/>
-          </a:fillRef>
-          <a:effectRef idx="2">
-            <a:schemeClr val="accent1"/>
-          </a:effectRef>
-          <a:fontRef idx="minor">
-            <a:schemeClr val="lt1"/>
-          </a:fontRef>
-        </p:style>
-        <p:txBody>
-          <a:bodyPr rtlCol="0" anchor="ctr"/>
-          <a:lstStyle/>
-          <a:p>
-            <a:pPr algn="ctr"/>
-          </a:p>
-        </p:txBody>
-      </p:sp>
-      <p:sp>
-        <p:nvSpPr>
-          <p:cNvPr id="129" name="TextBox 128"/>
+          <p:cNvPr id="128" name="TextBox 127"/>
           <p:cNvSpPr txBox="1"/>
           <p:nvPr/>
         </p:nvSpPr>
         <p:spPr>
           <a:xfrm>
-            <a:off x="13670280" y="30769560"/>
-            <a:ext cx="4251959" cy="1463040"/>
-          </a:xfrm>
-          <a:prstGeom prst="rect">
-            <a:avLst/>
-          </a:prstGeom>
-          <a:noFill/>
-        </p:spPr>
-        <p:txBody>
-          <a:bodyPr wrap="square" anchor="t" lIns="73152" rIns="73152" tIns="27432" bIns="27432">
-            <a:spAutoFit/>
-          </a:bodyPr>
-          <a:lstStyle/>
-          <a:p>
-            <a:pPr algn="ctr">
-              <a:spcBef>
-                <a:spcPts val="0"/>
-              </a:spcBef>
-              <a:spcAft>
-                <a:spcPts val="0"/>
-              </a:spcAft>
-            </a:pPr>
-            <a:r>
-              <a:rPr sz="4000" b="1" i="0" u="none">
-                <a:solidFill>
-                  <a:srgbClr val="0070C0"/>
-                </a:solidFill>
-                <a:latin typeface="Arial"/>
-              </a:rPr>
-              <a:t>77.8%</a:t>
-            </a:r>
-          </a:p>
-          <a:p>
-            <a:pPr algn="ctr">
-              <a:spcBef>
-                <a:spcPts val="0"/>
-              </a:spcBef>
-              <a:spcAft>
-                <a:spcPts val="0"/>
-              </a:spcAft>
-            </a:pPr>
-            <a:r>
-              <a:rPr sz="1800" b="0" i="0" u="none">
-                <a:solidFill>
-                  <a:srgbClr val="1F2937"/>
-                </a:solidFill>
-                <a:latin typeface="Arial"/>
-              </a:rPr>
-              <a:t>Spider EX (paper 77.9%)</a:t>
-            </a:r>
-          </a:p>
-        </p:txBody>
-      </p:sp>
-      <p:sp>
-        <p:nvSpPr>
-          <p:cNvPr id="130" name="TextBox 129"/>
-          <p:cNvSpPr txBox="1"/>
-          <p:nvPr/>
-        </p:nvSpPr>
-        <p:spPr>
-          <a:xfrm>
-            <a:off x="13670280" y="32345215"/>
-            <a:ext cx="4251959" cy="1463040"/>
-          </a:xfrm>
-          <a:prstGeom prst="rect">
-            <a:avLst/>
-          </a:prstGeom>
-          <a:noFill/>
-        </p:spPr>
-        <p:txBody>
-          <a:bodyPr wrap="square" anchor="t" lIns="73152" rIns="73152" tIns="27432" bIns="27432">
-            <a:spAutoFit/>
-          </a:bodyPr>
-          <a:lstStyle/>
-          <a:p>
-            <a:pPr algn="ctr">
-              <a:spcBef>
-                <a:spcPts val="0"/>
-              </a:spcBef>
-              <a:spcAft>
-                <a:spcPts val="0"/>
-              </a:spcAft>
-            </a:pPr>
-            <a:r>
-              <a:rPr sz="4000" b="1" i="0" u="none">
-                <a:solidFill>
-                  <a:srgbClr val="0070C0"/>
-                </a:solidFill>
-                <a:latin typeface="Arial"/>
-              </a:rPr>
-              <a:t>69.5%</a:t>
-            </a:r>
-          </a:p>
-          <a:p>
-            <a:pPr algn="ctr">
-              <a:spcBef>
-                <a:spcPts val="0"/>
-              </a:spcBef>
-              <a:spcAft>
-                <a:spcPts val="0"/>
-              </a:spcAft>
-            </a:pPr>
-            <a:r>
-              <a:rPr sz="1800" b="0" i="0" u="none">
-                <a:solidFill>
-                  <a:srgbClr val="1F2937"/>
-                </a:solidFill>
-                <a:latin typeface="Arial"/>
-              </a:rPr>
-              <a:t>Spider-Realistic (paper 70.9%)</a:t>
-            </a:r>
-          </a:p>
-        </p:txBody>
-      </p:sp>
-      <p:sp>
-        <p:nvSpPr>
-          <p:cNvPr id="131" name="TextBox 130"/>
-          <p:cNvSpPr txBox="1"/>
-          <p:nvPr/>
-        </p:nvSpPr>
-        <p:spPr>
-          <a:xfrm>
-            <a:off x="13670280" y="33920871"/>
-            <a:ext cx="4251959" cy="1463040"/>
-          </a:xfrm>
-          <a:prstGeom prst="rect">
-            <a:avLst/>
-          </a:prstGeom>
-          <a:noFill/>
-        </p:spPr>
-        <p:txBody>
-          <a:bodyPr wrap="square" anchor="t" lIns="73152" rIns="73152" tIns="27432" bIns="27432">
-            <a:spAutoFit/>
-          </a:bodyPr>
-          <a:lstStyle/>
-          <a:p>
-            <a:pPr algn="ctr">
-              <a:spcBef>
-                <a:spcPts val="0"/>
-              </a:spcBef>
-              <a:spcAft>
-                <a:spcPts val="0"/>
-              </a:spcAft>
-            </a:pPr>
-            <a:r>
-              <a:rPr sz="4000" b="1" i="0" u="none">
-                <a:solidFill>
-                  <a:srgbClr val="0070C0"/>
-                </a:solidFill>
-                <a:latin typeface="Arial"/>
-              </a:rPr>
-              <a:t>83.3%</a:t>
-            </a:r>
-          </a:p>
-          <a:p>
-            <a:pPr algn="ctr">
-              <a:spcBef>
-                <a:spcPts val="0"/>
-              </a:spcBef>
-              <a:spcAft>
-                <a:spcPts val="0"/>
-              </a:spcAft>
-            </a:pPr>
-            <a:r>
-              <a:rPr sz="1800" b="0" i="0" u="none">
-                <a:solidFill>
-                  <a:srgbClr val="1F2937"/>
-                </a:solidFill>
-                <a:latin typeface="Arial"/>
-              </a:rPr>
-              <a:t>correct when it answers (vs 77.8%)</a:t>
-            </a:r>
-          </a:p>
-        </p:txBody>
-      </p:sp>
-      <p:sp>
-        <p:nvSpPr>
-          <p:cNvPr id="132" name="TextBox 131"/>
-          <p:cNvSpPr txBox="1"/>
-          <p:nvPr/>
-        </p:nvSpPr>
-        <p:spPr>
-          <a:xfrm>
-            <a:off x="13670280" y="35496526"/>
-            <a:ext cx="4251959" cy="1463040"/>
-          </a:xfrm>
-          <a:prstGeom prst="rect">
-            <a:avLst/>
-          </a:prstGeom>
-          <a:noFill/>
-        </p:spPr>
-        <p:txBody>
-          <a:bodyPr wrap="square" anchor="t" lIns="73152" rIns="73152" tIns="27432" bIns="27432">
-            <a:spAutoFit/>
-          </a:bodyPr>
-          <a:lstStyle/>
-          <a:p>
-            <a:pPr algn="ctr">
-              <a:spcBef>
-                <a:spcPts val="0"/>
-              </a:spcBef>
-              <a:spcAft>
-                <a:spcPts val="0"/>
-              </a:spcAft>
-            </a:pPr>
-            <a:r>
-              <a:rPr sz="4000" b="1" i="0" u="none">
-                <a:solidFill>
-                  <a:srgbClr val="0070C0"/>
-                </a:solidFill>
-                <a:latin typeface="Arial"/>
-              </a:rPr>
-              <a:t>−32%</a:t>
-            </a:r>
-          </a:p>
-          <a:p>
-            <a:pPr algn="ctr">
-              <a:spcBef>
-                <a:spcPts val="0"/>
-              </a:spcBef>
-              <a:spcAft>
-                <a:spcPts val="0"/>
-              </a:spcAft>
-            </a:pPr>
-            <a:r>
-              <a:rPr sz="1800" b="0" i="0" u="none">
-                <a:solidFill>
-                  <a:srgbClr val="1F2937"/>
-                </a:solidFill>
-                <a:latin typeface="Arial"/>
-              </a:rPr>
-              <a:t>wrong answers (230 → 156)</a:t>
-            </a:r>
-          </a:p>
-        </p:txBody>
-      </p:sp>
-      <p:sp>
-        <p:nvSpPr>
-          <p:cNvPr id="133" name="TextBox 132"/>
-          <p:cNvSpPr txBox="1"/>
-          <p:nvPr/>
-        </p:nvSpPr>
-        <p:spPr>
-          <a:xfrm>
-            <a:off x="13670280" y="37072182"/>
-            <a:ext cx="4251959" cy="1463040"/>
-          </a:xfrm>
-          <a:prstGeom prst="rect">
-            <a:avLst/>
-          </a:prstGeom>
-          <a:noFill/>
-        </p:spPr>
-        <p:txBody>
-          <a:bodyPr wrap="square" anchor="t" lIns="73152" rIns="73152" tIns="27432" bIns="27432">
-            <a:spAutoFit/>
-          </a:bodyPr>
-          <a:lstStyle/>
-          <a:p>
-            <a:pPr algn="ctr">
-              <a:spcBef>
-                <a:spcPts val="0"/>
-              </a:spcBef>
-              <a:spcAft>
-                <a:spcPts val="0"/>
-              </a:spcAft>
-            </a:pPr>
-            <a:r>
-              <a:rPr sz="4000" b="1" i="0" u="none">
-                <a:solidFill>
-                  <a:srgbClr val="0070C0"/>
-                </a:solidFill>
-                <a:latin typeface="Arial"/>
-              </a:rPr>
-              <a:t>p &lt; 10⁻⁹</a:t>
-            </a:r>
-          </a:p>
-          <a:p>
-            <a:pPr algn="ctr">
-              <a:spcBef>
-                <a:spcPts val="0"/>
-              </a:spcBef>
-              <a:spcAft>
-                <a:spcPts val="0"/>
-              </a:spcAft>
-            </a:pPr>
-            <a:r>
-              <a:rPr sz="1800" b="0" i="0" u="none">
-                <a:solidFill>
-                  <a:srgbClr val="1F2937"/>
-                </a:solidFill>
-                <a:latin typeface="Arial"/>
-              </a:rPr>
-              <a:t>paired t-test</a:t>
-            </a:r>
-          </a:p>
-        </p:txBody>
-      </p:sp>
-      <p:sp>
-        <p:nvSpPr>
-          <p:cNvPr id="134" name="TextBox 133"/>
-          <p:cNvSpPr txBox="1"/>
-          <p:nvPr/>
-        </p:nvSpPr>
-        <p:spPr>
-          <a:xfrm>
-            <a:off x="640080" y="38876437"/>
-            <a:ext cx="17373600" cy="2957362"/>
+            <a:off x="640080" y="40748551"/>
+            <a:ext cx="17373600" cy="1085248"/>
           </a:xfrm>
           <a:prstGeom prst="rect">
             <a:avLst/>
@@ -10226,11 +9873,11 @@
                 <a:spcPts val="0"/>
               </a:spcBef>
               <a:spcAft>
-                <a:spcPts val="375"/>
+                <a:spcPts val="176"/>
               </a:spcAft>
             </a:pPr>
             <a:r>
-              <a:rPr sz="2500" b="1" i="0" u="none">
+              <a:rPr sz="2200" b="1" i="0" u="none">
                 <a:solidFill>
                   <a:srgbClr val="1F2937"/>
                 </a:solidFill>
@@ -10239,7 +9886,7 @@
               <a:t>Significant: </a:t>
             </a:r>
             <a:r>
-              <a:rPr sz="2500" b="0" i="0" u="none">
+              <a:rPr sz="2200" b="0" i="0" u="none">
                 <a:solidFill>
                   <a:srgbClr val="1F2937"/>
                 </a:solidFill>
@@ -10254,11 +9901,11 @@
                 <a:spcPts val="0"/>
               </a:spcBef>
               <a:spcAft>
-                <a:spcPts val="375"/>
+                <a:spcPts val="176"/>
               </a:spcAft>
             </a:pPr>
             <a:r>
-              <a:rPr sz="2500" b="1" i="0" u="none">
+              <a:rPr sz="2200" b="1" i="0" u="none">
                 <a:solidFill>
                   <a:srgbClr val="1F2937"/>
                 </a:solidFill>
@@ -10267,7 +9914,7 @@
               <a:t>Robust: </a:t>
             </a:r>
             <a:r>
-              <a:rPr sz="2500" b="0" i="0" u="none">
+              <a:rPr sz="2200" b="0" i="0" u="none">
                 <a:solidFill>
                   <a:srgbClr val="1F2937"/>
                 </a:solidFill>
@@ -10280,7 +9927,7 @@
       </p:sp>
       <p:sp>
         <p:nvSpPr>
-          <p:cNvPr id="135" name="Rounded Rectangle 134"/>
+          <p:cNvPr id="129" name="Rounded Rectangle 128"/>
           <p:cNvSpPr/>
           <p:nvPr/>
         </p:nvSpPr>
@@ -10329,7 +9976,7 @@
       </p:sp>
       <p:sp>
         <p:nvSpPr>
-          <p:cNvPr id="136" name="TextBox 135"/>
+          <p:cNvPr id="130" name="TextBox 129"/>
           <p:cNvSpPr txBox="1"/>
           <p:nvPr/>
         </p:nvSpPr>
@@ -10576,7 +10223,7 @@
       </p:sp>
       <p:sp>
         <p:nvSpPr>
-          <p:cNvPr id="137" name="Rounded Rectangle 136"/>
+          <p:cNvPr id="131" name="Rounded Rectangle 130"/>
           <p:cNvSpPr/>
           <p:nvPr/>
         </p:nvSpPr>
@@ -10625,7 +10272,7 @@
       </p:sp>
       <p:sp>
         <p:nvSpPr>
-          <p:cNvPr id="138" name="TextBox 137"/>
+          <p:cNvPr id="132" name="TextBox 131"/>
           <p:cNvSpPr txBox="1"/>
           <p:nvPr/>
         </p:nvSpPr>
@@ -10838,7 +10485,7 @@
       </p:sp>
       <p:sp>
         <p:nvSpPr>
-          <p:cNvPr id="139" name="Rectangle 138"/>
+          <p:cNvPr id="133" name="Rectangle 132"/>
           <p:cNvSpPr/>
           <p:nvPr/>
         </p:nvSpPr>
@@ -10898,7 +10545,7 @@
       </p:sp>
       <p:sp>
         <p:nvSpPr>
-          <p:cNvPr id="140" name="TextBox 139"/>
+          <p:cNvPr id="134" name="TextBox 133"/>
           <p:cNvSpPr txBox="1"/>
           <p:nvPr/>
         </p:nvSpPr>

</xml_diff>

<commit_message>
Poster: remove the tagline under the title
Co-Authored-By: Claude Opus 5.5 <noreply@anthropic.com>
</commit_message>
<xml_diff>
--- a/docs/Review-III/QueryGenie_Poster.pptx
+++ b/docs/Review-III/QueryGenie_Poster.pptx
@@ -4590,7 +4590,7 @@
           </a:xfrm>
         </p:spPr>
         <p:txBody>
-          <a:bodyPr wrap="square" anchor="t" lIns="73152" rIns="73152" tIns="27432" bIns="27432"/>
+          <a:bodyPr wrap="square" anchor="ctr" lIns="73152" rIns="73152" tIns="27432" bIns="27432"/>
           <a:lstStyle/>
           <a:p>
             <a:pPr algn="ctr">
@@ -4628,25 +4628,6 @@
                 <a:latin typeface="Arial"/>
               </a:rPr>
               <a:t>A Self-Correcting, Confidence-Aware Natural Language to SQL Interface</a:t>
-            </a:r>
-          </a:p>
-          <a:p>
-            <a:pPr algn="ctr">
-              <a:spcBef>
-                <a:spcPts val="0"/>
-              </a:spcBef>
-              <a:spcAft>
-                <a:spcPts val="104"/>
-              </a:spcAft>
-            </a:pPr>
-            <a:r>
-              <a:rPr sz="2700" b="0" i="1" u="none">
-                <a:solidFill>
-                  <a:srgbClr val="4B5563"/>
-                </a:solidFill>
-                <a:latin typeface="Arial"/>
-              </a:rPr>
-              <a:t>Ask a database in plain English — and be told when the answer can't be trusted</a:t>
             </a:r>
           </a:p>
         </p:txBody>

</xml_diff>

<commit_message>
Poster: template font (Aptos) and underlined headings as in the reviewer's reference; tool strip removed; project coordinator listed
Aptos is the template's theme font and the one the reviewer's reference poster uses. Runs carry the
same face for east-Asian/complex scripts and en-US, because the template's title box is tagged
right-to-left and renderers otherwise substituted a serif.

Co-Authored-By: Claude Opus 5.5 <noreply@anthropic.com>
</commit_message>
<xml_diff>
--- a/docs/Review-III/QueryGenie_Poster.pptx
+++ b/docs/Review-III/QueryGenie_Poster.pptx
@@ -4242,11 +4242,13 @@
               </a:spcAft>
             </a:pPr>
             <a:r>
-              <a:rPr sz="3800" b="1" i="0" u="none">
+              <a:rPr sz="3800" b="1" i="0" u="sng" lang="en-US">
                 <a:solidFill>
                   <a:srgbClr val="FFFFFF"/>
                 </a:solidFill>
-                <a:latin typeface="Arial"/>
+                <a:latin typeface="Aptos"/>
+                <a:ea typeface="Aptos"/>
+                <a:cs typeface="Aptos"/>
               </a:rPr>
               <a:t>Abstract</a:t>
             </a:r>
@@ -4291,11 +4293,13 @@
               </a:spcAft>
             </a:pPr>
             <a:r>
-              <a:rPr sz="3800" b="1" i="0" u="none">
+              <a:rPr sz="3800" b="1" i="0" u="sng" lang="en-US">
                 <a:solidFill>
                   <a:srgbClr val="FFFFFF"/>
                 </a:solidFill>
-                <a:latin typeface="Arial"/>
+                <a:latin typeface="Aptos"/>
+                <a:ea typeface="Aptos"/>
+                <a:cs typeface="Aptos"/>
               </a:rPr>
               <a:t>Objectives</a:t>
             </a:r>
@@ -4340,11 +4344,13 @@
               </a:spcAft>
             </a:pPr>
             <a:r>
-              <a:rPr sz="3800" b="1" i="0" u="none">
+              <a:rPr sz="3800" b="1" i="0" u="sng" lang="en-US">
                 <a:solidFill>
                   <a:srgbClr val="FFFFFF"/>
                 </a:solidFill>
-                <a:latin typeface="Arial"/>
+                <a:latin typeface="Aptos"/>
+                <a:ea typeface="Aptos"/>
+                <a:cs typeface="Aptos"/>
               </a:rPr>
               <a:t>Proposed Methodology / System Architecture</a:t>
             </a:r>
@@ -4419,11 +4425,13 @@
               </a:spcAft>
             </a:pPr>
             <a:r>
-              <a:rPr sz="3800" b="1" i="0" u="none">
+              <a:rPr sz="3800" b="1" i="0" u="sng" lang="en-US">
                 <a:solidFill>
                   <a:srgbClr val="FFFFFF"/>
                 </a:solidFill>
-                <a:latin typeface="Arial"/>
+                <a:latin typeface="Aptos"/>
+                <a:ea typeface="Aptos"/>
+                <a:cs typeface="Aptos"/>
               </a:rPr>
               <a:t>References</a:t>
             </a:r>
@@ -4498,11 +4506,13 @@
               </a:spcAft>
             </a:pPr>
             <a:r>
-              <a:rPr sz="3800" b="1" i="0" u="none">
+              <a:rPr sz="3800" b="1" i="0" u="sng" lang="en-US">
                 <a:solidFill>
                   <a:srgbClr val="FFFFFF"/>
                 </a:solidFill>
-                <a:latin typeface="Arial"/>
+                <a:latin typeface="Aptos"/>
+                <a:ea typeface="Aptos"/>
+                <a:cs typeface="Aptos"/>
               </a:rPr>
               <a:t>Team Details</a:t>
             </a:r>
@@ -4602,11 +4612,13 @@
               </a:spcAft>
             </a:pPr>
             <a:r>
-              <a:rPr sz="9600" b="1" i="0" u="none">
+              <a:rPr sz="10000" b="1" i="0" u="none" lang="en-US">
                 <a:solidFill>
                   <a:srgbClr val="002060"/>
                 </a:solidFill>
-                <a:latin typeface="Arial"/>
+                <a:latin typeface="Aptos"/>
+                <a:ea typeface="Aptos"/>
+                <a:cs typeface="Aptos"/>
               </a:rPr>
               <a:t>QueryGenie</a:t>
             </a:r>
@@ -4621,11 +4633,13 @@
               </a:spcAft>
             </a:pPr>
             <a:r>
-              <a:rPr sz="4000" b="0" i="0" u="none">
+              <a:rPr sz="4200" b="1" i="0" u="none" lang="en-US">
                 <a:solidFill>
                   <a:srgbClr val="002060"/>
                 </a:solidFill>
-                <a:latin typeface="Arial"/>
+                <a:latin typeface="Aptos"/>
+                <a:ea typeface="Aptos"/>
+                <a:cs typeface="Aptos"/>
               </a:rPr>
               <a:t>A Self-Correcting, Confidence-Aware Natural Language to SQL Interface</a:t>
             </a:r>
@@ -4670,11 +4684,13 @@
               </a:spcAft>
             </a:pPr>
             <a:r>
-              <a:rPr sz="3800" b="1" i="0" u="none">
+              <a:rPr sz="3800" b="1" i="0" u="sng" lang="en-US">
                 <a:solidFill>
                   <a:srgbClr val="FFFFFF"/>
                 </a:solidFill>
-                <a:latin typeface="Arial"/>
+                <a:latin typeface="Aptos"/>
+                <a:ea typeface="Aptos"/>
+                <a:cs typeface="Aptos"/>
               </a:rPr>
               <a:t>Experimental Results</a:t>
             </a:r>
@@ -4794,7 +4810,7 @@
                 <a:solidFill>
                   <a:schemeClr val="tx1"/>
                 </a:solidFill>
-                <a:latin typeface="Arial"/>
+                <a:latin typeface="Aptos"/>
               </a:rPr>
               <a:t>Department of Computer Science and Information Technology</a:t>
             </a:r>
@@ -5064,7 +5080,7 @@
                 <a:solidFill>
                   <a:srgbClr val="002060"/>
                 </a:solidFill>
-                <a:latin typeface="Arial"/>
+                <a:latin typeface="Aptos"/>
               </a:rPr>
               <a:t>STUDENTS</a:t>
             </a:r>
@@ -5105,7 +5121,7 @@
                 <a:solidFill>
                   <a:srgbClr val="002060"/>
                 </a:solidFill>
-                <a:latin typeface="Arial"/>
+                <a:latin typeface="Aptos"/>
               </a:rPr>
               <a:t>INNOVATION</a:t>
             </a:r>
@@ -5146,7 +5162,7 @@
                 <a:solidFill>
                   <a:srgbClr val="002060"/>
                 </a:solidFill>
-                <a:latin typeface="Arial"/>
+                <a:latin typeface="Aptos"/>
               </a:rPr>
               <a:t>RESEARCH</a:t>
             </a:r>
@@ -5187,7 +5203,7 @@
                 <a:solidFill>
                   <a:srgbClr val="002060"/>
                 </a:solidFill>
-                <a:latin typeface="Arial"/>
+                <a:latin typeface="Aptos"/>
               </a:rPr>
               <a:t>IMPACT</a:t>
             </a:r>
@@ -5226,12 +5242,12 @@
         </p:nvSpPr>
         <p:spPr>
           <a:xfrm>
-            <a:off x="640080" y="5394960"/>
-            <a:ext cx="3463290" cy="1143000"/>
+            <a:off x="640080" y="7680960"/>
+            <a:ext cx="14264640" cy="5074920"/>
           </a:xfrm>
           <a:prstGeom prst="roundRect">
             <a:avLst>
-              <a:gd name="adj" fmla="val 18000"/>
+              <a:gd name="adj" fmla="val 5000"/>
             </a:avLst>
           </a:prstGeom>
           <a:solidFill>
@@ -5241,6 +5257,7 @@
             <a:solidFill>
               <a:srgbClr val="C9D3E0"/>
             </a:solidFill>
+            <a:prstDash val="dash"/>
           </a:ln>
           <a:effectLst/>
         </p:spPr>
@@ -5266,95 +5283,80 @@
           </a:p>
         </p:txBody>
       </p:sp>
-      <p:pic>
-        <p:nvPicPr>
-          <p:cNvPr id="29" name="Picture 28" descr="brand_python.png"/>
-          <p:cNvPicPr>
-            <a:picLocks noChangeAspect="1"/>
-          </p:cNvPicPr>
+      <p:sp>
+        <p:nvSpPr>
+          <p:cNvPr id="29" name="TextBox 28"/>
+          <p:cNvSpPr txBox="1"/>
           <p:nvPr/>
-        </p:nvPicPr>
-        <p:blipFill>
-          <a:blip r:embed="rId4"/>
-          <a:stretch>
-            <a:fillRect/>
-          </a:stretch>
-        </p:blipFill>
-        <p:spPr>
-          <a:xfrm>
-            <a:off x="777240" y="5641848"/>
-            <a:ext cx="640080" cy="640080"/>
+        </p:nvSpPr>
+        <p:spPr>
+          <a:xfrm>
+            <a:off x="777240" y="7772400"/>
+            <a:ext cx="13990319" cy="4937760"/>
           </a:xfrm>
           <a:prstGeom prst="rect">
             <a:avLst/>
           </a:prstGeom>
-        </p:spPr>
-      </p:pic>
-      <p:sp>
-        <p:nvSpPr>
-          <p:cNvPr id="30" name="TextBox 29"/>
-          <p:cNvSpPr txBox="1"/>
-          <p:nvPr/>
-        </p:nvSpPr>
-        <p:spPr>
-          <a:xfrm>
-            <a:off x="1463040" y="5394960"/>
-            <a:ext cx="2594610" cy="1143000"/>
-          </a:xfrm>
-          <a:prstGeom prst="rect">
-            <a:avLst/>
-          </a:prstGeom>
           <a:noFill/>
         </p:spPr>
         <p:txBody>
-          <a:bodyPr wrap="square" anchor="ctr" lIns="36576" rIns="36576" tIns="27432" bIns="27432">
+          <a:bodyPr wrap="square" anchor="t" lIns="73152" rIns="73152" tIns="27432" bIns="27432">
             <a:spAutoFit/>
           </a:bodyPr>
           <a:lstStyle/>
           <a:p>
-            <a:pPr algn="l">
+            <a:pPr algn="just">
               <a:spcBef>
                 <a:spcPts val="0"/>
               </a:spcBef>
               <a:spcAft>
-                <a:spcPts val="650"/>
+                <a:spcPts val="775"/>
               </a:spcAft>
             </a:pPr>
             <a:r>
-              <a:rPr sz="2000" b="1" i="0" u="none">
-                <a:solidFill>
-                  <a:srgbClr val="002060"/>
-                </a:solidFill>
-                <a:latin typeface="Arial"/>
+              <a:rPr sz="3100" b="1" i="0" u="none" lang="en-US">
+                <a:solidFill>
+                  <a:srgbClr val="1F2937"/>
+                </a:solidFill>
+                <a:latin typeface="Aptos"/>
+                <a:ea typeface="Aptos"/>
+                <a:cs typeface="Aptos"/>
               </a:rPr>
-              <a:t>Python 3.13</a:t>
-            </a:r>
-          </a:p>
-        </p:txBody>
-      </p:sp>
-      <p:sp>
-        <p:nvSpPr>
-          <p:cNvPr id="31" name="Rounded Rectangle 30"/>
+              <a:t>QueryGenie</a:t>
+            </a:r>
+            <a:r>
+              <a:rPr sz="3100" b="0" i="0" u="none" lang="en-US">
+                <a:solidFill>
+                  <a:srgbClr val="1F2937"/>
+                </a:solidFill>
+                <a:latin typeface="Aptos"/>
+                <a:ea typeface="Aptos"/>
+                <a:cs typeface="Aptos"/>
+              </a:rPr>
+              <a:t> lets anyone ask a database questions in plain English. Text-to-SQL models answer every question with the same confidence, so a wrong answer looks exactly like a right one. We reproduce CodeS (SIGMOD 2024), an open-source text-to-SQL model, to 77.8% execution accuracy on Spider (paper: 77.9%), and add confidence-aware abstention: the system runs every candidate query the model writes and checks whether they agree. When they don't, it asks the user instead of guessing. It answers 90.4% of questions and is right on 83.3% of them, with a third fewer wrong answers — a statistically significant gain. It runs fully locally in a desktop app.</a:t>
+            </a:r>
+          </a:p>
+        </p:txBody>
+      </p:sp>
+      <p:sp>
+        <p:nvSpPr>
+          <p:cNvPr id="30" name="Oval 29"/>
           <p:cNvSpPr/>
           <p:nvPr/>
         </p:nvSpPr>
         <p:spPr>
           <a:xfrm>
-            <a:off x="4286250" y="5394960"/>
-            <a:ext cx="3463290" cy="1143000"/>
-          </a:xfrm>
-          <a:prstGeom prst="roundRect">
-            <a:avLst>
-              <a:gd name="adj" fmla="val 18000"/>
-            </a:avLst>
+            <a:off x="777240" y="13944600"/>
+            <a:ext cx="731520" cy="731520"/>
+          </a:xfrm>
+          <a:prstGeom prst="ellipse">
+            <a:avLst/>
           </a:prstGeom>
           <a:solidFill>
-            <a:srgbClr val="FFFFFF"/>
+            <a:srgbClr val="0070C0"/>
           </a:solidFill>
-          <a:ln w="19050">
-            <a:solidFill>
-              <a:srgbClr val="C9D3E0"/>
-            </a:solidFill>
+          <a:ln>
+            <a:noFill/>
           </a:ln>
           <a:effectLst/>
         </p:spPr>
@@ -5373,60 +5375,10 @@
           </a:fontRef>
         </p:style>
         <p:txBody>
-          <a:bodyPr rtlCol="0" anchor="ctr"/>
-          <a:lstStyle/>
-          <a:p>
-            <a:pPr algn="ctr"/>
-          </a:p>
-        </p:txBody>
-      </p:sp>
-      <p:pic>
-        <p:nvPicPr>
-          <p:cNvPr id="32" name="Picture 31" descr="brand_pytorch.png"/>
-          <p:cNvPicPr>
-            <a:picLocks noChangeAspect="1"/>
-          </p:cNvPicPr>
-          <p:nvPr/>
-        </p:nvPicPr>
-        <p:blipFill>
-          <a:blip r:embed="rId5"/>
-          <a:stretch>
-            <a:fillRect/>
-          </a:stretch>
-        </p:blipFill>
-        <p:spPr>
-          <a:xfrm>
-            <a:off x="4423410" y="5641848"/>
-            <a:ext cx="640080" cy="640080"/>
-          </a:xfrm>
-          <a:prstGeom prst="rect">
-            <a:avLst/>
-          </a:prstGeom>
-        </p:spPr>
-      </p:pic>
-      <p:sp>
-        <p:nvSpPr>
-          <p:cNvPr id="33" name="TextBox 32"/>
-          <p:cNvSpPr txBox="1"/>
-          <p:nvPr/>
-        </p:nvSpPr>
-        <p:spPr>
-          <a:xfrm>
-            <a:off x="5109210" y="5394960"/>
-            <a:ext cx="2594610" cy="1143000"/>
-          </a:xfrm>
-          <a:prstGeom prst="rect">
-            <a:avLst/>
-          </a:prstGeom>
-          <a:noFill/>
-        </p:spPr>
-        <p:txBody>
-          <a:bodyPr wrap="square" anchor="ctr" lIns="36576" rIns="36576" tIns="27432" bIns="27432">
-            <a:spAutoFit/>
-          </a:bodyPr>
-          <a:lstStyle/>
-          <a:p>
-            <a:pPr algn="l">
+          <a:bodyPr rtlCol="0" anchor="ctr" wrap="square" lIns="0" rIns="0" tIns="27432" bIns="27432"/>
+          <a:lstStyle/>
+          <a:p>
+            <a:pPr algn="ctr">
               <a:spcBef>
                 <a:spcPts val="0"/>
               </a:spcBef>
@@ -5435,40 +5387,82 @@
               </a:spcAft>
             </a:pPr>
             <a:r>
-              <a:rPr sz="2000" b="1" i="0" u="none">
-                <a:solidFill>
-                  <a:srgbClr val="002060"/>
-                </a:solidFill>
-                <a:latin typeface="Arial"/>
+              <a:rPr sz="2800" b="1" i="0" u="none" lang="en-US">
+                <a:solidFill>
+                  <a:srgbClr val="FFFFFF"/>
+                </a:solidFill>
+                <a:latin typeface="Aptos"/>
+                <a:ea typeface="Aptos"/>
+                <a:cs typeface="Aptos"/>
               </a:rPr>
-              <a:t>PyTorch</a:t>
-            </a:r>
-          </a:p>
-        </p:txBody>
-      </p:sp>
-      <p:sp>
-        <p:nvSpPr>
-          <p:cNvPr id="34" name="Rounded Rectangle 33"/>
+              <a:t>1</a:t>
+            </a:r>
+          </a:p>
+        </p:txBody>
+      </p:sp>
+      <p:sp>
+        <p:nvSpPr>
+          <p:cNvPr id="31" name="TextBox 30"/>
+          <p:cNvSpPr txBox="1"/>
+          <p:nvPr/>
+        </p:nvSpPr>
+        <p:spPr>
+          <a:xfrm>
+            <a:off x="1691639" y="13880592"/>
+            <a:ext cx="13121640" cy="868680"/>
+          </a:xfrm>
+          <a:prstGeom prst="rect">
+            <a:avLst/>
+          </a:prstGeom>
+          <a:noFill/>
+        </p:spPr>
+        <p:txBody>
+          <a:bodyPr wrap="square" anchor="ctr" lIns="73152" rIns="73152" tIns="27432" bIns="27432">
+            <a:spAutoFit/>
+          </a:bodyPr>
+          <a:lstStyle/>
+          <a:p>
+            <a:pPr algn="l">
+              <a:spcBef>
+                <a:spcPts val="0"/>
+              </a:spcBef>
+              <a:spcAft>
+                <a:spcPts val="675"/>
+              </a:spcAft>
+            </a:pPr>
+            <a:r>
+              <a:rPr sz="2700" b="0" i="0" u="none" lang="en-US">
+                <a:solidFill>
+                  <a:srgbClr val="1F2937"/>
+                </a:solidFill>
+                <a:latin typeface="Aptos"/>
+                <a:ea typeface="Aptos"/>
+                <a:cs typeface="Aptos"/>
+              </a:rPr>
+              <a:t>Reproduce CodeS-1B on Spider within the ±5–10% tolerance</a:t>
+            </a:r>
+          </a:p>
+        </p:txBody>
+      </p:sp>
+      <p:sp>
+        <p:nvSpPr>
+          <p:cNvPr id="32" name="Oval 31"/>
           <p:cNvSpPr/>
           <p:nvPr/>
         </p:nvSpPr>
         <p:spPr>
           <a:xfrm>
-            <a:off x="7932420" y="5394960"/>
-            <a:ext cx="3463290" cy="1143000"/>
-          </a:xfrm>
-          <a:prstGeom prst="roundRect">
-            <a:avLst>
-              <a:gd name="adj" fmla="val 18000"/>
-            </a:avLst>
+            <a:off x="777240" y="14904720"/>
+            <a:ext cx="731520" cy="731520"/>
+          </a:xfrm>
+          <a:prstGeom prst="ellipse">
+            <a:avLst/>
           </a:prstGeom>
           <a:solidFill>
-            <a:srgbClr val="FFFFFF"/>
+            <a:srgbClr val="2E7D32"/>
           </a:solidFill>
-          <a:ln w="19050">
-            <a:solidFill>
-              <a:srgbClr val="C9D3E0"/>
-            </a:solidFill>
+          <a:ln>
+            <a:noFill/>
           </a:ln>
           <a:effectLst/>
         </p:spPr>
@@ -5487,60 +5481,10 @@
           </a:fontRef>
         </p:style>
         <p:txBody>
-          <a:bodyPr rtlCol="0" anchor="ctr"/>
-          <a:lstStyle/>
-          <a:p>
-            <a:pPr algn="ctr"/>
-          </a:p>
-        </p:txBody>
-      </p:sp>
-      <p:pic>
-        <p:nvPicPr>
-          <p:cNvPr id="35" name="Picture 34" descr="brand_huggingface.png"/>
-          <p:cNvPicPr>
-            <a:picLocks noChangeAspect="1"/>
-          </p:cNvPicPr>
-          <p:nvPr/>
-        </p:nvPicPr>
-        <p:blipFill>
-          <a:blip r:embed="rId6"/>
-          <a:stretch>
-            <a:fillRect/>
-          </a:stretch>
-        </p:blipFill>
-        <p:spPr>
-          <a:xfrm>
-            <a:off x="8069580" y="5641848"/>
-            <a:ext cx="640080" cy="640080"/>
-          </a:xfrm>
-          <a:prstGeom prst="rect">
-            <a:avLst/>
-          </a:prstGeom>
-        </p:spPr>
-      </p:pic>
-      <p:sp>
-        <p:nvSpPr>
-          <p:cNvPr id="36" name="TextBox 35"/>
-          <p:cNvSpPr txBox="1"/>
-          <p:nvPr/>
-        </p:nvSpPr>
-        <p:spPr>
-          <a:xfrm>
-            <a:off x="8755380" y="5394960"/>
-            <a:ext cx="2594610" cy="1143000"/>
-          </a:xfrm>
-          <a:prstGeom prst="rect">
-            <a:avLst/>
-          </a:prstGeom>
-          <a:noFill/>
-        </p:spPr>
-        <p:txBody>
-          <a:bodyPr wrap="square" anchor="ctr" lIns="36576" rIns="36576" tIns="27432" bIns="27432">
-            <a:spAutoFit/>
-          </a:bodyPr>
-          <a:lstStyle/>
-          <a:p>
-            <a:pPr algn="l">
+          <a:bodyPr rtlCol="0" anchor="ctr" wrap="square" lIns="0" rIns="0" tIns="27432" bIns="27432"/>
+          <a:lstStyle/>
+          <a:p>
+            <a:pPr algn="ctr">
               <a:spcBef>
                 <a:spcPts val="0"/>
               </a:spcBef>
@@ -5549,40 +5493,82 @@
               </a:spcAft>
             </a:pPr>
             <a:r>
-              <a:rPr sz="2000" b="1" i="0" u="none">
-                <a:solidFill>
-                  <a:srgbClr val="002060"/>
-                </a:solidFill>
-                <a:latin typeface="Arial"/>
+              <a:rPr sz="2800" b="1" i="0" u="none" lang="en-US">
+                <a:solidFill>
+                  <a:srgbClr val="FFFFFF"/>
+                </a:solidFill>
+                <a:latin typeface="Aptos"/>
+                <a:ea typeface="Aptos"/>
+                <a:cs typeface="Aptos"/>
               </a:rPr>
-              <a:t>Hugging Face</a:t>
-            </a:r>
-          </a:p>
-        </p:txBody>
-      </p:sp>
-      <p:sp>
-        <p:nvSpPr>
-          <p:cNvPr id="37" name="Rounded Rectangle 36"/>
+              <a:t>2</a:t>
+            </a:r>
+          </a:p>
+        </p:txBody>
+      </p:sp>
+      <p:sp>
+        <p:nvSpPr>
+          <p:cNvPr id="33" name="TextBox 32"/>
+          <p:cNvSpPr txBox="1"/>
+          <p:nvPr/>
+        </p:nvSpPr>
+        <p:spPr>
+          <a:xfrm>
+            <a:off x="1691639" y="14840712"/>
+            <a:ext cx="13121640" cy="868680"/>
+          </a:xfrm>
+          <a:prstGeom prst="rect">
+            <a:avLst/>
+          </a:prstGeom>
+          <a:noFill/>
+        </p:spPr>
+        <p:txBody>
+          <a:bodyPr wrap="square" anchor="ctr" lIns="73152" rIns="73152" tIns="27432" bIns="27432">
+            <a:spAutoFit/>
+          </a:bodyPr>
+          <a:lstStyle/>
+          <a:p>
+            <a:pPr algn="l">
+              <a:spcBef>
+                <a:spcPts val="0"/>
+              </a:spcBef>
+              <a:spcAft>
+                <a:spcPts val="675"/>
+              </a:spcAft>
+            </a:pPr>
+            <a:r>
+              <a:rPr sz="2700" b="0" i="0" u="none" lang="en-US">
+                <a:solidFill>
+                  <a:srgbClr val="1F2937"/>
+                </a:solidFill>
+                <a:latin typeface="Aptos"/>
+                <a:ea typeface="Aptos"/>
+                <a:cs typeface="Aptos"/>
+              </a:rPr>
+              <a:t>Find which parts of the CodeS pipeline matter (ablation)</a:t>
+            </a:r>
+          </a:p>
+        </p:txBody>
+      </p:sp>
+      <p:sp>
+        <p:nvSpPr>
+          <p:cNvPr id="34" name="Oval 33"/>
           <p:cNvSpPr/>
           <p:nvPr/>
         </p:nvSpPr>
         <p:spPr>
           <a:xfrm>
-            <a:off x="11578590" y="5394960"/>
-            <a:ext cx="3463290" cy="1143000"/>
-          </a:xfrm>
-          <a:prstGeom prst="roundRect">
-            <a:avLst>
-              <a:gd name="adj" fmla="val 18000"/>
-            </a:avLst>
+            <a:off x="777240" y="15864840"/>
+            <a:ext cx="731520" cy="731520"/>
+          </a:xfrm>
+          <a:prstGeom prst="ellipse">
+            <a:avLst/>
           </a:prstGeom>
           <a:solidFill>
-            <a:srgbClr val="FFFFFF"/>
+            <a:srgbClr val="FFC000"/>
           </a:solidFill>
-          <a:ln w="19050">
-            <a:solidFill>
-              <a:srgbClr val="C9D3E0"/>
-            </a:solidFill>
+          <a:ln>
+            <a:noFill/>
           </a:ln>
           <a:effectLst/>
         </p:spPr>
@@ -5601,60 +5587,10 @@
           </a:fontRef>
         </p:style>
         <p:txBody>
-          <a:bodyPr rtlCol="0" anchor="ctr"/>
-          <a:lstStyle/>
-          <a:p>
-            <a:pPr algn="ctr"/>
-          </a:p>
-        </p:txBody>
-      </p:sp>
-      <p:pic>
-        <p:nvPicPr>
-          <p:cNvPr id="38" name="Picture 37" descr="brand_sqlite.png"/>
-          <p:cNvPicPr>
-            <a:picLocks noChangeAspect="1"/>
-          </p:cNvPicPr>
-          <p:nvPr/>
-        </p:nvPicPr>
-        <p:blipFill>
-          <a:blip r:embed="rId7"/>
-          <a:stretch>
-            <a:fillRect/>
-          </a:stretch>
-        </p:blipFill>
-        <p:spPr>
-          <a:xfrm>
-            <a:off x="11715750" y="5641848"/>
-            <a:ext cx="640080" cy="640080"/>
-          </a:xfrm>
-          <a:prstGeom prst="rect">
-            <a:avLst/>
-          </a:prstGeom>
-        </p:spPr>
-      </p:pic>
-      <p:sp>
-        <p:nvSpPr>
-          <p:cNvPr id="39" name="TextBox 38"/>
-          <p:cNvSpPr txBox="1"/>
-          <p:nvPr/>
-        </p:nvSpPr>
-        <p:spPr>
-          <a:xfrm>
-            <a:off x="12401550" y="5394960"/>
-            <a:ext cx="2594610" cy="1143000"/>
-          </a:xfrm>
-          <a:prstGeom prst="rect">
-            <a:avLst/>
-          </a:prstGeom>
-          <a:noFill/>
-        </p:spPr>
-        <p:txBody>
-          <a:bodyPr wrap="square" anchor="ctr" lIns="36576" rIns="36576" tIns="27432" bIns="27432">
-            <a:spAutoFit/>
-          </a:bodyPr>
-          <a:lstStyle/>
-          <a:p>
-            <a:pPr algn="l">
+          <a:bodyPr rtlCol="0" anchor="ctr" wrap="square" lIns="0" rIns="0" tIns="27432" bIns="27432"/>
+          <a:lstStyle/>
+          <a:p>
+            <a:pPr algn="ctr">
               <a:spcBef>
                 <a:spcPts val="0"/>
               </a:spcBef>
@@ -5663,40 +5599,82 @@
               </a:spcAft>
             </a:pPr>
             <a:r>
-              <a:rPr sz="2000" b="1" i="0" u="none">
-                <a:solidFill>
-                  <a:srgbClr val="002060"/>
-                </a:solidFill>
-                <a:latin typeface="Arial"/>
+              <a:rPr sz="2800" b="1" i="0" u="none" lang="en-US">
+                <a:solidFill>
+                  <a:srgbClr val="FFFFFF"/>
+                </a:solidFill>
+                <a:latin typeface="Aptos"/>
+                <a:ea typeface="Aptos"/>
+                <a:cs typeface="Aptos"/>
               </a:rPr>
-              <a:t>SQLite</a:t>
-            </a:r>
-          </a:p>
-        </p:txBody>
-      </p:sp>
-      <p:sp>
-        <p:nvSpPr>
-          <p:cNvPr id="40" name="Rounded Rectangle 39"/>
+              <a:t>3</a:t>
+            </a:r>
+          </a:p>
+        </p:txBody>
+      </p:sp>
+      <p:sp>
+        <p:nvSpPr>
+          <p:cNvPr id="35" name="TextBox 34"/>
+          <p:cNvSpPr txBox="1"/>
+          <p:nvPr/>
+        </p:nvSpPr>
+        <p:spPr>
+          <a:xfrm>
+            <a:off x="1691639" y="15800832"/>
+            <a:ext cx="13121640" cy="868680"/>
+          </a:xfrm>
+          <a:prstGeom prst="rect">
+            <a:avLst/>
+          </a:prstGeom>
+          <a:noFill/>
+        </p:spPr>
+        <p:txBody>
+          <a:bodyPr wrap="square" anchor="ctr" lIns="73152" rIns="73152" tIns="27432" bIns="27432">
+            <a:spAutoFit/>
+          </a:bodyPr>
+          <a:lstStyle/>
+          <a:p>
+            <a:pPr algn="l">
+              <a:spcBef>
+                <a:spcPts val="0"/>
+              </a:spcBef>
+              <a:spcAft>
+                <a:spcPts val="675"/>
+              </a:spcAft>
+            </a:pPr>
+            <a:r>
+              <a:rPr sz="2700" b="0" i="0" u="none" lang="en-US">
+                <a:solidFill>
+                  <a:srgbClr val="1F2937"/>
+                </a:solidFill>
+                <a:latin typeface="Aptos"/>
+                <a:ea typeface="Aptos"/>
+                <a:cs typeface="Aptos"/>
+              </a:rPr>
+              <a:t>Make the system say when it is unsure — tested statistically</a:t>
+            </a:r>
+          </a:p>
+        </p:txBody>
+      </p:sp>
+      <p:sp>
+        <p:nvSpPr>
+          <p:cNvPr id="36" name="Oval 35"/>
           <p:cNvSpPr/>
           <p:nvPr/>
         </p:nvSpPr>
         <p:spPr>
           <a:xfrm>
-            <a:off x="15224760" y="5394960"/>
-            <a:ext cx="3463290" cy="1143000"/>
-          </a:xfrm>
-          <a:prstGeom prst="roundRect">
-            <a:avLst>
-              <a:gd name="adj" fmla="val 18000"/>
-            </a:avLst>
+            <a:off x="777240" y="16824960"/>
+            <a:ext cx="731520" cy="731520"/>
+          </a:xfrm>
+          <a:prstGeom prst="ellipse">
+            <a:avLst/>
           </a:prstGeom>
           <a:solidFill>
-            <a:srgbClr val="FFFFFF"/>
+            <a:srgbClr val="C00000"/>
           </a:solidFill>
-          <a:ln w="19050">
-            <a:solidFill>
-              <a:srgbClr val="C9D3E0"/>
-            </a:solidFill>
+          <a:ln>
+            <a:noFill/>
           </a:ln>
           <a:effectLst/>
         </p:spPr>
@@ -5715,60 +5693,10 @@
           </a:fontRef>
         </p:style>
         <p:txBody>
-          <a:bodyPr rtlCol="0" anchor="ctr"/>
-          <a:lstStyle/>
-          <a:p>
-            <a:pPr algn="ctr"/>
-          </a:p>
-        </p:txBody>
-      </p:sp>
-      <p:pic>
-        <p:nvPicPr>
-          <p:cNvPr id="41" name="Picture 40" descr="brand_postgresql.png"/>
-          <p:cNvPicPr>
-            <a:picLocks noChangeAspect="1"/>
-          </p:cNvPicPr>
-          <p:nvPr/>
-        </p:nvPicPr>
-        <p:blipFill>
-          <a:blip r:embed="rId8"/>
-          <a:stretch>
-            <a:fillRect/>
-          </a:stretch>
-        </p:blipFill>
-        <p:spPr>
-          <a:xfrm>
-            <a:off x="15361920" y="5641848"/>
-            <a:ext cx="640080" cy="640080"/>
-          </a:xfrm>
-          <a:prstGeom prst="rect">
-            <a:avLst/>
-          </a:prstGeom>
-        </p:spPr>
-      </p:pic>
-      <p:sp>
-        <p:nvSpPr>
-          <p:cNvPr id="42" name="TextBox 41"/>
-          <p:cNvSpPr txBox="1"/>
-          <p:nvPr/>
-        </p:nvSpPr>
-        <p:spPr>
-          <a:xfrm>
-            <a:off x="16047720" y="5394960"/>
-            <a:ext cx="2594610" cy="1143000"/>
-          </a:xfrm>
-          <a:prstGeom prst="rect">
-            <a:avLst/>
-          </a:prstGeom>
-          <a:noFill/>
-        </p:spPr>
-        <p:txBody>
-          <a:bodyPr wrap="square" anchor="ctr" lIns="36576" rIns="36576" tIns="27432" bIns="27432">
-            <a:spAutoFit/>
-          </a:bodyPr>
-          <a:lstStyle/>
-          <a:p>
-            <a:pPr algn="l">
+          <a:bodyPr rtlCol="0" anchor="ctr" wrap="square" lIns="0" rIns="0" tIns="27432" bIns="27432"/>
+          <a:lstStyle/>
+          <a:p>
+            <a:pPr algn="ctr">
               <a:spcBef>
                 <a:spcPts val="0"/>
               </a:spcBef>
@@ -5777,40 +5705,82 @@
               </a:spcAft>
             </a:pPr>
             <a:r>
-              <a:rPr sz="2000" b="1" i="0" u="none">
-                <a:solidFill>
-                  <a:srgbClr val="002060"/>
-                </a:solidFill>
-                <a:latin typeface="Arial"/>
+              <a:rPr sz="2800" b="1" i="0" u="none" lang="en-US">
+                <a:solidFill>
+                  <a:srgbClr val="FFFFFF"/>
+                </a:solidFill>
+                <a:latin typeface="Aptos"/>
+                <a:ea typeface="Aptos"/>
+                <a:cs typeface="Aptos"/>
               </a:rPr>
-              <a:t>PostgreSQL · MySQL</a:t>
-            </a:r>
-          </a:p>
-        </p:txBody>
-      </p:sp>
-      <p:sp>
-        <p:nvSpPr>
-          <p:cNvPr id="43" name="Rounded Rectangle 42"/>
+              <a:t>4</a:t>
+            </a:r>
+          </a:p>
+        </p:txBody>
+      </p:sp>
+      <p:sp>
+        <p:nvSpPr>
+          <p:cNvPr id="37" name="TextBox 36"/>
+          <p:cNvSpPr txBox="1"/>
+          <p:nvPr/>
+        </p:nvSpPr>
+        <p:spPr>
+          <a:xfrm>
+            <a:off x="1691639" y="16760951"/>
+            <a:ext cx="13121640" cy="868680"/>
+          </a:xfrm>
+          <a:prstGeom prst="rect">
+            <a:avLst/>
+          </a:prstGeom>
+          <a:noFill/>
+        </p:spPr>
+        <p:txBody>
+          <a:bodyPr wrap="square" anchor="ctr" lIns="73152" rIns="73152" tIns="27432" bIns="27432">
+            <a:spAutoFit/>
+          </a:bodyPr>
+          <a:lstStyle/>
+          <a:p>
+            <a:pPr algn="l">
+              <a:spcBef>
+                <a:spcPts val="0"/>
+              </a:spcBef>
+              <a:spcAft>
+                <a:spcPts val="675"/>
+              </a:spcAft>
+            </a:pPr>
+            <a:r>
+              <a:rPr sz="2700" b="0" i="0" u="none" lang="en-US">
+                <a:solidFill>
+                  <a:srgbClr val="1F2937"/>
+                </a:solidFill>
+                <a:latin typeface="Aptos"/>
+                <a:ea typeface="Aptos"/>
+                <a:cs typeface="Aptos"/>
+              </a:rPr>
+              <a:t>Measure accuracy on realistically worded questions</a:t>
+            </a:r>
+          </a:p>
+        </p:txBody>
+      </p:sp>
+      <p:sp>
+        <p:nvSpPr>
+          <p:cNvPr id="38" name="Oval 37"/>
           <p:cNvSpPr/>
           <p:nvPr/>
         </p:nvSpPr>
         <p:spPr>
           <a:xfrm>
-            <a:off x="18870930" y="5394960"/>
-            <a:ext cx="3463290" cy="1143000"/>
-          </a:xfrm>
-          <a:prstGeom prst="roundRect">
-            <a:avLst>
-              <a:gd name="adj" fmla="val 18000"/>
-            </a:avLst>
+            <a:off x="777240" y="17785080"/>
+            <a:ext cx="731520" cy="731520"/>
+          </a:xfrm>
+          <a:prstGeom prst="ellipse">
+            <a:avLst/>
           </a:prstGeom>
           <a:solidFill>
-            <a:srgbClr val="FFFFFF"/>
+            <a:srgbClr val="7030A0"/>
           </a:solidFill>
-          <a:ln w="19050">
-            <a:solidFill>
-              <a:srgbClr val="C9D3E0"/>
-            </a:solidFill>
+          <a:ln>
+            <a:noFill/>
           </a:ln>
           <a:effectLst/>
         </p:spPr>
@@ -5829,60 +5799,10 @@
           </a:fontRef>
         </p:style>
         <p:txBody>
-          <a:bodyPr rtlCol="0" anchor="ctr"/>
-          <a:lstStyle/>
-          <a:p>
-            <a:pPr algn="ctr"/>
-          </a:p>
-        </p:txBody>
-      </p:sp>
-      <p:pic>
-        <p:nvPicPr>
-          <p:cNvPr id="44" name="Picture 43" descr="monitor-smartphone_navy.png"/>
-          <p:cNvPicPr>
-            <a:picLocks noChangeAspect="1"/>
-          </p:cNvPicPr>
-          <p:nvPr/>
-        </p:nvPicPr>
-        <p:blipFill>
-          <a:blip r:embed="rId9"/>
-          <a:stretch>
-            <a:fillRect/>
-          </a:stretch>
-        </p:blipFill>
-        <p:spPr>
-          <a:xfrm>
-            <a:off x="19008089" y="5641848"/>
-            <a:ext cx="640080" cy="640080"/>
-          </a:xfrm>
-          <a:prstGeom prst="rect">
-            <a:avLst/>
-          </a:prstGeom>
-        </p:spPr>
-      </p:pic>
-      <p:sp>
-        <p:nvSpPr>
-          <p:cNvPr id="45" name="TextBox 44"/>
-          <p:cNvSpPr txBox="1"/>
-          <p:nvPr/>
-        </p:nvSpPr>
-        <p:spPr>
-          <a:xfrm>
-            <a:off x="19693889" y="5394960"/>
-            <a:ext cx="2594610" cy="1143000"/>
-          </a:xfrm>
-          <a:prstGeom prst="rect">
-            <a:avLst/>
-          </a:prstGeom>
-          <a:noFill/>
-        </p:spPr>
-        <p:txBody>
-          <a:bodyPr wrap="square" anchor="ctr" lIns="36576" rIns="36576" tIns="27432" bIns="27432">
-            <a:spAutoFit/>
-          </a:bodyPr>
-          <a:lstStyle/>
-          <a:p>
-            <a:pPr algn="l">
+          <a:bodyPr rtlCol="0" anchor="ctr" wrap="square" lIns="0" rIns="0" tIns="27432" bIns="27432"/>
+          <a:lstStyle/>
+          <a:p>
+            <a:pPr algn="ctr">
               <a:spcBef>
                 <a:spcPts val="0"/>
               </a:spcBef>
@@ -5891,40 +5811,82 @@
               </a:spcAft>
             </a:pPr>
             <a:r>
-              <a:rPr sz="2000" b="1" i="0" u="none">
-                <a:solidFill>
-                  <a:srgbClr val="002060"/>
-                </a:solidFill>
-                <a:latin typeface="Arial"/>
+              <a:rPr sz="2800" b="1" i="0" u="none" lang="en-US">
+                <a:solidFill>
+                  <a:srgbClr val="FFFFFF"/>
+                </a:solidFill>
+                <a:latin typeface="Aptos"/>
+                <a:ea typeface="Aptos"/>
+                <a:cs typeface="Aptos"/>
               </a:rPr>
-              <a:t>macOS · Windows app</a:t>
-            </a:r>
-          </a:p>
-        </p:txBody>
-      </p:sp>
-      <p:sp>
-        <p:nvSpPr>
-          <p:cNvPr id="46" name="Rounded Rectangle 45"/>
+              <a:t>5</a:t>
+            </a:r>
+          </a:p>
+        </p:txBody>
+      </p:sp>
+      <p:sp>
+        <p:nvSpPr>
+          <p:cNvPr id="39" name="TextBox 38"/>
+          <p:cNvSpPr txBox="1"/>
+          <p:nvPr/>
+        </p:nvSpPr>
+        <p:spPr>
+          <a:xfrm>
+            <a:off x="1691639" y="17721072"/>
+            <a:ext cx="13121640" cy="868680"/>
+          </a:xfrm>
+          <a:prstGeom prst="rect">
+            <a:avLst/>
+          </a:prstGeom>
+          <a:noFill/>
+        </p:spPr>
+        <p:txBody>
+          <a:bodyPr wrap="square" anchor="ctr" lIns="73152" rIns="73152" tIns="27432" bIns="27432">
+            <a:spAutoFit/>
+          </a:bodyPr>
+          <a:lstStyle/>
+          <a:p>
+            <a:pPr algn="l">
+              <a:spcBef>
+                <a:spcPts val="0"/>
+              </a:spcBef>
+              <a:spcAft>
+                <a:spcPts val="675"/>
+              </a:spcAft>
+            </a:pPr>
+            <a:r>
+              <a:rPr sz="2700" b="0" i="0" u="none" lang="en-US">
+                <a:solidFill>
+                  <a:srgbClr val="1F2937"/>
+                </a:solidFill>
+                <a:latin typeface="Aptos"/>
+                <a:ea typeface="Aptos"/>
+                <a:cs typeface="Aptos"/>
+              </a:rPr>
+              <a:t>Deliver a desktop app that runs fully locally</a:t>
+            </a:r>
+          </a:p>
+        </p:txBody>
+      </p:sp>
+      <p:sp>
+        <p:nvSpPr>
+          <p:cNvPr id="40" name="Rectangle 39"/>
           <p:cNvSpPr/>
           <p:nvPr/>
         </p:nvSpPr>
         <p:spPr>
           <a:xfrm>
-            <a:off x="22517100" y="5394960"/>
-            <a:ext cx="3463290" cy="1143000"/>
-          </a:xfrm>
-          <a:prstGeom prst="roundRect">
-            <a:avLst>
-              <a:gd name="adj" fmla="val 18000"/>
-            </a:avLst>
+            <a:off x="640080" y="18882360"/>
+            <a:ext cx="14264640" cy="731520"/>
+          </a:xfrm>
+          <a:prstGeom prst="rect">
+            <a:avLst/>
           </a:prstGeom>
           <a:solidFill>
-            <a:srgbClr val="FFFFFF"/>
+            <a:srgbClr val="C00000"/>
           </a:solidFill>
-          <a:ln w="19050">
-            <a:solidFill>
-              <a:srgbClr val="C9D3E0"/>
-            </a:solidFill>
+          <a:ln>
+            <a:noFill/>
           </a:ln>
           <a:effectLst/>
         </p:spPr>
@@ -5943,60 +5905,10 @@
           </a:fontRef>
         </p:style>
         <p:txBody>
-          <a:bodyPr rtlCol="0" anchor="ctr"/>
-          <a:lstStyle/>
-          <a:p>
-            <a:pPr algn="ctr"/>
-          </a:p>
-        </p:txBody>
-      </p:sp>
-      <p:pic>
-        <p:nvPicPr>
-          <p:cNvPr id="47" name="Picture 46" descr="badge-check_green.png"/>
-          <p:cNvPicPr>
-            <a:picLocks noChangeAspect="1"/>
-          </p:cNvPicPr>
-          <p:nvPr/>
-        </p:nvPicPr>
-        <p:blipFill>
-          <a:blip r:embed="rId10"/>
-          <a:stretch>
-            <a:fillRect/>
-          </a:stretch>
-        </p:blipFill>
-        <p:spPr>
-          <a:xfrm>
-            <a:off x="22654260" y="5641848"/>
-            <a:ext cx="640080" cy="640080"/>
-          </a:xfrm>
-          <a:prstGeom prst="rect">
-            <a:avLst/>
-          </a:prstGeom>
-        </p:spPr>
-      </p:pic>
-      <p:sp>
-        <p:nvSpPr>
-          <p:cNvPr id="48" name="TextBox 47"/>
-          <p:cNvSpPr txBox="1"/>
-          <p:nvPr/>
-        </p:nvSpPr>
-        <p:spPr>
-          <a:xfrm>
-            <a:off x="23340060" y="5394960"/>
-            <a:ext cx="2594610" cy="1143000"/>
-          </a:xfrm>
-          <a:prstGeom prst="rect">
-            <a:avLst/>
-          </a:prstGeom>
-          <a:noFill/>
-        </p:spPr>
-        <p:txBody>
-          <a:bodyPr wrap="square" anchor="ctr" lIns="36576" rIns="36576" tIns="27432" bIns="27432">
-            <a:spAutoFit/>
-          </a:bodyPr>
-          <a:lstStyle/>
-          <a:p>
-            <a:pPr algn="l">
+          <a:bodyPr rtlCol="0" anchor="ctr" wrap="square" lIns="73152" rIns="73152" tIns="27432" bIns="27432"/>
+          <a:lstStyle/>
+          <a:p>
+            <a:pPr algn="ctr">
               <a:spcBef>
                 <a:spcPts val="0"/>
               </a:spcBef>
@@ -6005,40 +5917,394 @@
               </a:spcAft>
             </a:pPr>
             <a:r>
-              <a:rPr sz="2000" b="1" i="0" u="none">
+              <a:rPr sz="3800" b="1" i="0" u="sng" lang="en-US">
+                <a:solidFill>
+                  <a:srgbClr val="FFFFFF"/>
+                </a:solidFill>
+                <a:latin typeface="Aptos"/>
+                <a:ea typeface="Aptos"/>
+                <a:cs typeface="Aptos"/>
+              </a:rPr>
+              <a:t>Key Innovations &amp; Contributions</a:t>
+            </a:r>
+          </a:p>
+        </p:txBody>
+      </p:sp>
+      <p:pic>
+        <p:nvPicPr>
+          <p:cNvPr id="41" name="Picture 40" descr="shield-check_blue.png"/>
+          <p:cNvPicPr>
+            <a:picLocks noChangeAspect="1"/>
+          </p:cNvPicPr>
+          <p:nvPr/>
+        </p:nvPicPr>
+        <p:blipFill>
+          <a:blip r:embed="rId4"/>
+          <a:stretch>
+            <a:fillRect/>
+          </a:stretch>
+        </p:blipFill>
+        <p:spPr>
+          <a:xfrm>
+            <a:off x="822959" y="19961352"/>
+            <a:ext cx="868680" cy="868680"/>
+          </a:xfrm>
+          <a:prstGeom prst="rect">
+            <a:avLst/>
+          </a:prstGeom>
+        </p:spPr>
+      </p:pic>
+      <p:sp>
+        <p:nvSpPr>
+          <p:cNvPr id="42" name="TextBox 41"/>
+          <p:cNvSpPr txBox="1"/>
+          <p:nvPr/>
+        </p:nvSpPr>
+        <p:spPr>
+          <a:xfrm>
+            <a:off x="1920239" y="19796760"/>
+            <a:ext cx="12893040" cy="1536192"/>
+          </a:xfrm>
+          <a:prstGeom prst="rect">
+            <a:avLst/>
+          </a:prstGeom>
+          <a:noFill/>
+        </p:spPr>
+        <p:txBody>
+          <a:bodyPr wrap="square" anchor="t" lIns="73152" rIns="73152" tIns="27432" bIns="27432">
+            <a:spAutoFit/>
+          </a:bodyPr>
+          <a:lstStyle/>
+          <a:p>
+            <a:pPr algn="l">
+              <a:spcBef>
+                <a:spcPts val="0"/>
+              </a:spcBef>
+              <a:spcAft>
+                <a:spcPts val="104"/>
+              </a:spcAft>
+            </a:pPr>
+            <a:r>
+              <a:rPr sz="2700" b="1" i="0" u="none" lang="en-US">
                 <a:solidFill>
                   <a:srgbClr val="002060"/>
                 </a:solidFill>
-                <a:latin typeface="Arial"/>
+                <a:latin typeface="Aptos"/>
+                <a:ea typeface="Aptos"/>
+                <a:cs typeface="Aptos"/>
               </a:rPr>
-              <a:t>45 tests</a:t>
-            </a:r>
-          </a:p>
-        </p:txBody>
-      </p:sp>
-      <p:sp>
-        <p:nvSpPr>
-          <p:cNvPr id="49" name="Rounded Rectangle 48"/>
+              <a:t>1. Confidence-aware abstention</a:t>
+            </a:r>
+          </a:p>
+          <a:p>
+            <a:pPr algn="l">
+              <a:spcBef>
+                <a:spcPts val="0"/>
+              </a:spcBef>
+              <a:spcAft>
+                <a:spcPts val="104"/>
+              </a:spcAft>
+            </a:pPr>
+            <a:r>
+              <a:rPr sz="2300" b="0" i="0" u="none" lang="en-US">
+                <a:solidFill>
+                  <a:srgbClr val="1F2937"/>
+                </a:solidFill>
+                <a:latin typeface="Aptos"/>
+                <a:ea typeface="Aptos"/>
+                <a:cs typeface="Aptos"/>
+              </a:rPr>
+              <a:t>Run all candidate queries, count how many agree; ask “Did you mean…?” when they don't</a:t>
+            </a:r>
+          </a:p>
+        </p:txBody>
+      </p:sp>
+      <p:pic>
+        <p:nvPicPr>
+          <p:cNvPr id="43" name="Picture 42" descr="badge-check_blue.png"/>
+          <p:cNvPicPr>
+            <a:picLocks noChangeAspect="1"/>
+          </p:cNvPicPr>
+          <p:nvPr/>
+        </p:nvPicPr>
+        <p:blipFill>
+          <a:blip r:embed="rId5"/>
+          <a:stretch>
+            <a:fillRect/>
+          </a:stretch>
+        </p:blipFill>
+        <p:spPr>
+          <a:xfrm>
+            <a:off x="822959" y="21534119"/>
+            <a:ext cx="868680" cy="868680"/>
+          </a:xfrm>
+          <a:prstGeom prst="rect">
+            <a:avLst/>
+          </a:prstGeom>
+        </p:spPr>
+      </p:pic>
+      <p:sp>
+        <p:nvSpPr>
+          <p:cNvPr id="44" name="TextBox 43"/>
+          <p:cNvSpPr txBox="1"/>
+          <p:nvPr/>
+        </p:nvSpPr>
+        <p:spPr>
+          <a:xfrm>
+            <a:off x="1920239" y="21369527"/>
+            <a:ext cx="12893040" cy="1536192"/>
+          </a:xfrm>
+          <a:prstGeom prst="rect">
+            <a:avLst/>
+          </a:prstGeom>
+          <a:noFill/>
+        </p:spPr>
+        <p:txBody>
+          <a:bodyPr wrap="square" anchor="t" lIns="73152" rIns="73152" tIns="27432" bIns="27432">
+            <a:spAutoFit/>
+          </a:bodyPr>
+          <a:lstStyle/>
+          <a:p>
+            <a:pPr algn="l">
+              <a:spcBef>
+                <a:spcPts val="0"/>
+              </a:spcBef>
+              <a:spcAft>
+                <a:spcPts val="104"/>
+              </a:spcAft>
+            </a:pPr>
+            <a:r>
+              <a:rPr sz="2700" b="1" i="0" u="none" lang="en-US">
+                <a:solidFill>
+                  <a:srgbClr val="002060"/>
+                </a:solidFill>
+                <a:latin typeface="Aptos"/>
+                <a:ea typeface="Aptos"/>
+                <a:cs typeface="Aptos"/>
+              </a:rPr>
+              <a:t>2. Faithful, audited reproduction</a:t>
+            </a:r>
+          </a:p>
+          <a:p>
+            <a:pPr algn="l">
+              <a:spcBef>
+                <a:spcPts val="0"/>
+              </a:spcBef>
+              <a:spcAft>
+                <a:spcPts val="104"/>
+              </a:spcAft>
+            </a:pPr>
+            <a:r>
+              <a:rPr sz="2300" b="0" i="0" u="none" lang="en-US">
+                <a:solidFill>
+                  <a:srgbClr val="1F2937"/>
+                </a:solidFill>
+                <a:latin typeface="Aptos"/>
+                <a:ea typeface="Aptos"/>
+                <a:cs typeface="Aptos"/>
+              </a:rPr>
+              <a:t>77.8% vs 77.9% with the official evaluator, after auditing our own harness</a:t>
+            </a:r>
+          </a:p>
+        </p:txBody>
+      </p:sp>
+      <p:pic>
+        <p:nvPicPr>
+          <p:cNvPr id="45" name="Picture 44" descr="refresh-cw_blue.png"/>
+          <p:cNvPicPr>
+            <a:picLocks noChangeAspect="1"/>
+          </p:cNvPicPr>
+          <p:nvPr/>
+        </p:nvPicPr>
+        <p:blipFill>
+          <a:blip r:embed="rId6"/>
+          <a:stretch>
+            <a:fillRect/>
+          </a:stretch>
+        </p:blipFill>
+        <p:spPr>
+          <a:xfrm>
+            <a:off x="822959" y="23106888"/>
+            <a:ext cx="868680" cy="868680"/>
+          </a:xfrm>
+          <a:prstGeom prst="rect">
+            <a:avLst/>
+          </a:prstGeom>
+        </p:spPr>
+      </p:pic>
+      <p:sp>
+        <p:nvSpPr>
+          <p:cNvPr id="46" name="TextBox 45"/>
+          <p:cNvSpPr txBox="1"/>
+          <p:nvPr/>
+        </p:nvSpPr>
+        <p:spPr>
+          <a:xfrm>
+            <a:off x="1920239" y="22942296"/>
+            <a:ext cx="12893040" cy="1536192"/>
+          </a:xfrm>
+          <a:prstGeom prst="rect">
+            <a:avLst/>
+          </a:prstGeom>
+          <a:noFill/>
+        </p:spPr>
+        <p:txBody>
+          <a:bodyPr wrap="square" anchor="t" lIns="73152" rIns="73152" tIns="27432" bIns="27432">
+            <a:spAutoFit/>
+          </a:bodyPr>
+          <a:lstStyle/>
+          <a:p>
+            <a:pPr algn="l">
+              <a:spcBef>
+                <a:spcPts val="0"/>
+              </a:spcBef>
+              <a:spcAft>
+                <a:spcPts val="104"/>
+              </a:spcAft>
+            </a:pPr>
+            <a:r>
+              <a:rPr sz="2700" b="1" i="0" u="none" lang="en-US">
+                <a:solidFill>
+                  <a:srgbClr val="002060"/>
+                </a:solidFill>
+                <a:latin typeface="Aptos"/>
+                <a:ea typeface="Aptos"/>
+                <a:cs typeface="Aptos"/>
+              </a:rPr>
+              <a:t>3. Execution-guided self-correction</a:t>
+            </a:r>
+          </a:p>
+          <a:p>
+            <a:pPr algn="l">
+              <a:spcBef>
+                <a:spcPts val="0"/>
+              </a:spcBef>
+              <a:spcAft>
+                <a:spcPts val="104"/>
+              </a:spcAft>
+            </a:pPr>
+            <a:r>
+              <a:rPr sz="2300" b="0" i="0" u="none" lang="en-US">
+                <a:solidFill>
+                  <a:srgbClr val="1F2937"/>
+                </a:solidFill>
+                <a:latin typeface="Aptos"/>
+                <a:ea typeface="Aptos"/>
+                <a:cs typeface="Aptos"/>
+              </a:rPr>
+              <a:t>A failed query goes back to the model with the database error</a:t>
+            </a:r>
+          </a:p>
+        </p:txBody>
+      </p:sp>
+      <p:pic>
+        <p:nvPicPr>
+          <p:cNvPr id="47" name="Picture 46" descr="lock-keyhole_blue.png"/>
+          <p:cNvPicPr>
+            <a:picLocks noChangeAspect="1"/>
+          </p:cNvPicPr>
+          <p:nvPr/>
+        </p:nvPicPr>
+        <p:blipFill>
+          <a:blip r:embed="rId7"/>
+          <a:stretch>
+            <a:fillRect/>
+          </a:stretch>
+        </p:blipFill>
+        <p:spPr>
+          <a:xfrm>
+            <a:off x="822959" y="24679656"/>
+            <a:ext cx="868680" cy="868680"/>
+          </a:xfrm>
+          <a:prstGeom prst="rect">
+            <a:avLst/>
+          </a:prstGeom>
+        </p:spPr>
+      </p:pic>
+      <p:sp>
+        <p:nvSpPr>
+          <p:cNvPr id="48" name="TextBox 47"/>
+          <p:cNvSpPr txBox="1"/>
+          <p:nvPr/>
+        </p:nvSpPr>
+        <p:spPr>
+          <a:xfrm>
+            <a:off x="1920239" y="24515064"/>
+            <a:ext cx="12893040" cy="1536192"/>
+          </a:xfrm>
+          <a:prstGeom prst="rect">
+            <a:avLst/>
+          </a:prstGeom>
+          <a:noFill/>
+        </p:spPr>
+        <p:txBody>
+          <a:bodyPr wrap="square" anchor="t" lIns="73152" rIns="73152" tIns="27432" bIns="27432">
+            <a:spAutoFit/>
+          </a:bodyPr>
+          <a:lstStyle/>
+          <a:p>
+            <a:pPr algn="l">
+              <a:spcBef>
+                <a:spcPts val="0"/>
+              </a:spcBef>
+              <a:spcAft>
+                <a:spcPts val="104"/>
+              </a:spcAft>
+            </a:pPr>
+            <a:r>
+              <a:rPr sz="2700" b="1" i="0" u="none" lang="en-US">
+                <a:solidFill>
+                  <a:srgbClr val="002060"/>
+                </a:solidFill>
+                <a:latin typeface="Aptos"/>
+                <a:ea typeface="Aptos"/>
+                <a:cs typeface="Aptos"/>
+              </a:rPr>
+              <a:t>4. Private by design</a:t>
+            </a:r>
+          </a:p>
+          <a:p>
+            <a:pPr algn="l">
+              <a:spcBef>
+                <a:spcPts val="0"/>
+              </a:spcBef>
+              <a:spcAft>
+                <a:spcPts val="104"/>
+              </a:spcAft>
+            </a:pPr>
+            <a:r>
+              <a:rPr sz="2300" b="0" i="0" u="none" lang="en-US">
+                <a:solidFill>
+                  <a:srgbClr val="1F2937"/>
+                </a:solidFill>
+                <a:latin typeface="Aptos"/>
+                <a:ea typeface="Aptos"/>
+                <a:cs typeface="Aptos"/>
+              </a:rPr>
+              <a:t>Open weights, runs on the user's computer — no schema sent to a third party</a:t>
+            </a:r>
+          </a:p>
+        </p:txBody>
+      </p:sp>
+      <p:sp>
+        <p:nvSpPr>
+          <p:cNvPr id="49" name="Rectangle 48"/>
           <p:cNvSpPr/>
           <p:nvPr/>
         </p:nvSpPr>
         <p:spPr>
           <a:xfrm>
-            <a:off x="26163270" y="5394960"/>
-            <a:ext cx="3463290" cy="1143000"/>
-          </a:xfrm>
-          <a:prstGeom prst="roundRect">
-            <a:avLst>
-              <a:gd name="adj" fmla="val 18000"/>
-            </a:avLst>
+            <a:off x="640080" y="26197560"/>
+            <a:ext cx="14264640" cy="731520"/>
+          </a:xfrm>
+          <a:prstGeom prst="rect">
+            <a:avLst/>
           </a:prstGeom>
           <a:solidFill>
-            <a:srgbClr val="FFFFFF"/>
+            <a:srgbClr val="C00000"/>
           </a:solidFill>
-          <a:ln w="19050">
-            <a:solidFill>
-              <a:srgbClr val="C9D3E0"/>
-            </a:solidFill>
+          <a:ln>
+            <a:noFill/>
           </a:ln>
           <a:effectLst/>
         </p:spPr>
@@ -6057,217 +6323,7 @@
           </a:fontRef>
         </p:style>
         <p:txBody>
-          <a:bodyPr rtlCol="0" anchor="ctr"/>
-          <a:lstStyle/>
-          <a:p>
-            <a:pPr algn="ctr"/>
-          </a:p>
-        </p:txBody>
-      </p:sp>
-      <p:pic>
-        <p:nvPicPr>
-          <p:cNvPr id="50" name="Picture 49" descr="brand_github.png"/>
-          <p:cNvPicPr>
-            <a:picLocks noChangeAspect="1"/>
-          </p:cNvPicPr>
-          <p:nvPr/>
-        </p:nvPicPr>
-        <p:blipFill>
-          <a:blip r:embed="rId11"/>
-          <a:stretch>
-            <a:fillRect/>
-          </a:stretch>
-        </p:blipFill>
-        <p:spPr>
-          <a:xfrm>
-            <a:off x="26300430" y="5641848"/>
-            <a:ext cx="640080" cy="640080"/>
-          </a:xfrm>
-          <a:prstGeom prst="rect">
-            <a:avLst/>
-          </a:prstGeom>
-        </p:spPr>
-      </p:pic>
-      <p:sp>
-        <p:nvSpPr>
-          <p:cNvPr id="51" name="TextBox 50"/>
-          <p:cNvSpPr txBox="1"/>
-          <p:nvPr/>
-        </p:nvSpPr>
-        <p:spPr>
-          <a:xfrm>
-            <a:off x="26986230" y="5394960"/>
-            <a:ext cx="2594610" cy="1143000"/>
-          </a:xfrm>
-          <a:prstGeom prst="rect">
-            <a:avLst/>
-          </a:prstGeom>
-          <a:noFill/>
-        </p:spPr>
-        <p:txBody>
-          <a:bodyPr wrap="square" anchor="ctr" lIns="36576" rIns="36576" tIns="27432" bIns="27432">
-            <a:spAutoFit/>
-          </a:bodyPr>
-          <a:lstStyle/>
-          <a:p>
-            <a:pPr algn="l">
-              <a:spcBef>
-                <a:spcPts val="0"/>
-              </a:spcBef>
-              <a:spcAft>
-                <a:spcPts val="650"/>
-              </a:spcAft>
-            </a:pPr>
-            <a:r>
-              <a:rPr sz="2000" b="1" i="0" u="none">
-                <a:solidFill>
-                  <a:srgbClr val="002060"/>
-                </a:solidFill>
-                <a:latin typeface="Arial"/>
-              </a:rPr>
-              <a:t>Open source · GitHub</a:t>
-            </a:r>
-          </a:p>
-        </p:txBody>
-      </p:sp>
-      <p:sp>
-        <p:nvSpPr>
-          <p:cNvPr id="52" name="Rounded Rectangle 51"/>
-          <p:cNvSpPr/>
-          <p:nvPr/>
-        </p:nvSpPr>
-        <p:spPr>
-          <a:xfrm>
-            <a:off x="640080" y="7680960"/>
-            <a:ext cx="14264640" cy="5074920"/>
-          </a:xfrm>
-          <a:prstGeom prst="roundRect">
-            <a:avLst>
-              <a:gd name="adj" fmla="val 5000"/>
-            </a:avLst>
-          </a:prstGeom>
-          <a:solidFill>
-            <a:srgbClr val="FFFFFF"/>
-          </a:solidFill>
-          <a:ln w="19050">
-            <a:solidFill>
-              <a:srgbClr val="C9D3E0"/>
-            </a:solidFill>
-            <a:prstDash val="dash"/>
-          </a:ln>
-          <a:effectLst/>
-        </p:spPr>
-        <p:style>
-          <a:lnRef idx="1">
-            <a:schemeClr val="accent1"/>
-          </a:lnRef>
-          <a:fillRef idx="3">
-            <a:schemeClr val="accent1"/>
-          </a:fillRef>
-          <a:effectRef idx="2">
-            <a:schemeClr val="accent1"/>
-          </a:effectRef>
-          <a:fontRef idx="minor">
-            <a:schemeClr val="lt1"/>
-          </a:fontRef>
-        </p:style>
-        <p:txBody>
-          <a:bodyPr rtlCol="0" anchor="ctr"/>
-          <a:lstStyle/>
-          <a:p>
-            <a:pPr algn="ctr"/>
-          </a:p>
-        </p:txBody>
-      </p:sp>
-      <p:sp>
-        <p:nvSpPr>
-          <p:cNvPr id="53" name="TextBox 52"/>
-          <p:cNvSpPr txBox="1"/>
-          <p:nvPr/>
-        </p:nvSpPr>
-        <p:spPr>
-          <a:xfrm>
-            <a:off x="777240" y="7772400"/>
-            <a:ext cx="13990319" cy="4937760"/>
-          </a:xfrm>
-          <a:prstGeom prst="rect">
-            <a:avLst/>
-          </a:prstGeom>
-          <a:noFill/>
-        </p:spPr>
-        <p:txBody>
-          <a:bodyPr wrap="square" anchor="t" lIns="73152" rIns="73152" tIns="27432" bIns="27432">
-            <a:spAutoFit/>
-          </a:bodyPr>
-          <a:lstStyle/>
-          <a:p>
-            <a:pPr algn="l">
-              <a:spcBef>
-                <a:spcPts val="0"/>
-              </a:spcBef>
-              <a:spcAft>
-                <a:spcPts val="775"/>
-              </a:spcAft>
-            </a:pPr>
-            <a:r>
-              <a:rPr sz="3100" b="1" i="0" u="none">
-                <a:solidFill>
-                  <a:srgbClr val="1F2937"/>
-                </a:solidFill>
-                <a:latin typeface="Arial"/>
-              </a:rPr>
-              <a:t>QueryGenie</a:t>
-            </a:r>
-            <a:r>
-              <a:rPr sz="3100" b="0" i="0" u="none">
-                <a:solidFill>
-                  <a:srgbClr val="1F2937"/>
-                </a:solidFill>
-                <a:latin typeface="Arial"/>
-              </a:rPr>
-              <a:t> lets anyone ask a database questions in plain English. Text-to-SQL models answer every question with the same confidence, so a wrong answer looks exactly like a right one. We reproduce CodeS (SIGMOD 2024), an open-source text-to-SQL model, to 77.8% execution accuracy on Spider (paper: 77.9%), and add confidence-aware abstention: the system runs every candidate query the model writes and checks whether they agree. When they don't, it asks the user instead of guessing. It answers 90.4% of questions and is right on 83.3% of them, with a third fewer wrong answers — a statistically significant gain. It runs fully locally in a desktop app.</a:t>
-            </a:r>
-          </a:p>
-        </p:txBody>
-      </p:sp>
-      <p:sp>
-        <p:nvSpPr>
-          <p:cNvPr id="54" name="Oval 53"/>
-          <p:cNvSpPr/>
-          <p:nvPr/>
-        </p:nvSpPr>
-        <p:spPr>
-          <a:xfrm>
-            <a:off x="777240" y="13944600"/>
-            <a:ext cx="731520" cy="731520"/>
-          </a:xfrm>
-          <a:prstGeom prst="ellipse">
-            <a:avLst/>
-          </a:prstGeom>
-          <a:solidFill>
-            <a:srgbClr val="0070C0"/>
-          </a:solidFill>
-          <a:ln>
-            <a:noFill/>
-          </a:ln>
-          <a:effectLst/>
-        </p:spPr>
-        <p:style>
-          <a:lnRef idx="1">
-            <a:schemeClr val="accent1"/>
-          </a:lnRef>
-          <a:fillRef idx="3">
-            <a:schemeClr val="accent1"/>
-          </a:fillRef>
-          <a:effectRef idx="2">
-            <a:schemeClr val="accent1"/>
-          </a:effectRef>
-          <a:fontRef idx="minor">
-            <a:schemeClr val="lt1"/>
-          </a:fontRef>
-        </p:style>
-        <p:txBody>
-          <a:bodyPr rtlCol="0" anchor="ctr" wrap="square" lIns="0" rIns="0" tIns="27432" bIns="27432"/>
+          <a:bodyPr rtlCol="0" anchor="ctr" wrap="square" lIns="73152" rIns="73152" tIns="27432" bIns="27432"/>
           <a:lstStyle/>
           <a:p>
             <a:pPr algn="ctr">
@@ -6279,921 +6335,13 @@
               </a:spcAft>
             </a:pPr>
             <a:r>
-              <a:rPr sz="2800" b="1" i="0" u="none">
+              <a:rPr sz="3800" b="1" i="0" u="sng" lang="en-US">
                 <a:solidFill>
                   <a:srgbClr val="FFFFFF"/>
                 </a:solidFill>
-                <a:latin typeface="Arial"/>
-              </a:rPr>
-              <a:t>1</a:t>
-            </a:r>
-          </a:p>
-        </p:txBody>
-      </p:sp>
-      <p:sp>
-        <p:nvSpPr>
-          <p:cNvPr id="55" name="TextBox 54"/>
-          <p:cNvSpPr txBox="1"/>
-          <p:nvPr/>
-        </p:nvSpPr>
-        <p:spPr>
-          <a:xfrm>
-            <a:off x="1691639" y="13880592"/>
-            <a:ext cx="13121640" cy="868680"/>
-          </a:xfrm>
-          <a:prstGeom prst="rect">
-            <a:avLst/>
-          </a:prstGeom>
-          <a:noFill/>
-        </p:spPr>
-        <p:txBody>
-          <a:bodyPr wrap="square" anchor="ctr" lIns="73152" rIns="73152" tIns="27432" bIns="27432">
-            <a:spAutoFit/>
-          </a:bodyPr>
-          <a:lstStyle/>
-          <a:p>
-            <a:pPr algn="l">
-              <a:spcBef>
-                <a:spcPts val="0"/>
-              </a:spcBef>
-              <a:spcAft>
-                <a:spcPts val="675"/>
-              </a:spcAft>
-            </a:pPr>
-            <a:r>
-              <a:rPr sz="2700" b="0" i="0" u="none">
-                <a:solidFill>
-                  <a:srgbClr val="1F2937"/>
-                </a:solidFill>
-                <a:latin typeface="Arial"/>
-              </a:rPr>
-              <a:t>Reproduce CodeS-1B on Spider within the ±5–10% tolerance</a:t>
-            </a:r>
-          </a:p>
-        </p:txBody>
-      </p:sp>
-      <p:sp>
-        <p:nvSpPr>
-          <p:cNvPr id="56" name="Oval 55"/>
-          <p:cNvSpPr/>
-          <p:nvPr/>
-        </p:nvSpPr>
-        <p:spPr>
-          <a:xfrm>
-            <a:off x="777240" y="14904720"/>
-            <a:ext cx="731520" cy="731520"/>
-          </a:xfrm>
-          <a:prstGeom prst="ellipse">
-            <a:avLst/>
-          </a:prstGeom>
-          <a:solidFill>
-            <a:srgbClr val="2E7D32"/>
-          </a:solidFill>
-          <a:ln>
-            <a:noFill/>
-          </a:ln>
-          <a:effectLst/>
-        </p:spPr>
-        <p:style>
-          <a:lnRef idx="1">
-            <a:schemeClr val="accent1"/>
-          </a:lnRef>
-          <a:fillRef idx="3">
-            <a:schemeClr val="accent1"/>
-          </a:fillRef>
-          <a:effectRef idx="2">
-            <a:schemeClr val="accent1"/>
-          </a:effectRef>
-          <a:fontRef idx="minor">
-            <a:schemeClr val="lt1"/>
-          </a:fontRef>
-        </p:style>
-        <p:txBody>
-          <a:bodyPr rtlCol="0" anchor="ctr" wrap="square" lIns="0" rIns="0" tIns="27432" bIns="27432"/>
-          <a:lstStyle/>
-          <a:p>
-            <a:pPr algn="ctr">
-              <a:spcBef>
-                <a:spcPts val="0"/>
-              </a:spcBef>
-              <a:spcAft>
-                <a:spcPts val="650"/>
-              </a:spcAft>
-            </a:pPr>
-            <a:r>
-              <a:rPr sz="2800" b="1" i="0" u="none">
-                <a:solidFill>
-                  <a:srgbClr val="FFFFFF"/>
-                </a:solidFill>
-                <a:latin typeface="Arial"/>
-              </a:rPr>
-              <a:t>2</a:t>
-            </a:r>
-          </a:p>
-        </p:txBody>
-      </p:sp>
-      <p:sp>
-        <p:nvSpPr>
-          <p:cNvPr id="57" name="TextBox 56"/>
-          <p:cNvSpPr txBox="1"/>
-          <p:nvPr/>
-        </p:nvSpPr>
-        <p:spPr>
-          <a:xfrm>
-            <a:off x="1691639" y="14840712"/>
-            <a:ext cx="13121640" cy="868680"/>
-          </a:xfrm>
-          <a:prstGeom prst="rect">
-            <a:avLst/>
-          </a:prstGeom>
-          <a:noFill/>
-        </p:spPr>
-        <p:txBody>
-          <a:bodyPr wrap="square" anchor="ctr" lIns="73152" rIns="73152" tIns="27432" bIns="27432">
-            <a:spAutoFit/>
-          </a:bodyPr>
-          <a:lstStyle/>
-          <a:p>
-            <a:pPr algn="l">
-              <a:spcBef>
-                <a:spcPts val="0"/>
-              </a:spcBef>
-              <a:spcAft>
-                <a:spcPts val="675"/>
-              </a:spcAft>
-            </a:pPr>
-            <a:r>
-              <a:rPr sz="2700" b="0" i="0" u="none">
-                <a:solidFill>
-                  <a:srgbClr val="1F2937"/>
-                </a:solidFill>
-                <a:latin typeface="Arial"/>
-              </a:rPr>
-              <a:t>Find which parts of the CodeS pipeline matter (ablation)</a:t>
-            </a:r>
-          </a:p>
-        </p:txBody>
-      </p:sp>
-      <p:sp>
-        <p:nvSpPr>
-          <p:cNvPr id="58" name="Oval 57"/>
-          <p:cNvSpPr/>
-          <p:nvPr/>
-        </p:nvSpPr>
-        <p:spPr>
-          <a:xfrm>
-            <a:off x="777240" y="15864840"/>
-            <a:ext cx="731520" cy="731520"/>
-          </a:xfrm>
-          <a:prstGeom prst="ellipse">
-            <a:avLst/>
-          </a:prstGeom>
-          <a:solidFill>
-            <a:srgbClr val="FFC000"/>
-          </a:solidFill>
-          <a:ln>
-            <a:noFill/>
-          </a:ln>
-          <a:effectLst/>
-        </p:spPr>
-        <p:style>
-          <a:lnRef idx="1">
-            <a:schemeClr val="accent1"/>
-          </a:lnRef>
-          <a:fillRef idx="3">
-            <a:schemeClr val="accent1"/>
-          </a:fillRef>
-          <a:effectRef idx="2">
-            <a:schemeClr val="accent1"/>
-          </a:effectRef>
-          <a:fontRef idx="minor">
-            <a:schemeClr val="lt1"/>
-          </a:fontRef>
-        </p:style>
-        <p:txBody>
-          <a:bodyPr rtlCol="0" anchor="ctr" wrap="square" lIns="0" rIns="0" tIns="27432" bIns="27432"/>
-          <a:lstStyle/>
-          <a:p>
-            <a:pPr algn="ctr">
-              <a:spcBef>
-                <a:spcPts val="0"/>
-              </a:spcBef>
-              <a:spcAft>
-                <a:spcPts val="650"/>
-              </a:spcAft>
-            </a:pPr>
-            <a:r>
-              <a:rPr sz="2800" b="1" i="0" u="none">
-                <a:solidFill>
-                  <a:srgbClr val="FFFFFF"/>
-                </a:solidFill>
-                <a:latin typeface="Arial"/>
-              </a:rPr>
-              <a:t>3</a:t>
-            </a:r>
-          </a:p>
-        </p:txBody>
-      </p:sp>
-      <p:sp>
-        <p:nvSpPr>
-          <p:cNvPr id="59" name="TextBox 58"/>
-          <p:cNvSpPr txBox="1"/>
-          <p:nvPr/>
-        </p:nvSpPr>
-        <p:spPr>
-          <a:xfrm>
-            <a:off x="1691639" y="15800832"/>
-            <a:ext cx="13121640" cy="868680"/>
-          </a:xfrm>
-          <a:prstGeom prst="rect">
-            <a:avLst/>
-          </a:prstGeom>
-          <a:noFill/>
-        </p:spPr>
-        <p:txBody>
-          <a:bodyPr wrap="square" anchor="ctr" lIns="73152" rIns="73152" tIns="27432" bIns="27432">
-            <a:spAutoFit/>
-          </a:bodyPr>
-          <a:lstStyle/>
-          <a:p>
-            <a:pPr algn="l">
-              <a:spcBef>
-                <a:spcPts val="0"/>
-              </a:spcBef>
-              <a:spcAft>
-                <a:spcPts val="675"/>
-              </a:spcAft>
-            </a:pPr>
-            <a:r>
-              <a:rPr sz="2700" b="0" i="0" u="none">
-                <a:solidFill>
-                  <a:srgbClr val="1F2937"/>
-                </a:solidFill>
-                <a:latin typeface="Arial"/>
-              </a:rPr>
-              <a:t>Make the system say when it is unsure — tested statistically</a:t>
-            </a:r>
-          </a:p>
-        </p:txBody>
-      </p:sp>
-      <p:sp>
-        <p:nvSpPr>
-          <p:cNvPr id="60" name="Oval 59"/>
-          <p:cNvSpPr/>
-          <p:nvPr/>
-        </p:nvSpPr>
-        <p:spPr>
-          <a:xfrm>
-            <a:off x="777240" y="16824960"/>
-            <a:ext cx="731520" cy="731520"/>
-          </a:xfrm>
-          <a:prstGeom prst="ellipse">
-            <a:avLst/>
-          </a:prstGeom>
-          <a:solidFill>
-            <a:srgbClr val="C00000"/>
-          </a:solidFill>
-          <a:ln>
-            <a:noFill/>
-          </a:ln>
-          <a:effectLst/>
-        </p:spPr>
-        <p:style>
-          <a:lnRef idx="1">
-            <a:schemeClr val="accent1"/>
-          </a:lnRef>
-          <a:fillRef idx="3">
-            <a:schemeClr val="accent1"/>
-          </a:fillRef>
-          <a:effectRef idx="2">
-            <a:schemeClr val="accent1"/>
-          </a:effectRef>
-          <a:fontRef idx="minor">
-            <a:schemeClr val="lt1"/>
-          </a:fontRef>
-        </p:style>
-        <p:txBody>
-          <a:bodyPr rtlCol="0" anchor="ctr" wrap="square" lIns="0" rIns="0" tIns="27432" bIns="27432"/>
-          <a:lstStyle/>
-          <a:p>
-            <a:pPr algn="ctr">
-              <a:spcBef>
-                <a:spcPts val="0"/>
-              </a:spcBef>
-              <a:spcAft>
-                <a:spcPts val="650"/>
-              </a:spcAft>
-            </a:pPr>
-            <a:r>
-              <a:rPr sz="2800" b="1" i="0" u="none">
-                <a:solidFill>
-                  <a:srgbClr val="FFFFFF"/>
-                </a:solidFill>
-                <a:latin typeface="Arial"/>
-              </a:rPr>
-              <a:t>4</a:t>
-            </a:r>
-          </a:p>
-        </p:txBody>
-      </p:sp>
-      <p:sp>
-        <p:nvSpPr>
-          <p:cNvPr id="61" name="TextBox 60"/>
-          <p:cNvSpPr txBox="1"/>
-          <p:nvPr/>
-        </p:nvSpPr>
-        <p:spPr>
-          <a:xfrm>
-            <a:off x="1691639" y="16760951"/>
-            <a:ext cx="13121640" cy="868680"/>
-          </a:xfrm>
-          <a:prstGeom prst="rect">
-            <a:avLst/>
-          </a:prstGeom>
-          <a:noFill/>
-        </p:spPr>
-        <p:txBody>
-          <a:bodyPr wrap="square" anchor="ctr" lIns="73152" rIns="73152" tIns="27432" bIns="27432">
-            <a:spAutoFit/>
-          </a:bodyPr>
-          <a:lstStyle/>
-          <a:p>
-            <a:pPr algn="l">
-              <a:spcBef>
-                <a:spcPts val="0"/>
-              </a:spcBef>
-              <a:spcAft>
-                <a:spcPts val="675"/>
-              </a:spcAft>
-            </a:pPr>
-            <a:r>
-              <a:rPr sz="2700" b="0" i="0" u="none">
-                <a:solidFill>
-                  <a:srgbClr val="1F2937"/>
-                </a:solidFill>
-                <a:latin typeface="Arial"/>
-              </a:rPr>
-              <a:t>Measure accuracy on realistically worded questions</a:t>
-            </a:r>
-          </a:p>
-        </p:txBody>
-      </p:sp>
-      <p:sp>
-        <p:nvSpPr>
-          <p:cNvPr id="62" name="Oval 61"/>
-          <p:cNvSpPr/>
-          <p:nvPr/>
-        </p:nvSpPr>
-        <p:spPr>
-          <a:xfrm>
-            <a:off x="777240" y="17785080"/>
-            <a:ext cx="731520" cy="731520"/>
-          </a:xfrm>
-          <a:prstGeom prst="ellipse">
-            <a:avLst/>
-          </a:prstGeom>
-          <a:solidFill>
-            <a:srgbClr val="7030A0"/>
-          </a:solidFill>
-          <a:ln>
-            <a:noFill/>
-          </a:ln>
-          <a:effectLst/>
-        </p:spPr>
-        <p:style>
-          <a:lnRef idx="1">
-            <a:schemeClr val="accent1"/>
-          </a:lnRef>
-          <a:fillRef idx="3">
-            <a:schemeClr val="accent1"/>
-          </a:fillRef>
-          <a:effectRef idx="2">
-            <a:schemeClr val="accent1"/>
-          </a:effectRef>
-          <a:fontRef idx="minor">
-            <a:schemeClr val="lt1"/>
-          </a:fontRef>
-        </p:style>
-        <p:txBody>
-          <a:bodyPr rtlCol="0" anchor="ctr" wrap="square" lIns="0" rIns="0" tIns="27432" bIns="27432"/>
-          <a:lstStyle/>
-          <a:p>
-            <a:pPr algn="ctr">
-              <a:spcBef>
-                <a:spcPts val="0"/>
-              </a:spcBef>
-              <a:spcAft>
-                <a:spcPts val="650"/>
-              </a:spcAft>
-            </a:pPr>
-            <a:r>
-              <a:rPr sz="2800" b="1" i="0" u="none">
-                <a:solidFill>
-                  <a:srgbClr val="FFFFFF"/>
-                </a:solidFill>
-                <a:latin typeface="Arial"/>
-              </a:rPr>
-              <a:t>5</a:t>
-            </a:r>
-          </a:p>
-        </p:txBody>
-      </p:sp>
-      <p:sp>
-        <p:nvSpPr>
-          <p:cNvPr id="63" name="TextBox 62"/>
-          <p:cNvSpPr txBox="1"/>
-          <p:nvPr/>
-        </p:nvSpPr>
-        <p:spPr>
-          <a:xfrm>
-            <a:off x="1691639" y="17721072"/>
-            <a:ext cx="13121640" cy="868680"/>
-          </a:xfrm>
-          <a:prstGeom prst="rect">
-            <a:avLst/>
-          </a:prstGeom>
-          <a:noFill/>
-        </p:spPr>
-        <p:txBody>
-          <a:bodyPr wrap="square" anchor="ctr" lIns="73152" rIns="73152" tIns="27432" bIns="27432">
-            <a:spAutoFit/>
-          </a:bodyPr>
-          <a:lstStyle/>
-          <a:p>
-            <a:pPr algn="l">
-              <a:spcBef>
-                <a:spcPts val="0"/>
-              </a:spcBef>
-              <a:spcAft>
-                <a:spcPts val="675"/>
-              </a:spcAft>
-            </a:pPr>
-            <a:r>
-              <a:rPr sz="2700" b="0" i="0" u="none">
-                <a:solidFill>
-                  <a:srgbClr val="1F2937"/>
-                </a:solidFill>
-                <a:latin typeface="Arial"/>
-              </a:rPr>
-              <a:t>Deliver a desktop app that runs fully locally</a:t>
-            </a:r>
-          </a:p>
-        </p:txBody>
-      </p:sp>
-      <p:sp>
-        <p:nvSpPr>
-          <p:cNvPr id="64" name="Rectangle 63"/>
-          <p:cNvSpPr/>
-          <p:nvPr/>
-        </p:nvSpPr>
-        <p:spPr>
-          <a:xfrm>
-            <a:off x="640080" y="18882360"/>
-            <a:ext cx="14264640" cy="731520"/>
-          </a:xfrm>
-          <a:prstGeom prst="rect">
-            <a:avLst/>
-          </a:prstGeom>
-          <a:solidFill>
-            <a:srgbClr val="C00000"/>
-          </a:solidFill>
-          <a:ln>
-            <a:noFill/>
-          </a:ln>
-          <a:effectLst/>
-        </p:spPr>
-        <p:style>
-          <a:lnRef idx="1">
-            <a:schemeClr val="accent1"/>
-          </a:lnRef>
-          <a:fillRef idx="3">
-            <a:schemeClr val="accent1"/>
-          </a:fillRef>
-          <a:effectRef idx="2">
-            <a:schemeClr val="accent1"/>
-          </a:effectRef>
-          <a:fontRef idx="minor">
-            <a:schemeClr val="lt1"/>
-          </a:fontRef>
-        </p:style>
-        <p:txBody>
-          <a:bodyPr rtlCol="0" anchor="ctr" wrap="square" lIns="73152" rIns="73152" tIns="27432" bIns="27432"/>
-          <a:lstStyle/>
-          <a:p>
-            <a:pPr algn="ctr">
-              <a:spcBef>
-                <a:spcPts val="0"/>
-              </a:spcBef>
-              <a:spcAft>
-                <a:spcPts val="650"/>
-              </a:spcAft>
-            </a:pPr>
-            <a:r>
-              <a:rPr sz="3800" b="1" i="0" u="none">
-                <a:solidFill>
-                  <a:srgbClr val="FFFFFF"/>
-                </a:solidFill>
-                <a:latin typeface="Arial"/>
-              </a:rPr>
-              <a:t>Key Innovations &amp; Contributions</a:t>
-            </a:r>
-          </a:p>
-        </p:txBody>
-      </p:sp>
-      <p:pic>
-        <p:nvPicPr>
-          <p:cNvPr id="65" name="Picture 64" descr="shield-check_blue.png"/>
-          <p:cNvPicPr>
-            <a:picLocks noChangeAspect="1"/>
-          </p:cNvPicPr>
-          <p:nvPr/>
-        </p:nvPicPr>
-        <p:blipFill>
-          <a:blip r:embed="rId12"/>
-          <a:stretch>
-            <a:fillRect/>
-          </a:stretch>
-        </p:blipFill>
-        <p:spPr>
-          <a:xfrm>
-            <a:off x="822959" y="19961352"/>
-            <a:ext cx="868680" cy="868680"/>
-          </a:xfrm>
-          <a:prstGeom prst="rect">
-            <a:avLst/>
-          </a:prstGeom>
-        </p:spPr>
-      </p:pic>
-      <p:sp>
-        <p:nvSpPr>
-          <p:cNvPr id="66" name="TextBox 65"/>
-          <p:cNvSpPr txBox="1"/>
-          <p:nvPr/>
-        </p:nvSpPr>
-        <p:spPr>
-          <a:xfrm>
-            <a:off x="1920239" y="19796760"/>
-            <a:ext cx="12893040" cy="1536192"/>
-          </a:xfrm>
-          <a:prstGeom prst="rect">
-            <a:avLst/>
-          </a:prstGeom>
-          <a:noFill/>
-        </p:spPr>
-        <p:txBody>
-          <a:bodyPr wrap="square" anchor="t" lIns="73152" rIns="73152" tIns="27432" bIns="27432">
-            <a:spAutoFit/>
-          </a:bodyPr>
-          <a:lstStyle/>
-          <a:p>
-            <a:pPr algn="l">
-              <a:spcBef>
-                <a:spcPts val="0"/>
-              </a:spcBef>
-              <a:spcAft>
-                <a:spcPts val="104"/>
-              </a:spcAft>
-            </a:pPr>
-            <a:r>
-              <a:rPr sz="2700" b="1" i="0" u="none">
-                <a:solidFill>
-                  <a:srgbClr val="002060"/>
-                </a:solidFill>
-                <a:latin typeface="Arial"/>
-              </a:rPr>
-              <a:t>1. Confidence-aware abstention</a:t>
-            </a:r>
-          </a:p>
-          <a:p>
-            <a:pPr algn="l">
-              <a:spcBef>
-                <a:spcPts val="0"/>
-              </a:spcBef>
-              <a:spcAft>
-                <a:spcPts val="104"/>
-              </a:spcAft>
-            </a:pPr>
-            <a:r>
-              <a:rPr sz="2300" b="0" i="0" u="none">
-                <a:solidFill>
-                  <a:srgbClr val="1F2937"/>
-                </a:solidFill>
-                <a:latin typeface="Arial"/>
-              </a:rPr>
-              <a:t>Run all candidate queries, count how many agree; ask “Did you mean…?” when they don't</a:t>
-            </a:r>
-          </a:p>
-        </p:txBody>
-      </p:sp>
-      <p:pic>
-        <p:nvPicPr>
-          <p:cNvPr id="67" name="Picture 66" descr="badge-check_blue.png"/>
-          <p:cNvPicPr>
-            <a:picLocks noChangeAspect="1"/>
-          </p:cNvPicPr>
-          <p:nvPr/>
-        </p:nvPicPr>
-        <p:blipFill>
-          <a:blip r:embed="rId13"/>
-          <a:stretch>
-            <a:fillRect/>
-          </a:stretch>
-        </p:blipFill>
-        <p:spPr>
-          <a:xfrm>
-            <a:off x="822959" y="21534119"/>
-            <a:ext cx="868680" cy="868680"/>
-          </a:xfrm>
-          <a:prstGeom prst="rect">
-            <a:avLst/>
-          </a:prstGeom>
-        </p:spPr>
-      </p:pic>
-      <p:sp>
-        <p:nvSpPr>
-          <p:cNvPr id="68" name="TextBox 67"/>
-          <p:cNvSpPr txBox="1"/>
-          <p:nvPr/>
-        </p:nvSpPr>
-        <p:spPr>
-          <a:xfrm>
-            <a:off x="1920239" y="21369527"/>
-            <a:ext cx="12893040" cy="1536192"/>
-          </a:xfrm>
-          <a:prstGeom prst="rect">
-            <a:avLst/>
-          </a:prstGeom>
-          <a:noFill/>
-        </p:spPr>
-        <p:txBody>
-          <a:bodyPr wrap="square" anchor="t" lIns="73152" rIns="73152" tIns="27432" bIns="27432">
-            <a:spAutoFit/>
-          </a:bodyPr>
-          <a:lstStyle/>
-          <a:p>
-            <a:pPr algn="l">
-              <a:spcBef>
-                <a:spcPts val="0"/>
-              </a:spcBef>
-              <a:spcAft>
-                <a:spcPts val="104"/>
-              </a:spcAft>
-            </a:pPr>
-            <a:r>
-              <a:rPr sz="2700" b="1" i="0" u="none">
-                <a:solidFill>
-                  <a:srgbClr val="002060"/>
-                </a:solidFill>
-                <a:latin typeface="Arial"/>
-              </a:rPr>
-              <a:t>2. Faithful, audited reproduction</a:t>
-            </a:r>
-          </a:p>
-          <a:p>
-            <a:pPr algn="l">
-              <a:spcBef>
-                <a:spcPts val="0"/>
-              </a:spcBef>
-              <a:spcAft>
-                <a:spcPts val="104"/>
-              </a:spcAft>
-            </a:pPr>
-            <a:r>
-              <a:rPr sz="2300" b="0" i="0" u="none">
-                <a:solidFill>
-                  <a:srgbClr val="1F2937"/>
-                </a:solidFill>
-                <a:latin typeface="Arial"/>
-              </a:rPr>
-              <a:t>77.8% vs 77.9% with the official evaluator, after auditing our own harness</a:t>
-            </a:r>
-          </a:p>
-        </p:txBody>
-      </p:sp>
-      <p:pic>
-        <p:nvPicPr>
-          <p:cNvPr id="69" name="Picture 68" descr="refresh-cw_blue.png"/>
-          <p:cNvPicPr>
-            <a:picLocks noChangeAspect="1"/>
-          </p:cNvPicPr>
-          <p:nvPr/>
-        </p:nvPicPr>
-        <p:blipFill>
-          <a:blip r:embed="rId14"/>
-          <a:stretch>
-            <a:fillRect/>
-          </a:stretch>
-        </p:blipFill>
-        <p:spPr>
-          <a:xfrm>
-            <a:off x="822959" y="23106888"/>
-            <a:ext cx="868680" cy="868680"/>
-          </a:xfrm>
-          <a:prstGeom prst="rect">
-            <a:avLst/>
-          </a:prstGeom>
-        </p:spPr>
-      </p:pic>
-      <p:sp>
-        <p:nvSpPr>
-          <p:cNvPr id="70" name="TextBox 69"/>
-          <p:cNvSpPr txBox="1"/>
-          <p:nvPr/>
-        </p:nvSpPr>
-        <p:spPr>
-          <a:xfrm>
-            <a:off x="1920239" y="22942296"/>
-            <a:ext cx="12893040" cy="1536192"/>
-          </a:xfrm>
-          <a:prstGeom prst="rect">
-            <a:avLst/>
-          </a:prstGeom>
-          <a:noFill/>
-        </p:spPr>
-        <p:txBody>
-          <a:bodyPr wrap="square" anchor="t" lIns="73152" rIns="73152" tIns="27432" bIns="27432">
-            <a:spAutoFit/>
-          </a:bodyPr>
-          <a:lstStyle/>
-          <a:p>
-            <a:pPr algn="l">
-              <a:spcBef>
-                <a:spcPts val="0"/>
-              </a:spcBef>
-              <a:spcAft>
-                <a:spcPts val="104"/>
-              </a:spcAft>
-            </a:pPr>
-            <a:r>
-              <a:rPr sz="2700" b="1" i="0" u="none">
-                <a:solidFill>
-                  <a:srgbClr val="002060"/>
-                </a:solidFill>
-                <a:latin typeface="Arial"/>
-              </a:rPr>
-              <a:t>3. Execution-guided self-correction</a:t>
-            </a:r>
-          </a:p>
-          <a:p>
-            <a:pPr algn="l">
-              <a:spcBef>
-                <a:spcPts val="0"/>
-              </a:spcBef>
-              <a:spcAft>
-                <a:spcPts val="104"/>
-              </a:spcAft>
-            </a:pPr>
-            <a:r>
-              <a:rPr sz="2300" b="0" i="0" u="none">
-                <a:solidFill>
-                  <a:srgbClr val="1F2937"/>
-                </a:solidFill>
-                <a:latin typeface="Arial"/>
-              </a:rPr>
-              <a:t>A failed query goes back to the model with the database error</a:t>
-            </a:r>
-          </a:p>
-        </p:txBody>
-      </p:sp>
-      <p:pic>
-        <p:nvPicPr>
-          <p:cNvPr id="71" name="Picture 70" descr="lock-keyhole_blue.png"/>
-          <p:cNvPicPr>
-            <a:picLocks noChangeAspect="1"/>
-          </p:cNvPicPr>
-          <p:nvPr/>
-        </p:nvPicPr>
-        <p:blipFill>
-          <a:blip r:embed="rId15"/>
-          <a:stretch>
-            <a:fillRect/>
-          </a:stretch>
-        </p:blipFill>
-        <p:spPr>
-          <a:xfrm>
-            <a:off x="822959" y="24679656"/>
-            <a:ext cx="868680" cy="868680"/>
-          </a:xfrm>
-          <a:prstGeom prst="rect">
-            <a:avLst/>
-          </a:prstGeom>
-        </p:spPr>
-      </p:pic>
-      <p:sp>
-        <p:nvSpPr>
-          <p:cNvPr id="72" name="TextBox 71"/>
-          <p:cNvSpPr txBox="1"/>
-          <p:nvPr/>
-        </p:nvSpPr>
-        <p:spPr>
-          <a:xfrm>
-            <a:off x="1920239" y="24515064"/>
-            <a:ext cx="12893040" cy="1536192"/>
-          </a:xfrm>
-          <a:prstGeom prst="rect">
-            <a:avLst/>
-          </a:prstGeom>
-          <a:noFill/>
-        </p:spPr>
-        <p:txBody>
-          <a:bodyPr wrap="square" anchor="t" lIns="73152" rIns="73152" tIns="27432" bIns="27432">
-            <a:spAutoFit/>
-          </a:bodyPr>
-          <a:lstStyle/>
-          <a:p>
-            <a:pPr algn="l">
-              <a:spcBef>
-                <a:spcPts val="0"/>
-              </a:spcBef>
-              <a:spcAft>
-                <a:spcPts val="104"/>
-              </a:spcAft>
-            </a:pPr>
-            <a:r>
-              <a:rPr sz="2700" b="1" i="0" u="none">
-                <a:solidFill>
-                  <a:srgbClr val="002060"/>
-                </a:solidFill>
-                <a:latin typeface="Arial"/>
-              </a:rPr>
-              <a:t>4. Private by design</a:t>
-            </a:r>
-          </a:p>
-          <a:p>
-            <a:pPr algn="l">
-              <a:spcBef>
-                <a:spcPts val="0"/>
-              </a:spcBef>
-              <a:spcAft>
-                <a:spcPts val="104"/>
-              </a:spcAft>
-            </a:pPr>
-            <a:r>
-              <a:rPr sz="2300" b="0" i="0" u="none">
-                <a:solidFill>
-                  <a:srgbClr val="1F2937"/>
-                </a:solidFill>
-                <a:latin typeface="Arial"/>
-              </a:rPr>
-              <a:t>Open weights, runs on the user's computer — no schema sent to a third party</a:t>
-            </a:r>
-          </a:p>
-        </p:txBody>
-      </p:sp>
-      <p:sp>
-        <p:nvSpPr>
-          <p:cNvPr id="73" name="Rectangle 72"/>
-          <p:cNvSpPr/>
-          <p:nvPr/>
-        </p:nvSpPr>
-        <p:spPr>
-          <a:xfrm>
-            <a:off x="640080" y="26197560"/>
-            <a:ext cx="14264640" cy="731520"/>
-          </a:xfrm>
-          <a:prstGeom prst="rect">
-            <a:avLst/>
-          </a:prstGeom>
-          <a:solidFill>
-            <a:srgbClr val="C00000"/>
-          </a:solidFill>
-          <a:ln>
-            <a:noFill/>
-          </a:ln>
-          <a:effectLst/>
-        </p:spPr>
-        <p:style>
-          <a:lnRef idx="1">
-            <a:schemeClr val="accent1"/>
-          </a:lnRef>
-          <a:fillRef idx="3">
-            <a:schemeClr val="accent1"/>
-          </a:fillRef>
-          <a:effectRef idx="2">
-            <a:schemeClr val="accent1"/>
-          </a:effectRef>
-          <a:fontRef idx="minor">
-            <a:schemeClr val="lt1"/>
-          </a:fontRef>
-        </p:style>
-        <p:txBody>
-          <a:bodyPr rtlCol="0" anchor="ctr" wrap="square" lIns="73152" rIns="73152" tIns="27432" bIns="27432"/>
-          <a:lstStyle/>
-          <a:p>
-            <a:pPr algn="ctr">
-              <a:spcBef>
-                <a:spcPts val="0"/>
-              </a:spcBef>
-              <a:spcAft>
-                <a:spcPts val="650"/>
-              </a:spcAft>
-            </a:pPr>
-            <a:r>
-              <a:rPr sz="3800" b="1" i="0" u="none">
-                <a:solidFill>
-                  <a:srgbClr val="FFFFFF"/>
-                </a:solidFill>
-                <a:latin typeface="Arial"/>
+                <a:latin typeface="Aptos"/>
+                <a:ea typeface="Aptos"/>
+                <a:cs typeface="Aptos"/>
               </a:rPr>
               <a:t>Datasets (Hugging Face — approved source)</a:t>
             </a:r>
@@ -7202,7 +6350,7 @@
       </p:sp>
       <p:graphicFrame>
         <p:nvGraphicFramePr>
-          <p:cNvPr id="74" name="Table 73"/>
+          <p:cNvPr id="50" name="Table 49"/>
           <p:cNvGraphicFramePr>
             <a:graphicFrameLocks noGrp="1"/>
           </p:cNvGraphicFramePr>
@@ -7234,7 +6382,7 @@
                           <a:solidFill>
                             <a:srgbClr val="FFFFFF"/>
                           </a:solidFill>
-                          <a:latin typeface="Arial"/>
+                          <a:latin typeface="Aptos"/>
                         </a:rPr>
                         <a:t>Benchmark</a:t>
                       </a:r>
@@ -7256,7 +6404,7 @@
                           <a:solidFill>
                             <a:srgbClr val="FFFFFF"/>
                           </a:solidFill>
-                          <a:latin typeface="Arial"/>
+                          <a:latin typeface="Aptos"/>
                         </a:rPr>
                         <a:t>Questions</a:t>
                       </a:r>
@@ -7278,7 +6426,7 @@
                           <a:solidFill>
                             <a:srgbClr val="FFFFFF"/>
                           </a:solidFill>
-                          <a:latin typeface="Arial"/>
+                          <a:latin typeface="Aptos"/>
                         </a:rPr>
                         <a:t>Used for</a:t>
                       </a:r>
@@ -7302,7 +6450,7 @@
                           <a:solidFill>
                             <a:srgbClr val="1F2937"/>
                           </a:solidFill>
-                          <a:latin typeface="Arial"/>
+                          <a:latin typeface="Aptos"/>
                         </a:rPr>
                         <a:t>Spider dev</a:t>
                       </a:r>
@@ -7324,7 +6472,7 @@
                           <a:solidFill>
                             <a:srgbClr val="1F2937"/>
                           </a:solidFill>
-                          <a:latin typeface="Arial"/>
+                          <a:latin typeface="Aptos"/>
                         </a:rPr>
                         <a:t>1,034 · 20 databases</a:t>
                       </a:r>
@@ -7346,7 +6494,7 @@
                           <a:solidFill>
                             <a:srgbClr val="1F2937"/>
                           </a:solidFill>
-                          <a:latin typeface="Arial"/>
+                          <a:latin typeface="Aptos"/>
                         </a:rPr>
                         <a:t>Reproduction, ablation, enhancement</a:t>
                       </a:r>
@@ -7370,7 +6518,7 @@
                           <a:solidFill>
                             <a:srgbClr val="1F2937"/>
                           </a:solidFill>
-                          <a:latin typeface="Arial"/>
+                          <a:latin typeface="Aptos"/>
                         </a:rPr>
                         <a:t>Spider-Realistic</a:t>
                       </a:r>
@@ -7392,7 +6540,7 @@
                           <a:solidFill>
                             <a:srgbClr val="1F2937"/>
                           </a:solidFill>
-                          <a:latin typeface="Arial"/>
+                          <a:latin typeface="Aptos"/>
                         </a:rPr>
                         <a:t>508</a:t>
                       </a:r>
@@ -7414,7 +6562,7 @@
                           <a:solidFill>
                             <a:srgbClr val="1F2937"/>
                           </a:solidFill>
-                          <a:latin typeface="Arial"/>
+                          <a:latin typeface="Aptos"/>
                         </a:rPr>
                         <a:t>Questions without column names</a:t>
                       </a:r>
@@ -7438,7 +6586,7 @@
                           <a:solidFill>
                             <a:srgbClr val="1F2937"/>
                           </a:solidFill>
-                          <a:latin typeface="Arial"/>
+                          <a:latin typeface="Aptos"/>
                         </a:rPr>
                         <a:t>BIRD Mini-Dev</a:t>
                       </a:r>
@@ -7460,7 +6608,7 @@
                           <a:solidFill>
                             <a:srgbClr val="1F2937"/>
                           </a:solidFill>
-                          <a:latin typeface="Arial"/>
+                          <a:latin typeface="Aptos"/>
                         </a:rPr>
                         <a:t>500 · 11 databases</a:t>
                       </a:r>
@@ -7482,7 +6630,7 @@
                           <a:solidFill>
                             <a:srgbClr val="1F2937"/>
                           </a:solidFill>
-                          <a:latin typeface="Arial"/>
+                          <a:latin typeface="Aptos"/>
                         </a:rPr>
                         <a:t>Real-world databases (future work)</a:t>
                       </a:r>
@@ -7501,7 +6649,7 @@
       </p:graphicFrame>
       <p:sp>
         <p:nvSpPr>
-          <p:cNvPr id="75" name="Rounded Rectangle 74"/>
+          <p:cNvPr id="51" name="Rounded Rectangle 50"/>
           <p:cNvSpPr/>
           <p:nvPr/>
         </p:nvSpPr>
@@ -7550,7 +6698,7 @@
       </p:sp>
       <p:sp>
         <p:nvSpPr>
-          <p:cNvPr id="76" name="Rounded Rectangle 75"/>
+          <p:cNvPr id="52" name="Rounded Rectangle 51"/>
           <p:cNvSpPr/>
           <p:nvPr/>
         </p:nvSpPr>
@@ -7598,14 +6746,14 @@
       </p:sp>
       <p:pic>
         <p:nvPicPr>
-          <p:cNvPr id="77" name="Picture 76" descr="message-circle-question_blue.png"/>
+          <p:cNvPr id="53" name="Picture 52" descr="message-circle-question_blue.png"/>
           <p:cNvPicPr>
             <a:picLocks noChangeAspect="1"/>
           </p:cNvPicPr>
           <p:nvPr/>
         </p:nvPicPr>
         <p:blipFill>
-          <a:blip r:embed="rId16"/>
+          <a:blip r:embed="rId8"/>
           <a:stretch>
             <a:fillRect/>
           </a:stretch>
@@ -7622,7 +6770,7 @@
       </p:pic>
       <p:sp>
         <p:nvSpPr>
-          <p:cNvPr id="78" name="TextBox 77"/>
+          <p:cNvPr id="54" name="TextBox 53"/>
           <p:cNvSpPr txBox="1"/>
           <p:nvPr/>
         </p:nvSpPr>
@@ -7651,11 +6799,13 @@
               </a:spcAft>
             </a:pPr>
             <a:r>
-              <a:rPr sz="2700" b="1" i="0" u="none">
+              <a:rPr sz="2700" b="1" i="0" u="none" lang="en-US">
                 <a:solidFill>
                   <a:srgbClr val="002060"/>
                 </a:solidFill>
-                <a:latin typeface="Arial"/>
+                <a:latin typeface="Aptos"/>
+                <a:ea typeface="Aptos"/>
+                <a:cs typeface="Aptos"/>
               </a:rPr>
               <a:t>USER QUESTION</a:t>
             </a:r>
@@ -7670,11 +6820,13 @@
               </a:spcAft>
             </a:pPr>
             <a:r>
-              <a:rPr sz="2400" b="0" i="0" u="none">
+              <a:rPr sz="2400" b="0" i="0" u="none" lang="en-US">
                 <a:solidFill>
                   <a:srgbClr val="1F2937"/>
                 </a:solidFill>
-                <a:latin typeface="Arial"/>
+                <a:latin typeface="Aptos"/>
+                <a:ea typeface="Aptos"/>
+                <a:cs typeface="Aptos"/>
               </a:rPr>
               <a:t>“Which student scored the</a:t>
             </a:r>
@@ -7689,11 +6841,13 @@
               </a:spcAft>
             </a:pPr>
             <a:r>
-              <a:rPr sz="2400" b="0" i="0" u="none">
+              <a:rPr sz="2400" b="0" i="0" u="none" lang="en-US">
                 <a:solidFill>
                   <a:srgbClr val="1F2937"/>
                 </a:solidFill>
-                <a:latin typeface="Arial"/>
+                <a:latin typeface="Aptos"/>
+                <a:ea typeface="Aptos"/>
+                <a:cs typeface="Aptos"/>
               </a:rPr>
               <a:t>highest marks in DBMS?”</a:t>
             </a:r>
@@ -7702,7 +6856,7 @@
       </p:sp>
       <p:sp>
         <p:nvSpPr>
-          <p:cNvPr id="79" name="Rounded Rectangle 78"/>
+          <p:cNvPr id="55" name="Rounded Rectangle 54"/>
           <p:cNvSpPr/>
           <p:nvPr/>
         </p:nvSpPr>
@@ -7750,14 +6904,14 @@
       </p:sp>
       <p:pic>
         <p:nvPicPr>
-          <p:cNvPr id="80" name="Picture 79" descr="database_blue.png"/>
+          <p:cNvPr id="56" name="Picture 55" descr="database_blue.png"/>
           <p:cNvPicPr>
             <a:picLocks noChangeAspect="1"/>
           </p:cNvPicPr>
           <p:nvPr/>
         </p:nvPicPr>
         <p:blipFill>
-          <a:blip r:embed="rId17"/>
+          <a:blip r:embed="rId9"/>
           <a:stretch>
             <a:fillRect/>
           </a:stretch>
@@ -7774,7 +6928,7 @@
       </p:pic>
       <p:sp>
         <p:nvSpPr>
-          <p:cNvPr id="81" name="TextBox 80"/>
+          <p:cNvPr id="57" name="TextBox 56"/>
           <p:cNvSpPr txBox="1"/>
           <p:nvPr/>
         </p:nvSpPr>
@@ -7803,11 +6957,13 @@
               </a:spcAft>
             </a:pPr>
             <a:r>
-              <a:rPr sz="2700" b="1" i="0" u="none">
+              <a:rPr sz="2700" b="1" i="0" u="none" lang="en-US">
                 <a:solidFill>
                   <a:srgbClr val="002060"/>
                 </a:solidFill>
-                <a:latin typeface="Arial"/>
+                <a:latin typeface="Aptos"/>
+                <a:ea typeface="Aptos"/>
+                <a:cs typeface="Aptos"/>
               </a:rPr>
               <a:t>YOUR DATABASE</a:t>
             </a:r>
@@ -7822,11 +6978,13 @@
               </a:spcAft>
             </a:pPr>
             <a:r>
-              <a:rPr sz="2400" b="0" i="0" u="none">
+              <a:rPr sz="2400" b="0" i="0" u="none" lang="en-US">
                 <a:solidFill>
                   <a:srgbClr val="1F2937"/>
                 </a:solidFill>
-                <a:latin typeface="Arial"/>
+                <a:latin typeface="Aptos"/>
+                <a:ea typeface="Aptos"/>
+                <a:cs typeface="Aptos"/>
               </a:rPr>
               <a:t>SQLite · PostgreSQL · MySQL</a:t>
             </a:r>
@@ -7841,11 +6999,13 @@
               </a:spcAft>
             </a:pPr>
             <a:r>
-              <a:rPr sz="2400" b="0" i="0" u="none">
+              <a:rPr sz="2400" b="0" i="0" u="none" lang="en-US">
                 <a:solidFill>
                   <a:srgbClr val="1F2937"/>
                 </a:solidFill>
-                <a:latin typeface="Arial"/>
+                <a:latin typeface="Aptos"/>
+                <a:ea typeface="Aptos"/>
+                <a:cs typeface="Aptos"/>
               </a:rPr>
               <a:t>opened read-only</a:t>
             </a:r>
@@ -7854,7 +7014,7 @@
       </p:sp>
       <p:cxnSp>
         <p:nvCxnSpPr>
-          <p:cNvPr id="82" name="Connector 81"/>
+          <p:cNvPr id="58" name="Connector 57"/>
           <p:cNvCxnSpPr/>
           <p:nvPr/>
         </p:nvCxnSpPr>
@@ -7890,7 +7050,7 @@
       </p:cxnSp>
       <p:cxnSp>
         <p:nvCxnSpPr>
-          <p:cNvPr id="83" name="Connector 82"/>
+          <p:cNvPr id="59" name="Connector 58"/>
           <p:cNvCxnSpPr/>
           <p:nvPr/>
         </p:nvCxnSpPr>
@@ -7926,7 +7086,7 @@
       </p:cxnSp>
       <p:sp>
         <p:nvSpPr>
-          <p:cNvPr id="84" name="Rounded Rectangle 83"/>
+          <p:cNvPr id="60" name="Rounded Rectangle 59"/>
           <p:cNvSpPr/>
           <p:nvPr/>
         </p:nvSpPr>
@@ -7974,14 +7134,14 @@
       </p:sp>
       <p:pic>
         <p:nvPicPr>
-          <p:cNvPr id="85" name="Picture 84" descr="file-text_blue.png"/>
+          <p:cNvPr id="61" name="Picture 60" descr="file-text_blue.png"/>
           <p:cNvPicPr>
             <a:picLocks noChangeAspect="1"/>
           </p:cNvPicPr>
           <p:nvPr/>
         </p:nvPicPr>
         <p:blipFill>
-          <a:blip r:embed="rId18"/>
+          <a:blip r:embed="rId10"/>
           <a:stretch>
             <a:fillRect/>
           </a:stretch>
@@ -7998,7 +7158,7 @@
       </p:pic>
       <p:sp>
         <p:nvSpPr>
-          <p:cNvPr id="86" name="TextBox 85"/>
+          <p:cNvPr id="62" name="TextBox 61"/>
           <p:cNvSpPr txBox="1"/>
           <p:nvPr/>
         </p:nvSpPr>
@@ -8027,11 +7187,13 @@
               </a:spcAft>
             </a:pPr>
             <a:r>
-              <a:rPr sz="2700" b="1" i="0" u="none">
+              <a:rPr sz="2700" b="1" i="0" u="none" lang="en-US">
                 <a:solidFill>
                   <a:srgbClr val="002060"/>
                 </a:solidFill>
-                <a:latin typeface="Arial"/>
+                <a:latin typeface="Aptos"/>
+                <a:ea typeface="Aptos"/>
+                <a:cs typeface="Aptos"/>
               </a:rPr>
               <a:t>DATABASE PROMPT BUILDER</a:t>
             </a:r>
@@ -8046,11 +7208,13 @@
               </a:spcAft>
             </a:pPr>
             <a:r>
-              <a:rPr sz="2400" b="0" i="0" u="none">
+              <a:rPr sz="2400" b="0" i="0" u="none" lang="en-US">
                 <a:solidFill>
                   <a:srgbClr val="1F2937"/>
                 </a:solidFill>
-                <a:latin typeface="Arial"/>
+                <a:latin typeface="Aptos"/>
+                <a:ea typeface="Aptos"/>
+                <a:cs typeface="Aptos"/>
               </a:rPr>
               <a:t>Tables, columns, types, keys, 2 sample values each</a:t>
             </a:r>
@@ -8065,11 +7229,13 @@
               </a:spcAft>
             </a:pPr>
             <a:r>
-              <a:rPr sz="2400" b="0" i="0" u="none">
+              <a:rPr sz="2400" b="0" i="0" u="none" lang="en-US">
                 <a:solidFill>
                   <a:srgbClr val="1F2937"/>
                 </a:solidFill>
-                <a:latin typeface="Arial"/>
+                <a:latin typeface="Aptos"/>
+                <a:ea typeface="Aptos"/>
+                <a:cs typeface="Aptos"/>
               </a:rPr>
               <a:t>Value retriever: stored values that match the question</a:t>
             </a:r>
@@ -8078,7 +7244,7 @@
       </p:sp>
       <p:cxnSp>
         <p:nvCxnSpPr>
-          <p:cNvPr id="87" name="Connector 86"/>
+          <p:cNvPr id="63" name="Connector 62"/>
           <p:cNvCxnSpPr/>
           <p:nvPr/>
         </p:nvCxnSpPr>
@@ -8114,7 +7280,7 @@
       </p:cxnSp>
       <p:sp>
         <p:nvSpPr>
-          <p:cNvPr id="88" name="Rounded Rectangle 87"/>
+          <p:cNvPr id="64" name="Rounded Rectangle 63"/>
           <p:cNvSpPr/>
           <p:nvPr/>
         </p:nvSpPr>
@@ -8162,14 +7328,14 @@
       </p:sp>
       <p:pic>
         <p:nvPicPr>
-          <p:cNvPr id="89" name="Picture 88" descr="brain-circuit_blue.png"/>
+          <p:cNvPr id="65" name="Picture 64" descr="brain-circuit_blue.png"/>
           <p:cNvPicPr>
             <a:picLocks noChangeAspect="1"/>
           </p:cNvPicPr>
           <p:nvPr/>
         </p:nvPicPr>
         <p:blipFill>
-          <a:blip r:embed="rId19"/>
+          <a:blip r:embed="rId11"/>
           <a:stretch>
             <a:fillRect/>
           </a:stretch>
@@ -8186,7 +7352,7 @@
       </p:pic>
       <p:sp>
         <p:nvSpPr>
-          <p:cNvPr id="90" name="TextBox 89"/>
+          <p:cNvPr id="66" name="TextBox 65"/>
           <p:cNvSpPr txBox="1"/>
           <p:nvPr/>
         </p:nvSpPr>
@@ -8215,11 +7381,13 @@
               </a:spcAft>
             </a:pPr>
             <a:r>
-              <a:rPr sz="2700" b="1" i="0" u="none">
+              <a:rPr sz="2700" b="1" i="0" u="none" lang="en-US">
                 <a:solidFill>
                   <a:srgbClr val="002060"/>
                 </a:solidFill>
-                <a:latin typeface="Arial"/>
+                <a:latin typeface="Aptos"/>
+                <a:ea typeface="Aptos"/>
+                <a:cs typeface="Aptos"/>
               </a:rPr>
               <a:t>CODES-1B (FINE-TUNED ON SPIDER)</a:t>
             </a:r>
@@ -8234,11 +7402,13 @@
               </a:spcAft>
             </a:pPr>
             <a:r>
-              <a:rPr sz="2400" b="0" i="0" u="none">
+              <a:rPr sz="2400" b="0" i="0" u="none" lang="en-US">
                 <a:solidFill>
                   <a:srgbClr val="1F2937"/>
                 </a:solidFill>
-                <a:latin typeface="Arial"/>
+                <a:latin typeface="Aptos"/>
+                <a:ea typeface="Aptos"/>
+                <a:cs typeface="Aptos"/>
               </a:rPr>
               <a:t>Beam search → 4 candidate SQL queries, each scored</a:t>
             </a:r>
@@ -8247,7 +7417,7 @@
       </p:sp>
       <p:cxnSp>
         <p:nvCxnSpPr>
-          <p:cNvPr id="91" name="Connector 90"/>
+          <p:cNvPr id="67" name="Connector 66"/>
           <p:cNvCxnSpPr/>
           <p:nvPr/>
         </p:nvCxnSpPr>
@@ -8283,7 +7453,7 @@
       </p:cxnSp>
       <p:sp>
         <p:nvSpPr>
-          <p:cNvPr id="92" name="Rounded Rectangle 91"/>
+          <p:cNvPr id="68" name="Rounded Rectangle 67"/>
           <p:cNvSpPr/>
           <p:nvPr/>
         </p:nvSpPr>
@@ -8331,14 +7501,14 @@
       </p:sp>
       <p:pic>
         <p:nvPicPr>
-          <p:cNvPr id="93" name="Picture 92" descr="play_blue.png"/>
+          <p:cNvPr id="69" name="Picture 68" descr="play_blue.png"/>
           <p:cNvPicPr>
             <a:picLocks noChangeAspect="1"/>
           </p:cNvPicPr>
           <p:nvPr/>
         </p:nvPicPr>
         <p:blipFill>
-          <a:blip r:embed="rId20"/>
+          <a:blip r:embed="rId12"/>
           <a:stretch>
             <a:fillRect/>
           </a:stretch>
@@ -8355,7 +7525,7 @@
       </p:pic>
       <p:sp>
         <p:nvSpPr>
-          <p:cNvPr id="94" name="TextBox 93"/>
+          <p:cNvPr id="70" name="TextBox 69"/>
           <p:cNvSpPr txBox="1"/>
           <p:nvPr/>
         </p:nvSpPr>
@@ -8384,11 +7554,13 @@
               </a:spcAft>
             </a:pPr>
             <a:r>
-              <a:rPr sz="2700" b="1" i="0" u="none">
+              <a:rPr sz="2700" b="1" i="0" u="none" lang="en-US">
                 <a:solidFill>
                   <a:srgbClr val="002060"/>
                 </a:solidFill>
-                <a:latin typeface="Arial"/>
+                <a:latin typeface="Aptos"/>
+                <a:ea typeface="Aptos"/>
+                <a:cs typeface="Aptos"/>
               </a:rPr>
               <a:t>EXECUTE ALL 4</a:t>
             </a:r>
@@ -8403,11 +7575,13 @@
               </a:spcAft>
             </a:pPr>
             <a:r>
-              <a:rPr sz="2400" b="0" i="0" u="none">
+              <a:rPr sz="2400" b="0" i="0" u="none" lang="en-US">
                 <a:solidFill>
                   <a:srgbClr val="1F2937"/>
                 </a:solidFill>
-                <a:latin typeface="Arial"/>
+                <a:latin typeface="Aptos"/>
+                <a:ea typeface="Aptos"/>
+                <a:cs typeface="Aptos"/>
               </a:rPr>
               <a:t>Read-only; keep the first</a:t>
             </a:r>
@@ -8422,11 +7596,13 @@
               </a:spcAft>
             </a:pPr>
             <a:r>
-              <a:rPr sz="2400" b="0" i="0" u="none">
+              <a:rPr sz="2400" b="0" i="0" u="none" lang="en-US">
                 <a:solidFill>
                   <a:srgbClr val="1F2937"/>
                 </a:solidFill>
-                <a:latin typeface="Arial"/>
+                <a:latin typeface="Aptos"/>
+                <a:ea typeface="Aptos"/>
+                <a:cs typeface="Aptos"/>
               </a:rPr>
               <a:t>valid query (paper's rule)</a:t>
             </a:r>
@@ -8435,7 +7611,7 @@
       </p:sp>
       <p:sp>
         <p:nvSpPr>
-          <p:cNvPr id="95" name="Rounded Rectangle 94"/>
+          <p:cNvPr id="71" name="Rounded Rectangle 70"/>
           <p:cNvSpPr/>
           <p:nvPr/>
         </p:nvSpPr>
@@ -8483,14 +7659,14 @@
       </p:sp>
       <p:pic>
         <p:nvPicPr>
-          <p:cNvPr id="96" name="Picture 95" descr="refresh-cw_green.png"/>
+          <p:cNvPr id="72" name="Picture 71" descr="refresh-cw_green.png"/>
           <p:cNvPicPr>
             <a:picLocks noChangeAspect="1"/>
           </p:cNvPicPr>
           <p:nvPr/>
         </p:nvPicPr>
         <p:blipFill>
-          <a:blip r:embed="rId21"/>
+          <a:blip r:embed="rId13"/>
           <a:stretch>
             <a:fillRect/>
           </a:stretch>
@@ -8507,7 +7683,7 @@
       </p:pic>
       <p:sp>
         <p:nvSpPr>
-          <p:cNvPr id="97" name="TextBox 96"/>
+          <p:cNvPr id="73" name="TextBox 72"/>
           <p:cNvSpPr txBox="1"/>
           <p:nvPr/>
         </p:nvSpPr>
@@ -8536,11 +7712,13 @@
               </a:spcAft>
             </a:pPr>
             <a:r>
-              <a:rPr sz="2700" b="1" i="0" u="none">
+              <a:rPr sz="2700" b="1" i="0" u="none" lang="en-US">
                 <a:solidFill>
                   <a:srgbClr val="002060"/>
                 </a:solidFill>
-                <a:latin typeface="Arial"/>
+                <a:latin typeface="Aptos"/>
+                <a:ea typeface="Aptos"/>
+                <a:cs typeface="Aptos"/>
               </a:rPr>
               <a:t>SELF-CORRECTION</a:t>
             </a:r>
@@ -8555,11 +7733,13 @@
               </a:spcAft>
             </a:pPr>
             <a:r>
-              <a:rPr sz="2400" b="0" i="0" u="none">
+              <a:rPr sz="2400" b="0" i="0" u="none" lang="en-US">
                 <a:solidFill>
                   <a:srgbClr val="1F2937"/>
                 </a:solidFill>
-                <a:latin typeface="Arial"/>
+                <a:latin typeface="Aptos"/>
+                <a:ea typeface="Aptos"/>
+                <a:cs typeface="Aptos"/>
               </a:rPr>
               <a:t>Failed query + error →</a:t>
             </a:r>
@@ -8574,11 +7754,13 @@
               </a:spcAft>
             </a:pPr>
             <a:r>
-              <a:rPr sz="2400" b="0" i="0" u="none">
+              <a:rPr sz="2400" b="0" i="0" u="none" lang="en-US">
                 <a:solidFill>
                   <a:srgbClr val="1F2937"/>
                 </a:solidFill>
-                <a:latin typeface="Arial"/>
+                <a:latin typeface="Aptos"/>
+                <a:ea typeface="Aptos"/>
+                <a:cs typeface="Aptos"/>
               </a:rPr>
               <a:t>the model repairs it</a:t>
             </a:r>
@@ -8587,7 +7769,7 @@
       </p:sp>
       <p:cxnSp>
         <p:nvCxnSpPr>
-          <p:cNvPr id="98" name="Connector 97"/>
+          <p:cNvPr id="74" name="Connector 73"/>
           <p:cNvCxnSpPr/>
           <p:nvPr/>
         </p:nvCxnSpPr>
@@ -8623,7 +7805,7 @@
       </p:cxnSp>
       <p:cxnSp>
         <p:nvCxnSpPr>
-          <p:cNvPr id="99" name="Connector 98"/>
+          <p:cNvPr id="75" name="Connector 74"/>
           <p:cNvCxnSpPr/>
           <p:nvPr/>
         </p:nvCxnSpPr>
@@ -8659,7 +7841,7 @@
       </p:cxnSp>
       <p:sp>
         <p:nvSpPr>
-          <p:cNvPr id="100" name="Rounded Rectangle 99"/>
+          <p:cNvPr id="76" name="Rounded Rectangle 75"/>
           <p:cNvSpPr/>
           <p:nvPr/>
         </p:nvSpPr>
@@ -8707,14 +7889,14 @@
       </p:sp>
       <p:pic>
         <p:nvPicPr>
-          <p:cNvPr id="101" name="Picture 100" descr="list-checks_orange.png"/>
+          <p:cNvPr id="77" name="Picture 76" descr="list-checks_orange.png"/>
           <p:cNvPicPr>
             <a:picLocks noChangeAspect="1"/>
           </p:cNvPicPr>
           <p:nvPr/>
         </p:nvPicPr>
         <p:blipFill>
-          <a:blip r:embed="rId22"/>
+          <a:blip r:embed="rId14"/>
           <a:stretch>
             <a:fillRect/>
           </a:stretch>
@@ -8731,7 +7913,7 @@
       </p:pic>
       <p:sp>
         <p:nvSpPr>
-          <p:cNvPr id="102" name="TextBox 101"/>
+          <p:cNvPr id="78" name="TextBox 77"/>
           <p:cNvSpPr txBox="1"/>
           <p:nvPr/>
         </p:nvSpPr>
@@ -8760,11 +7942,13 @@
               </a:spcAft>
             </a:pPr>
             <a:r>
-              <a:rPr sz="2700" b="1" i="0" u="none">
+              <a:rPr sz="2700" b="1" i="0" u="none" lang="en-US">
                 <a:solidFill>
                   <a:srgbClr val="002060"/>
                 </a:solidFill>
-                <a:latin typeface="Arial"/>
+                <a:latin typeface="Aptos"/>
+                <a:ea typeface="Aptos"/>
+                <a:cs typeface="Aptos"/>
               </a:rPr>
               <a:t>EXECUTION AGREEMENT  ·  OUR ENHANCEMENT</a:t>
             </a:r>
@@ -8779,11 +7963,13 @@
               </a:spcAft>
             </a:pPr>
             <a:r>
-              <a:rPr sz="2400" b="0" i="0" u="none">
+              <a:rPr sz="2400" b="0" i="0" u="none" lang="en-US">
                 <a:solidFill>
                   <a:srgbClr val="1F2937"/>
                 </a:solidFill>
-                <a:latin typeface="Arial"/>
+                <a:latin typeface="Aptos"/>
+                <a:ea typeface="Aptos"/>
+                <a:cs typeface="Aptos"/>
               </a:rPr>
               <a:t>How many different queries return the same result (0–4)</a:t>
             </a:r>
@@ -8792,7 +7978,7 @@
       </p:sp>
       <p:cxnSp>
         <p:nvCxnSpPr>
-          <p:cNvPr id="103" name="Connector 102"/>
+          <p:cNvPr id="79" name="Connector 78"/>
           <p:cNvCxnSpPr/>
           <p:nvPr/>
         </p:nvCxnSpPr>
@@ -8828,7 +8014,7 @@
       </p:cxnSp>
       <p:sp>
         <p:nvSpPr>
-          <p:cNvPr id="104" name="Rounded Rectangle 103"/>
+          <p:cNvPr id="80" name="Rounded Rectangle 79"/>
           <p:cNvSpPr/>
           <p:nvPr/>
         </p:nvSpPr>
@@ -8876,14 +8062,14 @@
       </p:sp>
       <p:pic>
         <p:nvPicPr>
-          <p:cNvPr id="105" name="Picture 104" descr="gauge_orange.png"/>
+          <p:cNvPr id="81" name="Picture 80" descr="gauge_orange.png"/>
           <p:cNvPicPr>
             <a:picLocks noChangeAspect="1"/>
           </p:cNvPicPr>
           <p:nvPr/>
         </p:nvPicPr>
         <p:blipFill>
-          <a:blip r:embed="rId23"/>
+          <a:blip r:embed="rId15"/>
           <a:stretch>
             <a:fillRect/>
           </a:stretch>
@@ -8900,7 +8086,7 @@
       </p:pic>
       <p:sp>
         <p:nvSpPr>
-          <p:cNvPr id="106" name="TextBox 105"/>
+          <p:cNvPr id="82" name="TextBox 81"/>
           <p:cNvSpPr txBox="1"/>
           <p:nvPr/>
         </p:nvSpPr>
@@ -8929,11 +8115,13 @@
               </a:spcAft>
             </a:pPr>
             <a:r>
-              <a:rPr sz="2700" b="1" i="0" u="none">
+              <a:rPr sz="2700" b="1" i="0" u="none" lang="en-US">
                 <a:solidFill>
                   <a:srgbClr val="002060"/>
                 </a:solidFill>
-                <a:latin typeface="Arial"/>
+                <a:latin typeface="Aptos"/>
+                <a:ea typeface="Aptos"/>
+                <a:cs typeface="Aptos"/>
               </a:rPr>
               <a:t>CONFIDENT ENOUGH?</a:t>
             </a:r>
@@ -8948,11 +8136,13 @@
               </a:spcAft>
             </a:pPr>
             <a:r>
-              <a:rPr sz="2400" b="0" i="0" u="none">
+              <a:rPr sz="2400" b="0" i="0" u="none" lang="en-US">
                 <a:solidFill>
                   <a:srgbClr val="1F2937"/>
                 </a:solidFill>
-                <a:latin typeface="Arial"/>
+                <a:latin typeface="Aptos"/>
+                <a:ea typeface="Aptos"/>
+                <a:cs typeface="Aptos"/>
               </a:rPr>
               <a:t>Agreement vs a threshold calibrated on Spider (strictness mode)</a:t>
             </a:r>
@@ -8961,7 +8151,7 @@
       </p:sp>
       <p:cxnSp>
         <p:nvCxnSpPr>
-          <p:cNvPr id="107" name="Connector 106"/>
+          <p:cNvPr id="83" name="Connector 82"/>
           <p:cNvCxnSpPr/>
           <p:nvPr/>
         </p:nvCxnSpPr>
@@ -8997,7 +8187,7 @@
       </p:cxnSp>
       <p:sp>
         <p:nvSpPr>
-          <p:cNvPr id="108" name="TextBox 107"/>
+          <p:cNvPr id="84" name="TextBox 83"/>
           <p:cNvSpPr txBox="1"/>
           <p:nvPr/>
         </p:nvSpPr>
@@ -9026,11 +8216,13 @@
               </a:spcAft>
             </a:pPr>
             <a:r>
-              <a:rPr sz="2000" b="1" i="0" u="none">
+              <a:rPr sz="2000" b="1" i="0" u="none" lang="en-US">
                 <a:solidFill>
                   <a:srgbClr val="2E7D32"/>
                 </a:solidFill>
-                <a:latin typeface="Arial"/>
+                <a:latin typeface="Aptos"/>
+                <a:ea typeface="Aptos"/>
+                <a:cs typeface="Aptos"/>
               </a:rPr>
               <a:t>yes</a:t>
             </a:r>
@@ -9039,7 +8231,7 @@
       </p:sp>
       <p:cxnSp>
         <p:nvCxnSpPr>
-          <p:cNvPr id="109" name="Connector 108"/>
+          <p:cNvPr id="85" name="Connector 84"/>
           <p:cNvCxnSpPr/>
           <p:nvPr/>
         </p:nvCxnSpPr>
@@ -9075,7 +8267,7 @@
       </p:cxnSp>
       <p:sp>
         <p:nvSpPr>
-          <p:cNvPr id="110" name="TextBox 109"/>
+          <p:cNvPr id="86" name="TextBox 85"/>
           <p:cNvSpPr txBox="1"/>
           <p:nvPr/>
         </p:nvSpPr>
@@ -9104,11 +8296,13 @@
               </a:spcAft>
             </a:pPr>
             <a:r>
-              <a:rPr sz="2000" b="1" i="0" u="none">
+              <a:rPr sz="2000" b="1" i="0" u="none" lang="en-US">
                 <a:solidFill>
                   <a:srgbClr val="C98A00"/>
                 </a:solidFill>
-                <a:latin typeface="Arial"/>
+                <a:latin typeface="Aptos"/>
+                <a:ea typeface="Aptos"/>
+                <a:cs typeface="Aptos"/>
               </a:rPr>
               <a:t>no → ask</a:t>
             </a:r>
@@ -9117,7 +8311,7 @@
       </p:sp>
       <p:sp>
         <p:nvSpPr>
-          <p:cNvPr id="111" name="Rounded Rectangle 110"/>
+          <p:cNvPr id="87" name="Rounded Rectangle 86"/>
           <p:cNvSpPr/>
           <p:nvPr/>
         </p:nvSpPr>
@@ -9165,14 +8359,14 @@
       </p:sp>
       <p:pic>
         <p:nvPicPr>
-          <p:cNvPr id="112" name="Picture 111" descr="chart-column_green.png"/>
+          <p:cNvPr id="88" name="Picture 87" descr="chart-column_green.png"/>
           <p:cNvPicPr>
             <a:picLocks noChangeAspect="1"/>
           </p:cNvPicPr>
           <p:nvPr/>
         </p:nvPicPr>
         <p:blipFill>
-          <a:blip r:embed="rId24"/>
+          <a:blip r:embed="rId16"/>
           <a:stretch>
             <a:fillRect/>
           </a:stretch>
@@ -9189,7 +8383,7 @@
       </p:pic>
       <p:sp>
         <p:nvSpPr>
-          <p:cNvPr id="113" name="TextBox 112"/>
+          <p:cNvPr id="89" name="TextBox 88"/>
           <p:cNvSpPr txBox="1"/>
           <p:nvPr/>
         </p:nvSpPr>
@@ -9218,11 +8412,13 @@
               </a:spcAft>
             </a:pPr>
             <a:r>
-              <a:rPr sz="2700" b="1" i="0" u="none">
+              <a:rPr sz="2700" b="1" i="0" u="none" lang="en-US">
                 <a:solidFill>
                   <a:srgbClr val="002060"/>
                 </a:solidFill>
-                <a:latin typeface="Arial"/>
+                <a:latin typeface="Aptos"/>
+                <a:ea typeface="Aptos"/>
+                <a:cs typeface="Aptos"/>
               </a:rPr>
               <a:t>ANSWER</a:t>
             </a:r>
@@ -9237,11 +8433,13 @@
               </a:spcAft>
             </a:pPr>
             <a:r>
-              <a:rPr sz="2400" b="0" i="0" u="none">
+              <a:rPr sz="2400" b="0" i="0" u="none" lang="en-US">
                 <a:solidFill>
                   <a:srgbClr val="1F2937"/>
                 </a:solidFill>
-                <a:latin typeface="Arial"/>
+                <a:latin typeface="Aptos"/>
+                <a:ea typeface="Aptos"/>
+                <a:cs typeface="Aptos"/>
               </a:rPr>
               <a:t>Table + automatic chart</a:t>
             </a:r>
@@ -9256,11 +8454,13 @@
               </a:spcAft>
             </a:pPr>
             <a:r>
-              <a:rPr sz="2400" b="0" i="0" u="none">
+              <a:rPr sz="2400" b="0" i="0" u="none" lang="en-US">
                 <a:solidFill>
                   <a:srgbClr val="1F2937"/>
                 </a:solidFill>
-                <a:latin typeface="Arial"/>
+                <a:latin typeface="Aptos"/>
+                <a:ea typeface="Aptos"/>
+                <a:cs typeface="Aptos"/>
               </a:rPr>
               <a:t>SQL + “N of 4 agree”</a:t>
             </a:r>
@@ -9269,7 +8469,7 @@
       </p:sp>
       <p:sp>
         <p:nvSpPr>
-          <p:cNvPr id="114" name="Rounded Rectangle 113"/>
+          <p:cNvPr id="90" name="Rounded Rectangle 89"/>
           <p:cNvSpPr/>
           <p:nvPr/>
         </p:nvSpPr>
@@ -9317,14 +8517,14 @@
       </p:sp>
       <p:pic>
         <p:nvPicPr>
-          <p:cNvPr id="115" name="Picture 114" descr="circle-help_orange.png"/>
+          <p:cNvPr id="91" name="Picture 90" descr="circle-help_orange.png"/>
           <p:cNvPicPr>
             <a:picLocks noChangeAspect="1"/>
           </p:cNvPicPr>
           <p:nvPr/>
         </p:nvPicPr>
         <p:blipFill>
-          <a:blip r:embed="rId25"/>
+          <a:blip r:embed="rId17"/>
           <a:stretch>
             <a:fillRect/>
           </a:stretch>
@@ -9341,7 +8541,7 @@
       </p:pic>
       <p:sp>
         <p:nvSpPr>
-          <p:cNvPr id="116" name="TextBox 115"/>
+          <p:cNvPr id="92" name="TextBox 91"/>
           <p:cNvSpPr txBox="1"/>
           <p:nvPr/>
         </p:nvSpPr>
@@ -9370,11 +8570,13 @@
               </a:spcAft>
             </a:pPr>
             <a:r>
-              <a:rPr sz="2700" b="1" i="0" u="none">
+              <a:rPr sz="2700" b="1" i="0" u="none" lang="en-US">
                 <a:solidFill>
                   <a:srgbClr val="002060"/>
                 </a:solidFill>
-                <a:latin typeface="Arial"/>
+                <a:latin typeface="Aptos"/>
+                <a:ea typeface="Aptos"/>
+                <a:cs typeface="Aptos"/>
               </a:rPr>
               <a:t>“DID YOU MEAN…?”</a:t>
             </a:r>
@@ -9389,11 +8591,13 @@
               </a:spcAft>
             </a:pPr>
             <a:r>
-              <a:rPr sz="2400" b="0" i="0" u="none">
+              <a:rPr sz="2400" b="0" i="0" u="none" lang="en-US">
                 <a:solidFill>
                   <a:srgbClr val="1F2937"/>
                 </a:solidFill>
-                <a:latin typeface="Arial"/>
+                <a:latin typeface="Aptos"/>
+                <a:ea typeface="Aptos"/>
+                <a:cs typeface="Aptos"/>
               </a:rPr>
               <a:t>No guess: shows the different</a:t>
             </a:r>
@@ -9408,11 +8612,13 @@
               </a:spcAft>
             </a:pPr>
             <a:r>
-              <a:rPr sz="2400" b="0" i="0" u="none">
+              <a:rPr sz="2400" b="0" i="0" u="none" lang="en-US">
                 <a:solidFill>
                   <a:srgbClr val="1F2937"/>
                 </a:solidFill>
-                <a:latin typeface="Arial"/>
+                <a:latin typeface="Aptos"/>
+                <a:ea typeface="Aptos"/>
+                <a:cs typeface="Aptos"/>
               </a:rPr>
               <a:t>readings to choose from</a:t>
             </a:r>
@@ -9421,7 +8627,7 @@
       </p:sp>
       <p:sp>
         <p:nvSpPr>
-          <p:cNvPr id="117" name="Rounded Rectangle 116"/>
+          <p:cNvPr id="93" name="Rounded Rectangle 92"/>
           <p:cNvSpPr/>
           <p:nvPr/>
         </p:nvSpPr>
@@ -9469,7 +8675,7 @@
       </p:sp>
       <p:sp>
         <p:nvSpPr>
-          <p:cNvPr id="118" name="TextBox 117"/>
+          <p:cNvPr id="94" name="TextBox 93"/>
           <p:cNvSpPr txBox="1"/>
           <p:nvPr/>
         </p:nvSpPr>
@@ -9498,11 +8704,13 @@
               </a:spcAft>
             </a:pPr>
             <a:r>
-              <a:rPr sz="2100" b="0" i="0" u="none">
+              <a:rPr sz="2100" b="0" i="0" u="none" lang="en-US">
                 <a:solidFill>
                   <a:srgbClr val="1F2937"/>
                 </a:solidFill>
-                <a:latin typeface="Arial"/>
+                <a:latin typeface="Aptos"/>
+                <a:ea typeface="Aptos"/>
+                <a:cs typeface="Aptos"/>
               </a:rPr>
               <a:t>Reproduced from CodeS</a:t>
             </a:r>
@@ -9511,7 +8719,7 @@
       </p:sp>
       <p:sp>
         <p:nvSpPr>
-          <p:cNvPr id="119" name="Rounded Rectangle 118"/>
+          <p:cNvPr id="95" name="Rounded Rectangle 94"/>
           <p:cNvSpPr/>
           <p:nvPr/>
         </p:nvSpPr>
@@ -9559,7 +8767,7 @@
       </p:sp>
       <p:sp>
         <p:nvSpPr>
-          <p:cNvPr id="120" name="TextBox 119"/>
+          <p:cNvPr id="96" name="TextBox 95"/>
           <p:cNvSpPr txBox="1"/>
           <p:nvPr/>
         </p:nvSpPr>
@@ -9588,11 +8796,13 @@
               </a:spcAft>
             </a:pPr>
             <a:r>
-              <a:rPr sz="2100" b="0" i="0" u="none">
+              <a:rPr sz="2100" b="0" i="0" u="none" lang="en-US">
                 <a:solidFill>
                   <a:srgbClr val="1F2937"/>
                 </a:solidFill>
-                <a:latin typeface="Arial"/>
+                <a:latin typeface="Aptos"/>
+                <a:ea typeface="Aptos"/>
+                <a:cs typeface="Aptos"/>
               </a:rPr>
               <a:t>Our enhancement</a:t>
             </a:r>
@@ -9601,7 +8811,7 @@
       </p:sp>
       <p:sp>
         <p:nvSpPr>
-          <p:cNvPr id="121" name="Rounded Rectangle 120"/>
+          <p:cNvPr id="97" name="Rounded Rectangle 96"/>
           <p:cNvSpPr/>
           <p:nvPr/>
         </p:nvSpPr>
@@ -9649,7 +8859,7 @@
       </p:sp>
       <p:sp>
         <p:nvSpPr>
-          <p:cNvPr id="122" name="TextBox 121"/>
+          <p:cNvPr id="98" name="TextBox 97"/>
           <p:cNvSpPr txBox="1"/>
           <p:nvPr/>
         </p:nvSpPr>
@@ -9678,11 +8888,13 @@
               </a:spcAft>
             </a:pPr>
             <a:r>
-              <a:rPr sz="2100" b="0" i="0" u="none">
+              <a:rPr sz="2100" b="0" i="0" u="none" lang="en-US">
                 <a:solidFill>
                   <a:srgbClr val="1F2937"/>
                 </a:solidFill>
-                <a:latin typeface="Arial"/>
+                <a:latin typeface="Aptos"/>
+                <a:ea typeface="Aptos"/>
+                <a:cs typeface="Aptos"/>
               </a:rPr>
               <a:t>Application</a:t>
             </a:r>
@@ -9691,7 +8903,7 @@
       </p:sp>
       <p:sp>
         <p:nvSpPr>
-          <p:cNvPr id="123" name="TextBox 122"/>
+          <p:cNvPr id="99" name="TextBox 98"/>
           <p:cNvSpPr txBox="1"/>
           <p:nvPr/>
         </p:nvSpPr>
@@ -9720,11 +8932,13 @@
               </a:spcAft>
             </a:pPr>
             <a:r>
-              <a:rPr sz="2100" b="1" i="0" u="none">
+              <a:rPr sz="2100" b="1" i="0" u="none" lang="en-US">
                 <a:solidFill>
                   <a:srgbClr val="002060"/>
                 </a:solidFill>
-                <a:latin typeface="Arial"/>
+                <a:latin typeface="Aptos"/>
+                <a:ea typeface="Aptos"/>
+                <a:cs typeface="Aptos"/>
               </a:rPr>
               <a:t>Desktop app (macOS · Windows) · runs locally on open weights</a:t>
             </a:r>
@@ -9733,14 +8947,14 @@
       </p:sp>
       <p:pic>
         <p:nvPicPr>
-          <p:cNvPr id="124" name="Picture 123" descr="chart_reproduction.png"/>
+          <p:cNvPr id="100" name="Picture 99" descr="chart_reproduction.png"/>
           <p:cNvPicPr>
             <a:picLocks noChangeAspect="1"/>
           </p:cNvPicPr>
           <p:nvPr/>
         </p:nvPicPr>
         <p:blipFill>
-          <a:blip r:embed="rId26"/>
+          <a:blip r:embed="rId18"/>
           <a:stretch>
             <a:fillRect/>
           </a:stretch>
@@ -9757,14 +8971,14 @@
       </p:pic>
       <p:pic>
         <p:nvPicPr>
-          <p:cNvPr id="125" name="Picture 124" descr="chart_enhancement.png"/>
+          <p:cNvPr id="101" name="Picture 100" descr="chart_enhancement.png"/>
           <p:cNvPicPr>
             <a:picLocks noChangeAspect="1"/>
           </p:cNvPicPr>
           <p:nvPr/>
         </p:nvPicPr>
         <p:blipFill>
-          <a:blip r:embed="rId27"/>
+          <a:blip r:embed="rId19"/>
           <a:stretch>
             <a:fillRect/>
           </a:stretch>
@@ -9781,14 +8995,14 @@
       </p:pic>
       <p:pic>
         <p:nvPicPr>
-          <p:cNvPr id="126" name="Picture 125" descr="chart_wrong.png"/>
+          <p:cNvPr id="102" name="Picture 101" descr="chart_wrong.png"/>
           <p:cNvPicPr>
             <a:picLocks noChangeAspect="1"/>
           </p:cNvPicPr>
           <p:nvPr/>
         </p:nvPicPr>
         <p:blipFill>
-          <a:blip r:embed="rId28"/>
+          <a:blip r:embed="rId20"/>
           <a:stretch>
             <a:fillRect/>
           </a:stretch>
@@ -9805,14 +9019,14 @@
       </p:pic>
       <p:pic>
         <p:nvPicPr>
-          <p:cNvPr id="127" name="Picture 126" descr="chart_calibration.png"/>
+          <p:cNvPr id="103" name="Picture 102" descr="chart_calibration.png"/>
           <p:cNvPicPr>
             <a:picLocks noChangeAspect="1"/>
           </p:cNvPicPr>
           <p:nvPr/>
         </p:nvPicPr>
         <p:blipFill>
-          <a:blip r:embed="rId29"/>
+          <a:blip r:embed="rId21"/>
           <a:stretch>
             <a:fillRect/>
           </a:stretch>
@@ -9829,7 +9043,7 @@
       </p:pic>
       <p:sp>
         <p:nvSpPr>
-          <p:cNvPr id="128" name="TextBox 127"/>
+          <p:cNvPr id="104" name="TextBox 103"/>
           <p:cNvSpPr txBox="1"/>
           <p:nvPr/>
         </p:nvSpPr>
@@ -9858,20 +9072,24 @@
               </a:spcAft>
             </a:pPr>
             <a:r>
-              <a:rPr sz="2200" b="1" i="0" u="none">
+              <a:rPr sz="2200" b="1" i="0" u="none" lang="en-US">
                 <a:solidFill>
                   <a:srgbClr val="1F2937"/>
                 </a:solidFill>
-                <a:latin typeface="Arial"/>
+                <a:latin typeface="Aptos"/>
+                <a:ea typeface="Aptos"/>
+                <a:cs typeface="Aptos"/>
               </a:rPr>
               <a:t>Significant: </a:t>
             </a:r>
             <a:r>
-              <a:rPr sz="2200" b="0" i="0" u="none">
+              <a:rPr sz="2200" b="0" i="0" u="none" lang="en-US">
                 <a:solidFill>
                   <a:srgbClr val="1F2937"/>
                 </a:solidFill>
-                <a:latin typeface="Arial"/>
+                <a:latin typeface="Aptos"/>
+                <a:ea typeface="Aptos"/>
+                <a:cs typeface="Aptos"/>
               </a:rPr>
               <a:t>paired t-test p = 7.7×10⁻¹⁰, Wilcoxon p = 9.8×10⁻⁴, bootstrap 95% CI +4.5 to +6.7 points.</a:t>
             </a:r>
@@ -9886,20 +9104,24 @@
               </a:spcAft>
             </a:pPr>
             <a:r>
-              <a:rPr sz="2200" b="1" i="0" u="none">
+              <a:rPr sz="2200" b="1" i="0" u="none" lang="en-US">
                 <a:solidFill>
                   <a:srgbClr val="1F2937"/>
                 </a:solidFill>
-                <a:latin typeface="Arial"/>
+                <a:latin typeface="Aptos"/>
+                <a:ea typeface="Aptos"/>
+                <a:cs typeface="Aptos"/>
               </a:rPr>
               <a:t>Robust: </a:t>
             </a:r>
             <a:r>
-              <a:rPr sz="2200" b="0" i="0" u="none">
+              <a:rPr sz="2200" b="0" i="0" u="none" lang="en-US">
                 <a:solidFill>
                   <a:srgbClr val="1F2937"/>
                 </a:solidFill>
-                <a:latin typeface="Arial"/>
+                <a:latin typeface="Aptos"/>
+                <a:ea typeface="Aptos"/>
+                <a:cs typeface="Aptos"/>
               </a:rPr>
               <a:t>counting each different query only once, accuracy at 90% coverage is still 83.5%.</a:t>
             </a:r>
@@ -9908,7 +9130,7 @@
       </p:sp>
       <p:sp>
         <p:nvSpPr>
-          <p:cNvPr id="129" name="Rounded Rectangle 128"/>
+          <p:cNvPr id="105" name="Rounded Rectangle 104"/>
           <p:cNvSpPr/>
           <p:nvPr/>
         </p:nvSpPr>
@@ -9957,7 +9179,7 @@
       </p:sp>
       <p:sp>
         <p:nvSpPr>
-          <p:cNvPr id="130" name="TextBox 129"/>
+          <p:cNvPr id="106" name="TextBox 105"/>
           <p:cNvSpPr txBox="1"/>
           <p:nvPr/>
         </p:nvSpPr>
@@ -9986,20 +9208,24 @@
               </a:spcAft>
             </a:pPr>
             <a:r>
-              <a:rPr sz="2300" b="1" i="0" u="none">
+              <a:rPr sz="2300" b="1" i="0" u="none" lang="en-US">
                 <a:solidFill>
                   <a:srgbClr val="1F2937"/>
                 </a:solidFill>
-                <a:latin typeface="Arial"/>
+                <a:latin typeface="Aptos"/>
+                <a:ea typeface="Aptos"/>
+                <a:cs typeface="Aptos"/>
               </a:rPr>
               <a:t>[1] </a:t>
             </a:r>
             <a:r>
-              <a:rPr sz="2300" b="0" i="0" u="none">
+              <a:rPr sz="2300" b="0" i="0" u="none" lang="en-US">
                 <a:solidFill>
                   <a:srgbClr val="1F2937"/>
                 </a:solidFill>
-                <a:latin typeface="Arial"/>
+                <a:latin typeface="Aptos"/>
+                <a:ea typeface="Aptos"/>
+                <a:cs typeface="Aptos"/>
               </a:rPr>
               <a:t>Li, H., et al. (2024). CodeS: Towards building open-source language models for text-to-SQL. arXiv:2402.16347.</a:t>
             </a:r>
@@ -10014,20 +9240,24 @@
               </a:spcAft>
             </a:pPr>
             <a:r>
-              <a:rPr sz="2300" b="1" i="0" u="none">
+              <a:rPr sz="2300" b="1" i="0" u="none" lang="en-US">
                 <a:solidFill>
                   <a:srgbClr val="1F2937"/>
                 </a:solidFill>
-                <a:latin typeface="Arial"/>
+                <a:latin typeface="Aptos"/>
+                <a:ea typeface="Aptos"/>
+                <a:cs typeface="Aptos"/>
               </a:rPr>
               <a:t>[2] </a:t>
             </a:r>
             <a:r>
-              <a:rPr sz="2300" b="0" i="0" u="none">
+              <a:rPr sz="2300" b="0" i="0" u="none" lang="en-US">
                 <a:solidFill>
                   <a:srgbClr val="1F2937"/>
                 </a:solidFill>
-                <a:latin typeface="Arial"/>
+                <a:latin typeface="Aptos"/>
+                <a:ea typeface="Aptos"/>
+                <a:cs typeface="Aptos"/>
               </a:rPr>
               <a:t>Yu, T., et al. (2018). Spider: A large-scale human-labeled dataset for complex and cross-domain semantic parsing and text-to-SQL task. arXiv:1809.08887.</a:t>
             </a:r>
@@ -10042,20 +9272,24 @@
               </a:spcAft>
             </a:pPr>
             <a:r>
-              <a:rPr sz="2300" b="1" i="0" u="none">
+              <a:rPr sz="2300" b="1" i="0" u="none" lang="en-US">
                 <a:solidFill>
                   <a:srgbClr val="1F2937"/>
                 </a:solidFill>
-                <a:latin typeface="Arial"/>
+                <a:latin typeface="Aptos"/>
+                <a:ea typeface="Aptos"/>
+                <a:cs typeface="Aptos"/>
               </a:rPr>
               <a:t>[3] </a:t>
             </a:r>
             <a:r>
-              <a:rPr sz="2300" b="0" i="0" u="none">
+              <a:rPr sz="2300" b="0" i="0" u="none" lang="en-US">
                 <a:solidFill>
                   <a:srgbClr val="1F2937"/>
                 </a:solidFill>
-                <a:latin typeface="Arial"/>
+                <a:latin typeface="Aptos"/>
+                <a:ea typeface="Aptos"/>
+                <a:cs typeface="Aptos"/>
               </a:rPr>
               <a:t>Deng, X., et al. (2020). Structure-grounded pretraining for text-to-SQL. arXiv:2010.12773.</a:t>
             </a:r>
@@ -10070,20 +9304,24 @@
               </a:spcAft>
             </a:pPr>
             <a:r>
-              <a:rPr sz="2300" b="1" i="0" u="none">
+              <a:rPr sz="2300" b="1" i="0" u="none" lang="en-US">
                 <a:solidFill>
                   <a:srgbClr val="1F2937"/>
                 </a:solidFill>
-                <a:latin typeface="Arial"/>
+                <a:latin typeface="Aptos"/>
+                <a:ea typeface="Aptos"/>
+                <a:cs typeface="Aptos"/>
               </a:rPr>
               <a:t>[4] </a:t>
             </a:r>
             <a:r>
-              <a:rPr sz="2300" b="0" i="0" u="none">
+              <a:rPr sz="2300" b="0" i="0" u="none" lang="en-US">
                 <a:solidFill>
                   <a:srgbClr val="1F2937"/>
                 </a:solidFill>
-                <a:latin typeface="Arial"/>
+                <a:latin typeface="Aptos"/>
+                <a:ea typeface="Aptos"/>
+                <a:cs typeface="Aptos"/>
               </a:rPr>
               <a:t>Li, J., et al. (2023). Can LLM already serve as a database interface? A big bench for large-scale database grounded text-to-SQLs. arXiv:2305.03111.</a:t>
             </a:r>
@@ -10098,20 +9336,24 @@
               </a:spcAft>
             </a:pPr>
             <a:r>
-              <a:rPr sz="2300" b="1" i="0" u="none">
+              <a:rPr sz="2300" b="1" i="0" u="none" lang="en-US">
                 <a:solidFill>
                   <a:srgbClr val="1F2937"/>
                 </a:solidFill>
-                <a:latin typeface="Arial"/>
+                <a:latin typeface="Aptos"/>
+                <a:ea typeface="Aptos"/>
+                <a:cs typeface="Aptos"/>
               </a:rPr>
               <a:t>[5] </a:t>
             </a:r>
             <a:r>
-              <a:rPr sz="2300" b="0" i="0" u="none">
+              <a:rPr sz="2300" b="0" i="0" u="none" lang="en-US">
                 <a:solidFill>
                   <a:srgbClr val="1F2937"/>
                 </a:solidFill>
-                <a:latin typeface="Arial"/>
+                <a:latin typeface="Aptos"/>
+                <a:ea typeface="Aptos"/>
+                <a:cs typeface="Aptos"/>
               </a:rPr>
               <a:t>Pourreza, M., &amp; Rafiei, D. (2023). DIN-SQL: Decomposed in-context learning of text-to-SQL with self-correction. arXiv:2304.11015.</a:t>
             </a:r>
@@ -10126,20 +9368,24 @@
               </a:spcAft>
             </a:pPr>
             <a:r>
-              <a:rPr sz="2300" b="1" i="0" u="none">
+              <a:rPr sz="2300" b="1" i="0" u="none" lang="en-US">
                 <a:solidFill>
                   <a:srgbClr val="1F2937"/>
                 </a:solidFill>
-                <a:latin typeface="Arial"/>
+                <a:latin typeface="Aptos"/>
+                <a:ea typeface="Aptos"/>
+                <a:cs typeface="Aptos"/>
               </a:rPr>
               <a:t>[6] </a:t>
             </a:r>
             <a:r>
-              <a:rPr sz="2300" b="0" i="0" u="none">
+              <a:rPr sz="2300" b="0" i="0" u="none" lang="en-US">
                 <a:solidFill>
                   <a:srgbClr val="1F2937"/>
                 </a:solidFill>
-                <a:latin typeface="Arial"/>
+                <a:latin typeface="Aptos"/>
+                <a:ea typeface="Aptos"/>
+                <a:cs typeface="Aptos"/>
               </a:rPr>
               <a:t>Wang, X., et al. (2022). Self-consistency improves chain of thought reasoning in language models. arXiv:2203.11171.</a:t>
             </a:r>
@@ -10154,20 +9400,24 @@
               </a:spcAft>
             </a:pPr>
             <a:r>
-              <a:rPr sz="2300" b="1" i="0" u="none">
+              <a:rPr sz="2300" b="1" i="0" u="none" lang="en-US">
                 <a:solidFill>
                   <a:srgbClr val="1F2937"/>
                 </a:solidFill>
-                <a:latin typeface="Arial"/>
+                <a:latin typeface="Aptos"/>
+                <a:ea typeface="Aptos"/>
+                <a:cs typeface="Aptos"/>
               </a:rPr>
               <a:t>[7] </a:t>
             </a:r>
             <a:r>
-              <a:rPr sz="2300" b="0" i="0" u="none">
+              <a:rPr sz="2300" b="0" i="0" u="none" lang="en-US">
                 <a:solidFill>
                   <a:srgbClr val="1F2937"/>
                 </a:solidFill>
-                <a:latin typeface="Arial"/>
+                <a:latin typeface="Aptos"/>
+                <a:ea typeface="Aptos"/>
+                <a:cs typeface="Aptos"/>
               </a:rPr>
               <a:t>Geifman, Y., &amp; El-Yaniv, R. (2017). Selective classification for deep neural networks. arXiv:1705.08500.</a:t>
             </a:r>
@@ -10182,20 +9432,24 @@
               </a:spcAft>
             </a:pPr>
             <a:r>
-              <a:rPr sz="2300" b="1" i="0" u="none">
+              <a:rPr sz="2300" b="1" i="0" u="none" lang="en-US">
                 <a:solidFill>
                   <a:srgbClr val="1F2937"/>
                 </a:solidFill>
-                <a:latin typeface="Arial"/>
+                <a:latin typeface="Aptos"/>
+                <a:ea typeface="Aptos"/>
+                <a:cs typeface="Aptos"/>
               </a:rPr>
               <a:t>[8] </a:t>
             </a:r>
             <a:r>
-              <a:rPr sz="2300" b="0" i="0" u="none">
+              <a:rPr sz="2300" b="0" i="0" u="none" lang="en-US">
                 <a:solidFill>
                   <a:srgbClr val="1F2937"/>
                 </a:solidFill>
-                <a:latin typeface="Arial"/>
+                <a:latin typeface="Aptos"/>
+                <a:ea typeface="Aptos"/>
+                <a:cs typeface="Aptos"/>
               </a:rPr>
               <a:t>Zhong, R., Yu, T., &amp; Klein, D. (2020). Semantic evaluation for text-to-SQL with distilled test suites. arXiv:2010.02840.</a:t>
             </a:r>
@@ -10204,7 +9458,7 @@
       </p:sp>
       <p:sp>
         <p:nvSpPr>
-          <p:cNvPr id="131" name="Rounded Rectangle 130"/>
+          <p:cNvPr id="107" name="Rounded Rectangle 106"/>
           <p:cNvSpPr/>
           <p:nvPr/>
         </p:nvSpPr>
@@ -10253,7 +9507,7 @@
       </p:sp>
       <p:sp>
         <p:nvSpPr>
-          <p:cNvPr id="132" name="TextBox 131"/>
+          <p:cNvPr id="108" name="TextBox 107"/>
           <p:cNvSpPr txBox="1"/>
           <p:nvPr/>
         </p:nvSpPr>
@@ -10278,17 +9532,30 @@
                 <a:spcPts val="0"/>
               </a:spcBef>
               <a:spcAft>
-                <a:spcPts val="125"/>
+                <a:spcPts val="144"/>
               </a:spcAft>
             </a:pPr>
             <a:r>
-              <a:rPr sz="2700" b="1" i="0" u="none">
+              <a:rPr sz="2400" b="1" i="0" u="none" lang="en-US">
                 <a:solidFill>
                   <a:srgbClr val="002060"/>
                 </a:solidFill>
-                <a:latin typeface="Arial"/>
+                <a:latin typeface="Aptos"/>
+                <a:ea typeface="Aptos"/>
+                <a:cs typeface="Aptos"/>
               </a:rPr>
-              <a:t>Supervisor</a:t>
+              <a:t>❖ Project Guide: </a:t>
+            </a:r>
+            <a:r>
+              <a:rPr sz="2400" b="0" i="0" u="none" lang="en-US">
+                <a:solidFill>
+                  <a:srgbClr val="1F2937"/>
+                </a:solidFill>
+                <a:latin typeface="Aptos"/>
+                <a:ea typeface="Aptos"/>
+                <a:cs typeface="Aptos"/>
+              </a:rPr>
+              <a:t>M Parameswar, Associate Professor</a:t>
             </a:r>
           </a:p>
           <a:p>
@@ -10297,17 +9564,30 @@
                 <a:spcPts val="0"/>
               </a:spcBef>
               <a:spcAft>
-                <a:spcPts val="125"/>
+                <a:spcPts val="144"/>
               </a:spcAft>
             </a:pPr>
             <a:r>
-              <a:rPr sz="2500" b="0" i="0" u="none">
+              <a:rPr sz="2400" b="1" i="0" u="none" lang="en-US">
+                <a:solidFill>
+                  <a:srgbClr val="002060"/>
+                </a:solidFill>
+                <a:latin typeface="Aptos"/>
+                <a:ea typeface="Aptos"/>
+                <a:cs typeface="Aptos"/>
+              </a:rPr>
+              <a:t>❖ Project Coordinator: </a:t>
+            </a:r>
+            <a:r>
+              <a:rPr sz="2400" b="0" i="0" u="none" lang="en-US">
                 <a:solidFill>
                   <a:srgbClr val="1F2937"/>
                 </a:solidFill>
-                <a:latin typeface="Arial"/>
+                <a:latin typeface="Aptos"/>
+                <a:ea typeface="Aptos"/>
+                <a:cs typeface="Aptos"/>
               </a:rPr>
-              <a:t>M Parameswar</a:t>
+              <a:t>Dr. Jagan Mohan Reddy Danda, Associate Professor</a:t>
             </a:r>
           </a:p>
           <a:p>
@@ -10316,17 +9596,19 @@
                 <a:spcPts val="0"/>
               </a:spcBef>
               <a:spcAft>
-                <a:spcPts val="125"/>
+                <a:spcPts val="144"/>
               </a:spcAft>
             </a:pPr>
             <a:r>
-              <a:rPr sz="2200" b="0" i="0" u="none">
-                <a:solidFill>
-                  <a:srgbClr val="4B5563"/>
-                </a:solidFill>
-                <a:latin typeface="Arial"/>
+              <a:rPr sz="2400" b="1" i="0" u="none" lang="en-US">
+                <a:solidFill>
+                  <a:srgbClr val="002060"/>
+                </a:solidFill>
+                <a:latin typeface="Aptos"/>
+                <a:ea typeface="Aptos"/>
+                <a:cs typeface="Aptos"/>
               </a:rPr>
-              <a:t>Associate Professor</a:t>
+              <a:t>❖ Students (Team 18):</a:t>
             </a:r>
           </a:p>
           <a:p>
@@ -10335,17 +9617,19 @@
                 <a:spcPts val="0"/>
               </a:spcBef>
               <a:spcAft>
-                <a:spcPts val="125"/>
+                <a:spcPts val="144"/>
               </a:spcAft>
             </a:pPr>
             <a:r>
-              <a:rPr sz="2700" b="1" i="0" u="none">
-                <a:solidFill>
-                  <a:srgbClr val="002060"/>
-                </a:solidFill>
-                <a:latin typeface="Arial"/>
+              <a:rPr sz="2300" b="0" i="0" u="none" lang="en-US">
+                <a:solidFill>
+                  <a:srgbClr val="1F2937"/>
+                </a:solidFill>
+                <a:latin typeface="Aptos"/>
+                <a:ea typeface="Aptos"/>
+                <a:cs typeface="Aptos"/>
               </a:rPr>
-              <a:t>Team 18</a:t>
+              <a:t>N V V S S Jayakanth Kamisetti</a:t>
             </a:r>
           </a:p>
           <a:p>
@@ -10354,15 +9638,17 @@
                 <a:spcPts val="0"/>
               </a:spcBef>
               <a:spcAft>
-                <a:spcPts val="125"/>
+                <a:spcPts val="144"/>
               </a:spcAft>
             </a:pPr>
             <a:r>
-              <a:rPr sz="2100" b="1" i="0" u="none">
+              <a:rPr sz="2000" b="0" i="0" u="none" lang="en-US">
                 <a:solidFill>
                   <a:srgbClr val="4B5563"/>
                 </a:solidFill>
-                <a:latin typeface="Arial"/>
+                <a:latin typeface="Aptos"/>
+                <a:ea typeface="Aptos"/>
+                <a:cs typeface="Aptos"/>
               </a:rPr>
               <a:t>2320090050</a:t>
             </a:r>
@@ -10373,17 +9659,19 @@
                 <a:spcPts val="0"/>
               </a:spcBef>
               <a:spcAft>
-                <a:spcPts val="125"/>
+                <a:spcPts val="144"/>
               </a:spcAft>
             </a:pPr>
             <a:r>
-              <a:rPr sz="2200" b="0" i="0" u="none">
+              <a:rPr sz="2300" b="0" i="0" u="none" lang="en-US">
                 <a:solidFill>
                   <a:srgbClr val="1F2937"/>
                 </a:solidFill>
-                <a:latin typeface="Arial"/>
+                <a:latin typeface="Aptos"/>
+                <a:ea typeface="Aptos"/>
+                <a:cs typeface="Aptos"/>
               </a:rPr>
-              <a:t>N V V S S Jayakanth Kamisetti</a:t>
+              <a:t>Boddupally Narendar</a:t>
             </a:r>
           </a:p>
           <a:p>
@@ -10392,15 +9680,17 @@
                 <a:spcPts val="0"/>
               </a:spcBef>
               <a:spcAft>
-                <a:spcPts val="125"/>
+                <a:spcPts val="144"/>
               </a:spcAft>
             </a:pPr>
             <a:r>
-              <a:rPr sz="2100" b="1" i="0" u="none">
+              <a:rPr sz="2000" b="0" i="0" u="none" lang="en-US">
                 <a:solidFill>
                   <a:srgbClr val="4B5563"/>
                 </a:solidFill>
-                <a:latin typeface="Arial"/>
+                <a:latin typeface="Aptos"/>
+                <a:ea typeface="Aptos"/>
+                <a:cs typeface="Aptos"/>
               </a:rPr>
               <a:t>2320090009</a:t>
             </a:r>
@@ -10411,17 +9701,19 @@
                 <a:spcPts val="0"/>
               </a:spcBef>
               <a:spcAft>
-                <a:spcPts val="125"/>
+                <a:spcPts val="144"/>
               </a:spcAft>
             </a:pPr>
             <a:r>
-              <a:rPr sz="2200" b="0" i="0" u="none">
+              <a:rPr sz="2300" b="0" i="0" u="none" lang="en-US">
                 <a:solidFill>
                   <a:srgbClr val="1F2937"/>
                 </a:solidFill>
-                <a:latin typeface="Arial"/>
+                <a:latin typeface="Aptos"/>
+                <a:ea typeface="Aptos"/>
+                <a:cs typeface="Aptos"/>
               </a:rPr>
-              <a:t>Boddupally Narendar</a:t>
+              <a:t>M Praneeth Reddy</a:t>
             </a:r>
           </a:p>
           <a:p>
@@ -10430,43 +9722,26 @@
                 <a:spcPts val="0"/>
               </a:spcBef>
               <a:spcAft>
-                <a:spcPts val="125"/>
+                <a:spcPts val="144"/>
               </a:spcAft>
             </a:pPr>
             <a:r>
-              <a:rPr sz="2100" b="1" i="0" u="none">
+              <a:rPr sz="2000" b="0" i="0" u="none" lang="en-US">
                 <a:solidFill>
                   <a:srgbClr val="4B5563"/>
                 </a:solidFill>
-                <a:latin typeface="Arial"/>
+                <a:latin typeface="Aptos"/>
+                <a:ea typeface="Aptos"/>
+                <a:cs typeface="Aptos"/>
               </a:rPr>
               <a:t>2320090018</a:t>
             </a:r>
           </a:p>
-          <a:p>
-            <a:pPr algn="l">
-              <a:spcBef>
-                <a:spcPts val="0"/>
-              </a:spcBef>
-              <a:spcAft>
-                <a:spcPts val="125"/>
-              </a:spcAft>
-            </a:pPr>
-            <a:r>
-              <a:rPr sz="2200" b="0" i="0" u="none">
-                <a:solidFill>
-                  <a:srgbClr val="1F2937"/>
-                </a:solidFill>
-                <a:latin typeface="Arial"/>
-              </a:rPr>
-              <a:t>M Praneeth Reddy</a:t>
-            </a:r>
-          </a:p>
-        </p:txBody>
-      </p:sp>
-      <p:sp>
-        <p:nvSpPr>
-          <p:cNvPr id="133" name="Rectangle 132"/>
+        </p:txBody>
+      </p:sp>
+      <p:sp>
+        <p:nvSpPr>
+          <p:cNvPr id="109" name="Rectangle 108"/>
           <p:cNvSpPr/>
           <p:nvPr/>
         </p:nvSpPr>
@@ -10513,11 +9788,13 @@
               </a:spcAft>
             </a:pPr>
             <a:r>
-              <a:rPr sz="3800" b="1" i="0" u="none">
+              <a:rPr sz="3800" b="1" i="0" u="sng" lang="en-US">
                 <a:solidFill>
                   <a:srgbClr val="FFFFFF"/>
                 </a:solidFill>
-                <a:latin typeface="Arial"/>
+                <a:latin typeface="Aptos"/>
+                <a:ea typeface="Aptos"/>
+                <a:cs typeface="Aptos"/>
               </a:rPr>
               <a:t>Future Work</a:t>
             </a:r>
@@ -10526,7 +9803,7 @@
       </p:sp>
       <p:sp>
         <p:nvSpPr>
-          <p:cNvPr id="134" name="TextBox 133"/>
+          <p:cNvPr id="110" name="TextBox 109"/>
           <p:cNvSpPr txBox="1"/>
           <p:nvPr/>
         </p:nvSpPr>
@@ -10555,11 +9832,13 @@
               </a:spcAft>
             </a:pPr>
             <a:r>
-              <a:rPr sz="2400" b="0" i="0" u="none">
+              <a:rPr sz="2400" b="0" i="0" u="none" lang="en-US">
                 <a:solidFill>
                   <a:srgbClr val="1F2937"/>
                 </a:solidFill>
-                <a:latin typeface="Arial"/>
+                <a:latin typeface="Aptos"/>
+                <a:ea typeface="Aptos"/>
+                <a:cs typeface="Aptos"/>
               </a:rPr>
               <a:t>• CodeS-3B and more, more diverse candidate queries</a:t>
             </a:r>
@@ -10574,11 +9853,13 @@
               </a:spcAft>
             </a:pPr>
             <a:r>
-              <a:rPr sz="2400" b="0" i="0" u="none">
+              <a:rPr sz="2400" b="0" i="0" u="none" lang="en-US">
                 <a:solidFill>
                   <a:srgbClr val="1F2937"/>
                 </a:solidFill>
-                <a:latin typeface="Arial"/>
+                <a:latin typeface="Aptos"/>
+                <a:ea typeface="Aptos"/>
+                <a:cs typeface="Aptos"/>
               </a:rPr>
               <a:t>• Real-world databases (BIRD)</a:t>
             </a:r>
@@ -10593,11 +9874,13 @@
               </a:spcAft>
             </a:pPr>
             <a:r>
-              <a:rPr sz="2400" b="0" i="0" u="none">
+              <a:rPr sz="2400" b="0" i="0" u="none" lang="en-US">
                 <a:solidFill>
                   <a:srgbClr val="1F2937"/>
                 </a:solidFill>
-                <a:latin typeface="Arial"/>
+                <a:latin typeface="Aptos"/>
+                <a:ea typeface="Aptos"/>
+                <a:cs typeface="Aptos"/>
               </a:rPr>
               <a:t>• A platform for any database (Spark, Snowflake, NoSQL) with access control</a:t>
             </a:r>

</xml_diff>

<commit_message>
Poster: no fixed number of candidate queries (evaluator: don't limit it to 4)
Diagram says 'several candidate queries' / 'execute all candidates'; the calibration chart's axis is
the share of candidates that agree (25-100%), which is what was measured.

Co-Authored-By: Claude Sonnet 5.5 <noreply@anthropic.com>
</commit_message>
<xml_diff>
--- a/docs/Review-III/QueryGenie_Poster.pptx
+++ b/docs/Review-III/QueryGenie_Poster.pptx
@@ -7410,7 +7410,7 @@
                 <a:ea typeface="Aptos"/>
                 <a:cs typeface="Aptos"/>
               </a:rPr>
-              <a:t>Beam search → 4 candidate SQL queries, each scored</a:t>
+              <a:t>Beam search → several candidate SQL queries, each scored</a:t>
             </a:r>
           </a:p>
         </p:txBody>
@@ -7562,7 +7562,7 @@
                 <a:ea typeface="Aptos"/>
                 <a:cs typeface="Aptos"/>
               </a:rPr>
-              <a:t>EXECUTE ALL 4</a:t>
+              <a:t>EXECUTE ALL CANDIDATES</a:t>
             </a:r>
           </a:p>
           <a:p>
@@ -7971,7 +7971,7 @@
                 <a:ea typeface="Aptos"/>
                 <a:cs typeface="Aptos"/>
               </a:rPr>
-              <a:t>How many different queries return the same result (0–4)</a:t>
+              <a:t>Share of the different queries that return the same result</a:t>
             </a:r>
           </a:p>
         </p:txBody>
@@ -8462,7 +8462,7 @@
                 <a:ea typeface="Aptos"/>
                 <a:cs typeface="Aptos"/>
               </a:rPr>
-              <a:t>SQL + “N of 4 agree”</a:t>
+              <a:t>SQL + how many queries agree</a:t>
             </a:r>
           </a:p>
         </p:txBody>

</xml_diff>